<commit_message>
Show the thumb in the thumb-up diagrams and enlarge them
Co-Authored-By: Claude Opus 5.5 <noreply@anthropic.com>
</commit_message>
<xml_diff>
--- a/docs/progress/slides/2026-10-08.pptx
+++ b/docs/progress/slides/2026-10-08.pptx
@@ -10298,8 +10298,8 @@
         </p:nvSpPr>
         <p:spPr>
           <a:xfrm>
-            <a:off x="1100138" y="1743075"/>
-            <a:ext cx="1476375" cy="649605"/>
+            <a:off x="766762" y="1743075"/>
+            <a:ext cx="2143125" cy="942975"/>
           </a:xfrm>
           <a:prstGeom prst="rect">
             <a:avLst/>
@@ -10342,8 +10342,8 @@
         </p:nvSpPr>
         <p:spPr>
           <a:xfrm>
-            <a:off x="1123760" y="2292286"/>
-            <a:ext cx="1181100" cy="100394"/>
+            <a:off x="801052" y="2540318"/>
+            <a:ext cx="1714500" cy="145732"/>
           </a:xfrm>
           <a:prstGeom prst="rect">
             <a:avLst/>
@@ -10389,12 +10389,12 @@
         </p:nvSpPr>
         <p:spPr>
           <a:xfrm>
-            <a:off x="1159192" y="2023586"/>
-            <a:ext cx="832676" cy="147638"/>
+            <a:off x="852488" y="2150269"/>
+            <a:ext cx="1071562" cy="214312"/>
           </a:xfrm>
           <a:prstGeom prst="roundRect">
             <a:avLst>
-              <a:gd name="adj" fmla="val 38709"/>
+              <a:gd name="adj" fmla="val 26666"/>
             </a:avLst>
           </a:prstGeom>
           <a:solidFill>
@@ -10437,12 +10437,12 @@
         </p:nvSpPr>
         <p:spPr>
           <a:xfrm>
-            <a:off x="1974152" y="2008822"/>
-            <a:ext cx="212598" cy="177165"/>
+            <a:off x="1889760" y="2055971"/>
+            <a:ext cx="445770" cy="402908"/>
           </a:xfrm>
           <a:prstGeom prst="roundRect">
             <a:avLst>
-              <a:gd name="adj" fmla="val 37634"/>
+              <a:gd name="adj" fmla="val 16548"/>
             </a:avLst>
           </a:prstGeom>
           <a:solidFill>
@@ -10484,9 +10484,330 @@
           <p:nvPr/>
         </p:nvCxnSpPr>
         <p:spPr>
+          <a:xfrm>
+            <a:off x="2198370" y="2090261"/>
+            <a:ext cx="0" cy="120015"/>
+          </a:xfrm>
+          <a:prstGeom prst="line">
+            <a:avLst/>
+          </a:prstGeom>
+          <a:ln w="7143">
+            <a:solidFill>
+              <a:srgbClr val="8A7A6C"/>
+            </a:solidFill>
+          </a:ln>
+        </p:spPr>
+      </p:cxnSp>
+      <p:cxnSp>
+        <p:nvCxnSpPr>
+          <p:cNvPr id="12" name="Connector 11"/>
+          <p:cNvCxnSpPr/>
+          <p:nvPr/>
+        </p:nvCxnSpPr>
+        <p:spPr>
+          <a:xfrm>
+            <a:off x="2245519" y="2090261"/>
+            <a:ext cx="0" cy="120015"/>
+          </a:xfrm>
+          <a:prstGeom prst="line">
+            <a:avLst/>
+          </a:prstGeom>
+          <a:ln w="7143">
+            <a:solidFill>
+              <a:srgbClr val="8A7A6C"/>
+            </a:solidFill>
+          </a:ln>
+        </p:spPr>
+      </p:cxnSp>
+      <p:cxnSp>
+        <p:nvCxnSpPr>
+          <p:cNvPr id="13" name="Connector 12"/>
+          <p:cNvCxnSpPr/>
+          <p:nvPr/>
+        </p:nvCxnSpPr>
+        <p:spPr>
+          <a:xfrm>
+            <a:off x="2292668" y="2090261"/>
+            <a:ext cx="0" cy="120015"/>
+          </a:xfrm>
+          <a:prstGeom prst="line">
+            <a:avLst/>
+          </a:prstGeom>
+          <a:ln w="7143">
+            <a:solidFill>
+              <a:srgbClr val="8A7A6C"/>
+            </a:solidFill>
+          </a:ln>
+        </p:spPr>
+      </p:cxnSp>
+      <p:sp>
+        <p:nvSpPr>
+          <p:cNvPr id="14" name="Rounded Rectangle 13"/>
+          <p:cNvSpPr/>
+          <p:nvPr/>
+        </p:nvSpPr>
+        <p:spPr>
+          <a:xfrm>
+            <a:off x="1924050" y="2235994"/>
+            <a:ext cx="334328" cy="120015"/>
+          </a:xfrm>
+          <a:prstGeom prst="roundRect">
+            <a:avLst>
+              <a:gd name="adj" fmla="val 50000"/>
+            </a:avLst>
+          </a:prstGeom>
+          <a:solidFill>
+            <a:srgbClr val="E2C8B0"/>
+          </a:solidFill>
+          <a:ln w="9525">
+            <a:solidFill>
+              <a:srgbClr val="8A7A6C"/>
+            </a:solidFill>
+          </a:ln>
+          <a:effectLst/>
+        </p:spPr>
+        <p:style>
+          <a:lnRef idx="1">
+            <a:schemeClr val="accent1"/>
+          </a:lnRef>
+          <a:fillRef idx="3">
+            <a:schemeClr val="accent1"/>
+          </a:fillRef>
+          <a:effectRef idx="2">
+            <a:schemeClr val="accent1"/>
+          </a:effectRef>
+          <a:fontRef idx="minor">
+            <a:schemeClr val="lt1"/>
+          </a:fontRef>
+        </p:style>
+        <p:txBody>
+          <a:bodyPr rtlCol="0" anchor="ctr"/>
+          <a:lstStyle/>
+          <a:p>
+            <a:pPr algn="ctr"/>
+          </a:p>
+        </p:txBody>
+      </p:sp>
+      <p:sp>
+        <p:nvSpPr>
+          <p:cNvPr id="15" name="Rounded Rectangle 14"/>
+          <p:cNvSpPr/>
+          <p:nvPr/>
+        </p:nvSpPr>
+        <p:spPr>
+          <a:xfrm>
+            <a:off x="2164080" y="2257425"/>
+            <a:ext cx="68580" cy="77152"/>
+          </a:xfrm>
+          <a:prstGeom prst="roundRect">
+            <a:avLst>
+              <a:gd name="adj" fmla="val 27777"/>
+            </a:avLst>
+          </a:prstGeom>
+          <a:solidFill>
+            <a:srgbClr val="FFF7EF"/>
+          </a:solidFill>
+          <a:ln w="4762">
+            <a:solidFill>
+              <a:srgbClr val="8A7A6C"/>
+            </a:solidFill>
+          </a:ln>
+          <a:effectLst/>
+        </p:spPr>
+        <p:style>
+          <a:lnRef idx="1">
+            <a:schemeClr val="accent1"/>
+          </a:lnRef>
+          <a:fillRef idx="3">
+            <a:schemeClr val="accent1"/>
+          </a:fillRef>
+          <a:effectRef idx="2">
+            <a:schemeClr val="accent1"/>
+          </a:effectRef>
+          <a:fontRef idx="minor">
+            <a:schemeClr val="lt1"/>
+          </a:fontRef>
+        </p:style>
+        <p:txBody>
+          <a:bodyPr rtlCol="0" anchor="ctr"/>
+          <a:lstStyle/>
+          <a:p>
+            <a:pPr algn="ctr"/>
+          </a:p>
+        </p:txBody>
+      </p:sp>
+      <p:sp>
+        <p:nvSpPr>
+          <p:cNvPr id="16" name="TextBox 15"/>
+          <p:cNvSpPr txBox="1"/>
+          <p:nvPr/>
+        </p:nvSpPr>
+        <p:spPr>
+          <a:xfrm>
+            <a:off x="1581150" y="2381726"/>
+            <a:ext cx="282892" cy="128588"/>
+          </a:xfrm>
+          <a:prstGeom prst="rect">
+            <a:avLst/>
+          </a:prstGeom>
+          <a:noFill/>
+        </p:spPr>
+        <p:txBody>
+          <a:bodyPr wrap="square" tIns="0" rIns="0" bIns="0" lIns="0">
+            <a:spAutoFit/>
+          </a:bodyPr>
+          <a:lstStyle/>
+          <a:p>
+            <a:pPr algn="r">
+              <a:lnSpc>
+                <a:spcPct val="120000"/>
+              </a:lnSpc>
+              <a:spcBef>
+                <a:spcPts val="0"/>
+              </a:spcBef>
+              <a:spcAft>
+                <a:spcPts val="0"/>
+              </a:spcAft>
+            </a:pPr>
+            <a:r>
+              <a:rPr sz="712" b="1">
+                <a:solidFill>
+                  <a:srgbClr val="8A7A6C"/>
+                </a:solidFill>
+                <a:latin typeface="Meiryo"/>
+                <a:ea typeface="Meiryo"/>
+                <a:cs typeface="Meiryo"/>
+              </a:rPr>
+              <a:t>親指</a:t>
+            </a:r>
+          </a:p>
+        </p:txBody>
+      </p:sp>
+      <p:cxnSp>
+        <p:nvCxnSpPr>
+          <p:cNvPr id="17" name="Connector 16"/>
+          <p:cNvCxnSpPr/>
+          <p:nvPr/>
+        </p:nvCxnSpPr>
+        <p:spPr>
           <a:xfrm flipV="1">
-            <a:off x="2263521" y="1846421"/>
-            <a:ext cx="0" cy="236220"/>
+            <a:off x="1872615" y="2296001"/>
+            <a:ext cx="111443" cy="137160"/>
+          </a:xfrm>
+          <a:prstGeom prst="line">
+            <a:avLst/>
+          </a:prstGeom>
+          <a:ln w="7143">
+            <a:solidFill>
+              <a:srgbClr val="8A7A6C"/>
+            </a:solidFill>
+          </a:ln>
+        </p:spPr>
+      </p:cxnSp>
+      <p:sp>
+        <p:nvSpPr>
+          <p:cNvPr id="18" name="TextBox 17"/>
+          <p:cNvSpPr txBox="1"/>
+          <p:nvPr/>
+        </p:nvSpPr>
+        <p:spPr>
+          <a:xfrm>
+            <a:off x="869632" y="2004536"/>
+            <a:ext cx="771525" cy="128588"/>
+          </a:xfrm>
+          <a:prstGeom prst="rect">
+            <a:avLst/>
+          </a:prstGeom>
+          <a:noFill/>
+        </p:spPr>
+        <p:txBody>
+          <a:bodyPr wrap="square" tIns="0" rIns="0" bIns="0" lIns="0">
+            <a:spAutoFit/>
+          </a:bodyPr>
+          <a:lstStyle/>
+          <a:p>
+            <a:pPr algn="l">
+              <a:lnSpc>
+                <a:spcPct val="120000"/>
+              </a:lnSpc>
+              <a:spcBef>
+                <a:spcPts val="0"/>
+              </a:spcBef>
+              <a:spcAft>
+                <a:spcPts val="0"/>
+              </a:spcAft>
+            </a:pPr>
+            <a:r>
+              <a:rPr sz="675" b="1">
+                <a:solidFill>
+                  <a:srgbClr val="6B6B6B"/>
+                </a:solidFill>
+                <a:latin typeface="Meiryo"/>
+                <a:ea typeface="Meiryo"/>
+                <a:cs typeface="Meiryo"/>
+              </a:rPr>
+              <a:t>手の甲側</a:t>
+            </a:r>
+          </a:p>
+        </p:txBody>
+      </p:sp>
+      <p:sp>
+        <p:nvSpPr>
+          <p:cNvPr id="19" name="TextBox 18"/>
+          <p:cNvSpPr txBox="1"/>
+          <p:nvPr/>
+        </p:nvSpPr>
+        <p:spPr>
+          <a:xfrm>
+            <a:off x="869632" y="2381726"/>
+            <a:ext cx="771525" cy="128588"/>
+          </a:xfrm>
+          <a:prstGeom prst="rect">
+            <a:avLst/>
+          </a:prstGeom>
+          <a:noFill/>
+        </p:spPr>
+        <p:txBody>
+          <a:bodyPr wrap="square" tIns="0" rIns="0" bIns="0" lIns="0">
+            <a:spAutoFit/>
+          </a:bodyPr>
+          <a:lstStyle/>
+          <a:p>
+            <a:pPr algn="l">
+              <a:lnSpc>
+                <a:spcPct val="120000"/>
+              </a:lnSpc>
+              <a:spcBef>
+                <a:spcPts val="0"/>
+              </a:spcBef>
+              <a:spcAft>
+                <a:spcPts val="0"/>
+              </a:spcAft>
+            </a:pPr>
+            <a:r>
+              <a:rPr sz="675" b="1">
+                <a:solidFill>
+                  <a:srgbClr val="6B6B6B"/>
+                </a:solidFill>
+                <a:latin typeface="Meiryo"/>
+                <a:ea typeface="Meiryo"/>
+                <a:cs typeface="Meiryo"/>
+              </a:rPr>
+              <a:t>手のひら側</a:t>
+            </a:r>
+          </a:p>
+        </p:txBody>
+      </p:sp>
+      <p:cxnSp>
+        <p:nvCxnSpPr>
+          <p:cNvPr id="20" name="Connector 19"/>
+          <p:cNvCxnSpPr/>
+          <p:nvPr/>
+        </p:nvCxnSpPr>
+        <p:spPr>
+          <a:xfrm flipV="1">
+            <a:off x="2446972" y="1893094"/>
+            <a:ext cx="0" cy="342900"/>
           </a:xfrm>
           <a:prstGeom prst="line">
             <a:avLst/>
@@ -10501,18 +10822,18 @@
       </p:cxnSp>
       <p:sp>
         <p:nvSpPr>
-          <p:cNvPr id="12" name="Rounded Rectangle 11"/>
+          <p:cNvPr id="21" name="Rounded Rectangle 20"/>
           <p:cNvSpPr/>
           <p:nvPr/>
         </p:nvSpPr>
         <p:spPr>
           <a:xfrm>
-            <a:off x="1962340" y="1937956"/>
-            <a:ext cx="236220" cy="64960"/>
+            <a:off x="1941195" y="1953101"/>
+            <a:ext cx="342900" cy="94298"/>
           </a:xfrm>
           <a:prstGeom prst="roundRect">
             <a:avLst>
-              <a:gd name="adj" fmla="val 43988"/>
+              <a:gd name="adj" fmla="val 30303"/>
             </a:avLst>
           </a:prstGeom>
           <a:solidFill>
@@ -10547,14 +10868,14 @@
       </p:sp>
       <p:cxnSp>
         <p:nvCxnSpPr>
-          <p:cNvPr id="13" name="Connector 12"/>
+          <p:cNvPr id="22" name="Connector 21"/>
           <p:cNvCxnSpPr/>
           <p:nvPr/>
         </p:nvCxnSpPr>
         <p:spPr>
           <a:xfrm>
-            <a:off x="2080450" y="1772602"/>
-            <a:ext cx="0" cy="153544"/>
+            <a:off x="2112645" y="1713071"/>
+            <a:ext cx="0" cy="222885"/>
           </a:xfrm>
           <a:prstGeom prst="line">
             <a:avLst/>
@@ -10569,14 +10890,14 @@
       </p:cxnSp>
       <p:sp>
         <p:nvSpPr>
-          <p:cNvPr id="14" name="TextBox 13"/>
+          <p:cNvPr id="23" name="TextBox 22"/>
           <p:cNvSpPr txBox="1"/>
           <p:nvPr/>
         </p:nvSpPr>
         <p:spPr>
           <a:xfrm>
-            <a:off x="1430846" y="1784414"/>
-            <a:ext cx="605314" cy="100394"/>
+            <a:off x="1169670" y="1730216"/>
+            <a:ext cx="878681" cy="145732"/>
           </a:xfrm>
           <a:prstGeom prst="rect">
             <a:avLst/>
@@ -10616,13 +10937,13 @@
       </p:sp>
       <p:sp>
         <p:nvSpPr>
-          <p:cNvPr id="15" name="TextBox 14"/>
+          <p:cNvPr id="24" name="TextBox 23"/>
           <p:cNvSpPr txBox="1"/>
           <p:nvPr/>
         </p:nvSpPr>
         <p:spPr>
           <a:xfrm>
-            <a:off x="647700" y="2440305"/>
+            <a:off x="647700" y="2733675"/>
             <a:ext cx="2381250" cy="381000"/>
           </a:xfrm>
           <a:prstGeom prst="rect">
@@ -10663,7 +10984,7 @@
       </p:sp>
       <p:sp>
         <p:nvSpPr>
-          <p:cNvPr id="16" name="Rounded Rectangle 15"/>
+          <p:cNvPr id="25" name="Rounded Rectangle 24"/>
           <p:cNvSpPr/>
           <p:nvPr/>
         </p:nvSpPr>
@@ -10711,7 +11032,7 @@
       </p:sp>
       <p:sp>
         <p:nvSpPr>
-          <p:cNvPr id="17" name="TextBox 16"/>
+          <p:cNvPr id="26" name="TextBox 25"/>
           <p:cNvSpPr txBox="1"/>
           <p:nvPr/>
         </p:nvSpPr>
@@ -10769,14 +11090,14 @@
       </p:sp>
       <p:sp>
         <p:nvSpPr>
-          <p:cNvPr id="18" name="Rectangle 17"/>
+          <p:cNvPr id="27" name="Rectangle 26"/>
           <p:cNvSpPr/>
           <p:nvPr/>
         </p:nvSpPr>
         <p:spPr>
           <a:xfrm>
-            <a:off x="3805238" y="1743075"/>
-            <a:ext cx="1476375" cy="649605"/>
+            <a:off x="3471862" y="1743075"/>
+            <a:ext cx="2143125" cy="942975"/>
           </a:xfrm>
           <a:prstGeom prst="rect">
             <a:avLst/>
@@ -10813,14 +11134,14 @@
       </p:sp>
       <p:sp>
         <p:nvSpPr>
-          <p:cNvPr id="19" name="TextBox 18"/>
+          <p:cNvPr id="28" name="TextBox 27"/>
           <p:cNvSpPr txBox="1"/>
           <p:nvPr/>
         </p:nvSpPr>
         <p:spPr>
           <a:xfrm>
-            <a:off x="3828860" y="2292286"/>
-            <a:ext cx="1181100" cy="100394"/>
+            <a:off x="3506152" y="2540318"/>
+            <a:ext cx="1714500" cy="145732"/>
           </a:xfrm>
           <a:prstGeom prst="rect">
             <a:avLst/>
@@ -10860,18 +11181,18 @@
       </p:sp>
       <p:sp>
         <p:nvSpPr>
-          <p:cNvPr id="20" name="Rounded Rectangle 19"/>
+          <p:cNvPr id="29" name="Rounded Rectangle 28"/>
           <p:cNvSpPr/>
           <p:nvPr/>
         </p:nvSpPr>
         <p:spPr>
           <a:xfrm>
-            <a:off x="3864292" y="2023586"/>
-            <a:ext cx="832676" cy="147638"/>
+            <a:off x="3557588" y="2150269"/>
+            <a:ext cx="1071562" cy="214312"/>
           </a:xfrm>
           <a:prstGeom prst="roundRect">
             <a:avLst>
-              <a:gd name="adj" fmla="val 38709"/>
+              <a:gd name="adj" fmla="val 26666"/>
             </a:avLst>
           </a:prstGeom>
           <a:solidFill>
@@ -10908,18 +11229,18 @@
       </p:sp>
       <p:sp>
         <p:nvSpPr>
-          <p:cNvPr id="21" name="Rounded Rectangle 20"/>
+          <p:cNvPr id="30" name="Rounded Rectangle 29"/>
           <p:cNvSpPr/>
           <p:nvPr/>
         </p:nvSpPr>
         <p:spPr>
           <a:xfrm>
-            <a:off x="4679252" y="2008822"/>
-            <a:ext cx="212598" cy="177165"/>
+            <a:off x="4594860" y="2055971"/>
+            <a:ext cx="445770" cy="402908"/>
           </a:xfrm>
           <a:prstGeom prst="roundRect">
             <a:avLst>
-              <a:gd name="adj" fmla="val 37634"/>
+              <a:gd name="adj" fmla="val 16548"/>
             </a:avLst>
           </a:prstGeom>
           <a:solidFill>
@@ -10956,14 +11277,335 @@
       </p:sp>
       <p:cxnSp>
         <p:nvCxnSpPr>
-          <p:cNvPr id="22" name="Connector 21"/>
+          <p:cNvPr id="31" name="Connector 30"/>
           <p:cNvCxnSpPr/>
           <p:nvPr/>
         </p:nvCxnSpPr>
         <p:spPr>
+          <a:xfrm>
+            <a:off x="4903470" y="2090261"/>
+            <a:ext cx="0" cy="120015"/>
+          </a:xfrm>
+          <a:prstGeom prst="line">
+            <a:avLst/>
+          </a:prstGeom>
+          <a:ln w="7143">
+            <a:solidFill>
+              <a:srgbClr val="8A7A6C"/>
+            </a:solidFill>
+          </a:ln>
+        </p:spPr>
+      </p:cxnSp>
+      <p:cxnSp>
+        <p:nvCxnSpPr>
+          <p:cNvPr id="32" name="Connector 31"/>
+          <p:cNvCxnSpPr/>
+          <p:nvPr/>
+        </p:nvCxnSpPr>
+        <p:spPr>
+          <a:xfrm>
+            <a:off x="4950619" y="2090261"/>
+            <a:ext cx="0" cy="120015"/>
+          </a:xfrm>
+          <a:prstGeom prst="line">
+            <a:avLst/>
+          </a:prstGeom>
+          <a:ln w="7143">
+            <a:solidFill>
+              <a:srgbClr val="8A7A6C"/>
+            </a:solidFill>
+          </a:ln>
+        </p:spPr>
+      </p:cxnSp>
+      <p:cxnSp>
+        <p:nvCxnSpPr>
+          <p:cNvPr id="33" name="Connector 32"/>
+          <p:cNvCxnSpPr/>
+          <p:nvPr/>
+        </p:nvCxnSpPr>
+        <p:spPr>
+          <a:xfrm>
+            <a:off x="4997768" y="2090261"/>
+            <a:ext cx="0" cy="120015"/>
+          </a:xfrm>
+          <a:prstGeom prst="line">
+            <a:avLst/>
+          </a:prstGeom>
+          <a:ln w="7143">
+            <a:solidFill>
+              <a:srgbClr val="8A7A6C"/>
+            </a:solidFill>
+          </a:ln>
+        </p:spPr>
+      </p:cxnSp>
+      <p:sp>
+        <p:nvSpPr>
+          <p:cNvPr id="34" name="Rounded Rectangle 33"/>
+          <p:cNvSpPr/>
+          <p:nvPr/>
+        </p:nvSpPr>
+        <p:spPr>
+          <a:xfrm>
+            <a:off x="4629150" y="2235994"/>
+            <a:ext cx="334328" cy="120015"/>
+          </a:xfrm>
+          <a:prstGeom prst="roundRect">
+            <a:avLst>
+              <a:gd name="adj" fmla="val 50000"/>
+            </a:avLst>
+          </a:prstGeom>
+          <a:solidFill>
+            <a:srgbClr val="E2C8B0"/>
+          </a:solidFill>
+          <a:ln w="9525">
+            <a:solidFill>
+              <a:srgbClr val="8A7A6C"/>
+            </a:solidFill>
+          </a:ln>
+          <a:effectLst/>
+        </p:spPr>
+        <p:style>
+          <a:lnRef idx="1">
+            <a:schemeClr val="accent1"/>
+          </a:lnRef>
+          <a:fillRef idx="3">
+            <a:schemeClr val="accent1"/>
+          </a:fillRef>
+          <a:effectRef idx="2">
+            <a:schemeClr val="accent1"/>
+          </a:effectRef>
+          <a:fontRef idx="minor">
+            <a:schemeClr val="lt1"/>
+          </a:fontRef>
+        </p:style>
+        <p:txBody>
+          <a:bodyPr rtlCol="0" anchor="ctr"/>
+          <a:lstStyle/>
+          <a:p>
+            <a:pPr algn="ctr"/>
+          </a:p>
+        </p:txBody>
+      </p:sp>
+      <p:sp>
+        <p:nvSpPr>
+          <p:cNvPr id="35" name="Rounded Rectangle 34"/>
+          <p:cNvSpPr/>
+          <p:nvPr/>
+        </p:nvSpPr>
+        <p:spPr>
+          <a:xfrm>
+            <a:off x="4869180" y="2257425"/>
+            <a:ext cx="68580" cy="77152"/>
+          </a:xfrm>
+          <a:prstGeom prst="roundRect">
+            <a:avLst>
+              <a:gd name="adj" fmla="val 27777"/>
+            </a:avLst>
+          </a:prstGeom>
+          <a:solidFill>
+            <a:srgbClr val="FFF7EF"/>
+          </a:solidFill>
+          <a:ln w="4762">
+            <a:solidFill>
+              <a:srgbClr val="8A7A6C"/>
+            </a:solidFill>
+          </a:ln>
+          <a:effectLst/>
+        </p:spPr>
+        <p:style>
+          <a:lnRef idx="1">
+            <a:schemeClr val="accent1"/>
+          </a:lnRef>
+          <a:fillRef idx="3">
+            <a:schemeClr val="accent1"/>
+          </a:fillRef>
+          <a:effectRef idx="2">
+            <a:schemeClr val="accent1"/>
+          </a:effectRef>
+          <a:fontRef idx="minor">
+            <a:schemeClr val="lt1"/>
+          </a:fontRef>
+        </p:style>
+        <p:txBody>
+          <a:bodyPr rtlCol="0" anchor="ctr"/>
+          <a:lstStyle/>
+          <a:p>
+            <a:pPr algn="ctr"/>
+          </a:p>
+        </p:txBody>
+      </p:sp>
+      <p:sp>
+        <p:nvSpPr>
+          <p:cNvPr id="36" name="TextBox 35"/>
+          <p:cNvSpPr txBox="1"/>
+          <p:nvPr/>
+        </p:nvSpPr>
+        <p:spPr>
+          <a:xfrm>
+            <a:off x="4286250" y="2381726"/>
+            <a:ext cx="282892" cy="128588"/>
+          </a:xfrm>
+          <a:prstGeom prst="rect">
+            <a:avLst/>
+          </a:prstGeom>
+          <a:noFill/>
+        </p:spPr>
+        <p:txBody>
+          <a:bodyPr wrap="square" tIns="0" rIns="0" bIns="0" lIns="0">
+            <a:spAutoFit/>
+          </a:bodyPr>
+          <a:lstStyle/>
+          <a:p>
+            <a:pPr algn="r">
+              <a:lnSpc>
+                <a:spcPct val="120000"/>
+              </a:lnSpc>
+              <a:spcBef>
+                <a:spcPts val="0"/>
+              </a:spcBef>
+              <a:spcAft>
+                <a:spcPts val="0"/>
+              </a:spcAft>
+            </a:pPr>
+            <a:r>
+              <a:rPr sz="712" b="1">
+                <a:solidFill>
+                  <a:srgbClr val="8A7A6C"/>
+                </a:solidFill>
+                <a:latin typeface="Meiryo"/>
+                <a:ea typeface="Meiryo"/>
+                <a:cs typeface="Meiryo"/>
+              </a:rPr>
+              <a:t>親指</a:t>
+            </a:r>
+          </a:p>
+        </p:txBody>
+      </p:sp>
+      <p:cxnSp>
+        <p:nvCxnSpPr>
+          <p:cNvPr id="37" name="Connector 36"/>
+          <p:cNvCxnSpPr/>
+          <p:nvPr/>
+        </p:nvCxnSpPr>
+        <p:spPr>
           <a:xfrm flipV="1">
-            <a:off x="4968621" y="1846421"/>
-            <a:ext cx="0" cy="236220"/>
+            <a:off x="4577715" y="2296001"/>
+            <a:ext cx="111443" cy="137160"/>
+          </a:xfrm>
+          <a:prstGeom prst="line">
+            <a:avLst/>
+          </a:prstGeom>
+          <a:ln w="7143">
+            <a:solidFill>
+              <a:srgbClr val="8A7A6C"/>
+            </a:solidFill>
+          </a:ln>
+        </p:spPr>
+      </p:cxnSp>
+      <p:sp>
+        <p:nvSpPr>
+          <p:cNvPr id="38" name="TextBox 37"/>
+          <p:cNvSpPr txBox="1"/>
+          <p:nvPr/>
+        </p:nvSpPr>
+        <p:spPr>
+          <a:xfrm>
+            <a:off x="3574732" y="2004536"/>
+            <a:ext cx="771525" cy="128588"/>
+          </a:xfrm>
+          <a:prstGeom prst="rect">
+            <a:avLst/>
+          </a:prstGeom>
+          <a:noFill/>
+        </p:spPr>
+        <p:txBody>
+          <a:bodyPr wrap="square" tIns="0" rIns="0" bIns="0" lIns="0">
+            <a:spAutoFit/>
+          </a:bodyPr>
+          <a:lstStyle/>
+          <a:p>
+            <a:pPr algn="l">
+              <a:lnSpc>
+                <a:spcPct val="120000"/>
+              </a:lnSpc>
+              <a:spcBef>
+                <a:spcPts val="0"/>
+              </a:spcBef>
+              <a:spcAft>
+                <a:spcPts val="0"/>
+              </a:spcAft>
+            </a:pPr>
+            <a:r>
+              <a:rPr sz="675" b="1">
+                <a:solidFill>
+                  <a:srgbClr val="6B6B6B"/>
+                </a:solidFill>
+                <a:latin typeface="Meiryo"/>
+                <a:ea typeface="Meiryo"/>
+                <a:cs typeface="Meiryo"/>
+              </a:rPr>
+              <a:t>手の甲側</a:t>
+            </a:r>
+          </a:p>
+        </p:txBody>
+      </p:sp>
+      <p:sp>
+        <p:nvSpPr>
+          <p:cNvPr id="39" name="TextBox 38"/>
+          <p:cNvSpPr txBox="1"/>
+          <p:nvPr/>
+        </p:nvSpPr>
+        <p:spPr>
+          <a:xfrm>
+            <a:off x="3574732" y="2381726"/>
+            <a:ext cx="771525" cy="128588"/>
+          </a:xfrm>
+          <a:prstGeom prst="rect">
+            <a:avLst/>
+          </a:prstGeom>
+          <a:noFill/>
+        </p:spPr>
+        <p:txBody>
+          <a:bodyPr wrap="square" tIns="0" rIns="0" bIns="0" lIns="0">
+            <a:spAutoFit/>
+          </a:bodyPr>
+          <a:lstStyle/>
+          <a:p>
+            <a:pPr algn="l">
+              <a:lnSpc>
+                <a:spcPct val="120000"/>
+              </a:lnSpc>
+              <a:spcBef>
+                <a:spcPts val="0"/>
+              </a:spcBef>
+              <a:spcAft>
+                <a:spcPts val="0"/>
+              </a:spcAft>
+            </a:pPr>
+            <a:r>
+              <a:rPr sz="675" b="1">
+                <a:solidFill>
+                  <a:srgbClr val="6B6B6B"/>
+                </a:solidFill>
+                <a:latin typeface="Meiryo"/>
+                <a:ea typeface="Meiryo"/>
+                <a:cs typeface="Meiryo"/>
+              </a:rPr>
+              <a:t>手のひら側</a:t>
+            </a:r>
+          </a:p>
+        </p:txBody>
+      </p:sp>
+      <p:cxnSp>
+        <p:nvCxnSpPr>
+          <p:cNvPr id="40" name="Connector 39"/>
+          <p:cNvCxnSpPr/>
+          <p:nvPr/>
+        </p:nvCxnSpPr>
+        <p:spPr>
+          <a:xfrm flipV="1">
+            <a:off x="5152072" y="1893094"/>
+            <a:ext cx="0" cy="342900"/>
           </a:xfrm>
           <a:prstGeom prst="line">
             <a:avLst/>
@@ -10978,14 +11620,14 @@
       </p:cxnSp>
       <p:sp>
         <p:nvSpPr>
-          <p:cNvPr id="23" name="TextBox 22"/>
+          <p:cNvPr id="41" name="TextBox 40"/>
           <p:cNvSpPr txBox="1"/>
           <p:nvPr/>
         </p:nvSpPr>
         <p:spPr>
           <a:xfrm>
-            <a:off x="4112324" y="2177129"/>
-            <a:ext cx="944880" cy="118110"/>
+            <a:off x="3909060" y="2527459"/>
+            <a:ext cx="1371600" cy="171450"/>
           </a:xfrm>
           <a:prstGeom prst="rect">
             <a:avLst/>
@@ -11025,18 +11667,18 @@
       </p:sp>
       <p:sp>
         <p:nvSpPr>
-          <p:cNvPr id="24" name="Rounded Rectangle 23"/>
+          <p:cNvPr id="42" name="Rounded Rectangle 41"/>
           <p:cNvSpPr/>
           <p:nvPr/>
         </p:nvSpPr>
         <p:spPr>
           <a:xfrm>
-            <a:off x="4667440" y="1937956"/>
-            <a:ext cx="236220" cy="64960"/>
+            <a:off x="4646295" y="1953101"/>
+            <a:ext cx="342900" cy="94298"/>
           </a:xfrm>
           <a:prstGeom prst="roundRect">
             <a:avLst>
-              <a:gd name="adj" fmla="val 43988"/>
+              <a:gd name="adj" fmla="val 30303"/>
             </a:avLst>
           </a:prstGeom>
           <a:solidFill>
@@ -11071,14 +11713,14 @@
       </p:sp>
       <p:cxnSp>
         <p:nvCxnSpPr>
-          <p:cNvPr id="25" name="Connector 24"/>
+          <p:cNvPr id="43" name="Connector 42"/>
           <p:cNvCxnSpPr/>
           <p:nvPr/>
         </p:nvCxnSpPr>
         <p:spPr>
           <a:xfrm>
-            <a:off x="4785550" y="1772602"/>
-            <a:ext cx="0" cy="153544"/>
+            <a:off x="4817745" y="1713071"/>
+            <a:ext cx="0" cy="222885"/>
           </a:xfrm>
           <a:prstGeom prst="line">
             <a:avLst/>
@@ -11093,14 +11735,14 @@
       </p:cxnSp>
       <p:sp>
         <p:nvSpPr>
-          <p:cNvPr id="26" name="TextBox 25"/>
+          <p:cNvPr id="44" name="TextBox 43"/>
           <p:cNvSpPr txBox="1"/>
           <p:nvPr/>
         </p:nvSpPr>
         <p:spPr>
           <a:xfrm>
-            <a:off x="4135946" y="1784414"/>
-            <a:ext cx="605314" cy="100394"/>
+            <a:off x="3874770" y="1730216"/>
+            <a:ext cx="878681" cy="145732"/>
           </a:xfrm>
           <a:prstGeom prst="rect">
             <a:avLst/>
@@ -11140,13 +11782,13 @@
       </p:sp>
       <p:sp>
         <p:nvSpPr>
-          <p:cNvPr id="27" name="TextBox 26"/>
+          <p:cNvPr id="45" name="TextBox 44"/>
           <p:cNvSpPr txBox="1"/>
           <p:nvPr/>
         </p:nvSpPr>
         <p:spPr>
           <a:xfrm>
-            <a:off x="3352800" y="2440305"/>
+            <a:off x="3352800" y="2733675"/>
             <a:ext cx="2381250" cy="381000"/>
           </a:xfrm>
           <a:prstGeom prst="rect">
@@ -11187,7 +11829,7 @@
       </p:sp>
       <p:sp>
         <p:nvSpPr>
-          <p:cNvPr id="28" name="TextBox 27"/>
+          <p:cNvPr id="46" name="TextBox 45"/>
           <p:cNvSpPr txBox="1"/>
           <p:nvPr/>
         </p:nvSpPr>
@@ -11234,7 +11876,7 @@
       </p:sp>
       <p:sp>
         <p:nvSpPr>
-          <p:cNvPr id="29" name="Rounded Rectangle 28"/>
+          <p:cNvPr id="47" name="Rounded Rectangle 46"/>
           <p:cNvSpPr/>
           <p:nvPr/>
         </p:nvSpPr>
@@ -11282,7 +11924,7 @@
       </p:sp>
       <p:sp>
         <p:nvSpPr>
-          <p:cNvPr id="30" name="TextBox 29"/>
+          <p:cNvPr id="48" name="TextBox 47"/>
           <p:cNvSpPr txBox="1"/>
           <p:nvPr/>
         </p:nvSpPr>
@@ -11340,14 +11982,14 @@
       </p:sp>
       <p:sp>
         <p:nvSpPr>
-          <p:cNvPr id="31" name="Rectangle 30"/>
+          <p:cNvPr id="49" name="Rectangle 48"/>
           <p:cNvSpPr/>
           <p:nvPr/>
         </p:nvSpPr>
         <p:spPr>
           <a:xfrm>
-            <a:off x="6510338" y="1743075"/>
-            <a:ext cx="1476375" cy="649605"/>
+            <a:off x="6176962" y="1743075"/>
+            <a:ext cx="2143125" cy="942975"/>
           </a:xfrm>
           <a:prstGeom prst="rect">
             <a:avLst/>
@@ -11384,14 +12026,14 @@
       </p:sp>
       <p:sp>
         <p:nvSpPr>
-          <p:cNvPr id="32" name="TextBox 31"/>
+          <p:cNvPr id="50" name="TextBox 49"/>
           <p:cNvSpPr txBox="1"/>
           <p:nvPr/>
         </p:nvSpPr>
         <p:spPr>
           <a:xfrm>
-            <a:off x="6533960" y="2292286"/>
-            <a:ext cx="1181100" cy="100394"/>
+            <a:off x="6211252" y="2540318"/>
+            <a:ext cx="1714500" cy="145732"/>
           </a:xfrm>
           <a:prstGeom prst="rect">
             <a:avLst/>
@@ -11431,18 +12073,18 @@
       </p:sp>
       <p:sp>
         <p:nvSpPr>
-          <p:cNvPr id="33" name="Rounded Rectangle 32"/>
+          <p:cNvPr id="51" name="Rounded Rectangle 50"/>
           <p:cNvSpPr/>
           <p:nvPr/>
         </p:nvSpPr>
         <p:spPr>
           <a:xfrm>
-            <a:off x="6569392" y="2023586"/>
-            <a:ext cx="832676" cy="147638"/>
+            <a:off x="6262688" y="2150269"/>
+            <a:ext cx="1071562" cy="214312"/>
           </a:xfrm>
           <a:prstGeom prst="roundRect">
             <a:avLst>
-              <a:gd name="adj" fmla="val 38709"/>
+              <a:gd name="adj" fmla="val 26666"/>
             </a:avLst>
           </a:prstGeom>
           <a:solidFill>
@@ -11479,18 +12121,18 @@
       </p:sp>
       <p:sp>
         <p:nvSpPr>
-          <p:cNvPr id="34" name="Rounded Rectangle 33"/>
+          <p:cNvPr id="52" name="Rounded Rectangle 51"/>
           <p:cNvSpPr/>
           <p:nvPr/>
         </p:nvSpPr>
         <p:spPr>
           <a:xfrm>
-            <a:off x="7384352" y="2047208"/>
-            <a:ext cx="442912" cy="100394"/>
+            <a:off x="7299960" y="2133124"/>
+            <a:ext cx="771525" cy="248602"/>
           </a:xfrm>
           <a:prstGeom prst="roundRect">
             <a:avLst>
-              <a:gd name="adj" fmla="val 50000"/>
+              <a:gd name="adj" fmla="val 26819"/>
             </a:avLst>
           </a:prstGeom>
           <a:solidFill>
@@ -11527,14 +12169,335 @@
       </p:sp>
       <p:cxnSp>
         <p:nvCxnSpPr>
-          <p:cNvPr id="35" name="Connector 34"/>
+          <p:cNvPr id="53" name="Connector 52"/>
           <p:cNvCxnSpPr/>
           <p:nvPr/>
         </p:nvCxnSpPr>
         <p:spPr>
+          <a:xfrm>
+            <a:off x="7728585" y="2207704"/>
+            <a:ext cx="300037" cy="0"/>
+          </a:xfrm>
+          <a:prstGeom prst="line">
+            <a:avLst/>
+          </a:prstGeom>
+          <a:ln w="7143">
+            <a:solidFill>
+              <a:srgbClr val="8A7A6C"/>
+            </a:solidFill>
+          </a:ln>
+        </p:spPr>
+      </p:cxnSp>
+      <p:cxnSp>
+        <p:nvCxnSpPr>
+          <p:cNvPr id="54" name="Connector 53"/>
+          <p:cNvCxnSpPr/>
+          <p:nvPr/>
+        </p:nvCxnSpPr>
+        <p:spPr>
+          <a:xfrm>
+            <a:off x="7728585" y="2257425"/>
+            <a:ext cx="300037" cy="0"/>
+          </a:xfrm>
+          <a:prstGeom prst="line">
+            <a:avLst/>
+          </a:prstGeom>
+          <a:ln w="7143">
+            <a:solidFill>
+              <a:srgbClr val="8A7A6C"/>
+            </a:solidFill>
+          </a:ln>
+        </p:spPr>
+      </p:cxnSp>
+      <p:cxnSp>
+        <p:nvCxnSpPr>
+          <p:cNvPr id="55" name="Connector 54"/>
+          <p:cNvCxnSpPr/>
+          <p:nvPr/>
+        </p:nvCxnSpPr>
+        <p:spPr>
+          <a:xfrm>
+            <a:off x="7728585" y="2307146"/>
+            <a:ext cx="300037" cy="0"/>
+          </a:xfrm>
+          <a:prstGeom prst="line">
+            <a:avLst/>
+          </a:prstGeom>
+          <a:ln w="7143">
+            <a:solidFill>
+              <a:srgbClr val="8A7A6C"/>
+            </a:solidFill>
+          </a:ln>
+        </p:spPr>
+      </p:cxnSp>
+      <p:sp>
+        <p:nvSpPr>
+          <p:cNvPr id="56" name="Rounded Rectangle 55"/>
+          <p:cNvSpPr/>
+          <p:nvPr/>
+        </p:nvSpPr>
+        <p:spPr>
+          <a:xfrm>
+            <a:off x="7334250" y="2193131"/>
+            <a:ext cx="428625" cy="111443"/>
+          </a:xfrm>
+          <a:prstGeom prst="roundRect">
+            <a:avLst>
+              <a:gd name="adj" fmla="val 50000"/>
+            </a:avLst>
+          </a:prstGeom>
+          <a:solidFill>
+            <a:srgbClr val="E2C8B0"/>
+          </a:solidFill>
+          <a:ln w="9525">
+            <a:solidFill>
+              <a:srgbClr val="8A7A6C"/>
+            </a:solidFill>
+          </a:ln>
+          <a:effectLst/>
+        </p:spPr>
+        <p:style>
+          <a:lnRef idx="1">
+            <a:schemeClr val="accent1"/>
+          </a:lnRef>
+          <a:fillRef idx="3">
+            <a:schemeClr val="accent1"/>
+          </a:fillRef>
+          <a:effectRef idx="2">
+            <a:schemeClr val="accent1"/>
+          </a:effectRef>
+          <a:fontRef idx="minor">
+            <a:schemeClr val="lt1"/>
+          </a:fontRef>
+        </p:style>
+        <p:txBody>
+          <a:bodyPr rtlCol="0" anchor="ctr"/>
+          <a:lstStyle/>
+          <a:p>
+            <a:pPr algn="ctr"/>
+          </a:p>
+        </p:txBody>
+      </p:sp>
+      <p:sp>
+        <p:nvSpPr>
+          <p:cNvPr id="57" name="Rounded Rectangle 56"/>
+          <p:cNvSpPr/>
+          <p:nvPr/>
+        </p:nvSpPr>
+        <p:spPr>
+          <a:xfrm>
+            <a:off x="7668578" y="2214562"/>
+            <a:ext cx="68580" cy="68580"/>
+          </a:xfrm>
+          <a:prstGeom prst="roundRect">
+            <a:avLst>
+              <a:gd name="adj" fmla="val 27777"/>
+            </a:avLst>
+          </a:prstGeom>
+          <a:solidFill>
+            <a:srgbClr val="FFF7EF"/>
+          </a:solidFill>
+          <a:ln w="4762">
+            <a:solidFill>
+              <a:srgbClr val="8A7A6C"/>
+            </a:solidFill>
+          </a:ln>
+          <a:effectLst/>
+        </p:spPr>
+        <p:style>
+          <a:lnRef idx="1">
+            <a:schemeClr val="accent1"/>
+          </a:lnRef>
+          <a:fillRef idx="3">
+            <a:schemeClr val="accent1"/>
+          </a:fillRef>
+          <a:effectRef idx="2">
+            <a:schemeClr val="accent1"/>
+          </a:effectRef>
+          <a:fontRef idx="minor">
+            <a:schemeClr val="lt1"/>
+          </a:fontRef>
+        </p:style>
+        <p:txBody>
+          <a:bodyPr rtlCol="0" anchor="ctr"/>
+          <a:lstStyle/>
+          <a:p>
+            <a:pPr algn="ctr"/>
+          </a:p>
+        </p:txBody>
+      </p:sp>
+      <p:sp>
+        <p:nvSpPr>
+          <p:cNvPr id="58" name="TextBox 57"/>
+          <p:cNvSpPr txBox="1"/>
+          <p:nvPr/>
+        </p:nvSpPr>
+        <p:spPr>
+          <a:xfrm>
+            <a:off x="6991350" y="2381726"/>
+            <a:ext cx="282892" cy="128588"/>
+          </a:xfrm>
+          <a:prstGeom prst="rect">
+            <a:avLst/>
+          </a:prstGeom>
+          <a:noFill/>
+        </p:spPr>
+        <p:txBody>
+          <a:bodyPr wrap="square" tIns="0" rIns="0" bIns="0" lIns="0">
+            <a:spAutoFit/>
+          </a:bodyPr>
+          <a:lstStyle/>
+          <a:p>
+            <a:pPr algn="r">
+              <a:lnSpc>
+                <a:spcPct val="120000"/>
+              </a:lnSpc>
+              <a:spcBef>
+                <a:spcPts val="0"/>
+              </a:spcBef>
+              <a:spcAft>
+                <a:spcPts val="0"/>
+              </a:spcAft>
+            </a:pPr>
+            <a:r>
+              <a:rPr sz="712" b="1">
+                <a:solidFill>
+                  <a:srgbClr val="8A7A6C"/>
+                </a:solidFill>
+                <a:latin typeface="Meiryo"/>
+                <a:ea typeface="Meiryo"/>
+                <a:cs typeface="Meiryo"/>
+              </a:rPr>
+              <a:t>親指</a:t>
+            </a:r>
+          </a:p>
+        </p:txBody>
+      </p:sp>
+      <p:cxnSp>
+        <p:nvCxnSpPr>
+          <p:cNvPr id="59" name="Connector 58"/>
+          <p:cNvCxnSpPr/>
+          <p:nvPr/>
+        </p:nvCxnSpPr>
+        <p:spPr>
           <a:xfrm flipV="1">
-            <a:off x="7898130" y="1846421"/>
-            <a:ext cx="0" cy="236220"/>
+            <a:off x="7282815" y="2248852"/>
+            <a:ext cx="111443" cy="184309"/>
+          </a:xfrm>
+          <a:prstGeom prst="line">
+            <a:avLst/>
+          </a:prstGeom>
+          <a:ln w="7143">
+            <a:solidFill>
+              <a:srgbClr val="8A7A6C"/>
+            </a:solidFill>
+          </a:ln>
+        </p:spPr>
+      </p:cxnSp>
+      <p:sp>
+        <p:nvSpPr>
+          <p:cNvPr id="60" name="TextBox 59"/>
+          <p:cNvSpPr txBox="1"/>
+          <p:nvPr/>
+        </p:nvSpPr>
+        <p:spPr>
+          <a:xfrm>
+            <a:off x="6279832" y="2004536"/>
+            <a:ext cx="771525" cy="128588"/>
+          </a:xfrm>
+          <a:prstGeom prst="rect">
+            <a:avLst/>
+          </a:prstGeom>
+          <a:noFill/>
+        </p:spPr>
+        <p:txBody>
+          <a:bodyPr wrap="square" tIns="0" rIns="0" bIns="0" lIns="0">
+            <a:spAutoFit/>
+          </a:bodyPr>
+          <a:lstStyle/>
+          <a:p>
+            <a:pPr algn="l">
+              <a:lnSpc>
+                <a:spcPct val="120000"/>
+              </a:lnSpc>
+              <a:spcBef>
+                <a:spcPts val="0"/>
+              </a:spcBef>
+              <a:spcAft>
+                <a:spcPts val="0"/>
+              </a:spcAft>
+            </a:pPr>
+            <a:r>
+              <a:rPr sz="675" b="1">
+                <a:solidFill>
+                  <a:srgbClr val="6B6B6B"/>
+                </a:solidFill>
+                <a:latin typeface="Meiryo"/>
+                <a:ea typeface="Meiryo"/>
+                <a:cs typeface="Meiryo"/>
+              </a:rPr>
+              <a:t>手の甲側</a:t>
+            </a:r>
+          </a:p>
+        </p:txBody>
+      </p:sp>
+      <p:sp>
+        <p:nvSpPr>
+          <p:cNvPr id="61" name="TextBox 60"/>
+          <p:cNvSpPr txBox="1"/>
+          <p:nvPr/>
+        </p:nvSpPr>
+        <p:spPr>
+          <a:xfrm>
+            <a:off x="6279832" y="2381726"/>
+            <a:ext cx="771525" cy="128588"/>
+          </a:xfrm>
+          <a:prstGeom prst="rect">
+            <a:avLst/>
+          </a:prstGeom>
+          <a:noFill/>
+        </p:spPr>
+        <p:txBody>
+          <a:bodyPr wrap="square" tIns="0" rIns="0" bIns="0" lIns="0">
+            <a:spAutoFit/>
+          </a:bodyPr>
+          <a:lstStyle/>
+          <a:p>
+            <a:pPr algn="l">
+              <a:lnSpc>
+                <a:spcPct val="120000"/>
+              </a:lnSpc>
+              <a:spcBef>
+                <a:spcPts val="0"/>
+              </a:spcBef>
+              <a:spcAft>
+                <a:spcPts val="0"/>
+              </a:spcAft>
+            </a:pPr>
+            <a:r>
+              <a:rPr sz="675" b="1">
+                <a:solidFill>
+                  <a:srgbClr val="6B6B6B"/>
+                </a:solidFill>
+                <a:latin typeface="Meiryo"/>
+                <a:ea typeface="Meiryo"/>
+                <a:cs typeface="Meiryo"/>
+              </a:rPr>
+              <a:t>手のひら側</a:t>
+            </a:r>
+          </a:p>
+        </p:txBody>
+      </p:sp>
+      <p:cxnSp>
+        <p:nvCxnSpPr>
+          <p:cNvPr id="62" name="Connector 61"/>
+          <p:cNvCxnSpPr/>
+          <p:nvPr/>
+        </p:nvCxnSpPr>
+        <p:spPr>
+          <a:xfrm flipV="1">
+            <a:off x="8182928" y="1893094"/>
+            <a:ext cx="0" cy="342900"/>
           </a:xfrm>
           <a:prstGeom prst="line">
             <a:avLst/>
@@ -11549,18 +12512,18 @@
       </p:cxnSp>
       <p:sp>
         <p:nvSpPr>
-          <p:cNvPr id="36" name="Rounded Rectangle 35"/>
+          <p:cNvPr id="63" name="Rounded Rectangle 62"/>
           <p:cNvSpPr/>
           <p:nvPr/>
         </p:nvSpPr>
         <p:spPr>
           <a:xfrm>
-            <a:off x="7487698" y="1976342"/>
-            <a:ext cx="236220" cy="64960"/>
+            <a:off x="7514272" y="2030254"/>
+            <a:ext cx="342900" cy="94298"/>
           </a:xfrm>
           <a:prstGeom prst="roundRect">
             <a:avLst>
-              <a:gd name="adj" fmla="val 43988"/>
+              <a:gd name="adj" fmla="val 30303"/>
             </a:avLst>
           </a:prstGeom>
           <a:solidFill>
@@ -11595,14 +12558,14 @@
       </p:sp>
       <p:cxnSp>
         <p:nvCxnSpPr>
-          <p:cNvPr id="37" name="Connector 36"/>
+          <p:cNvPr id="64" name="Connector 63"/>
           <p:cNvCxnSpPr/>
           <p:nvPr/>
         </p:nvCxnSpPr>
         <p:spPr>
           <a:xfrm>
-            <a:off x="7605808" y="1810988"/>
-            <a:ext cx="0" cy="153543"/>
+            <a:off x="7685722" y="1790224"/>
+            <a:ext cx="0" cy="222885"/>
           </a:xfrm>
           <a:prstGeom prst="line">
             <a:avLst/>
@@ -11617,14 +12580,14 @@
       </p:cxnSp>
       <p:sp>
         <p:nvSpPr>
-          <p:cNvPr id="38" name="TextBox 37"/>
+          <p:cNvPr id="65" name="TextBox 64"/>
           <p:cNvSpPr txBox="1"/>
           <p:nvPr/>
         </p:nvSpPr>
         <p:spPr>
           <a:xfrm>
-            <a:off x="6956203" y="1822799"/>
-            <a:ext cx="605314" cy="100394"/>
+            <a:off x="6742748" y="1807369"/>
+            <a:ext cx="878681" cy="145732"/>
           </a:xfrm>
           <a:prstGeom prst="rect">
             <a:avLst/>
@@ -11664,13 +12627,13 @@
       </p:sp>
       <p:sp>
         <p:nvSpPr>
-          <p:cNvPr id="39" name="TextBox 38"/>
+          <p:cNvPr id="66" name="TextBox 65"/>
           <p:cNvSpPr txBox="1"/>
           <p:nvPr/>
         </p:nvSpPr>
         <p:spPr>
           <a:xfrm>
-            <a:off x="6057900" y="2440305"/>
+            <a:off x="6057900" y="2733675"/>
             <a:ext cx="2381250" cy="381000"/>
           </a:xfrm>
           <a:prstGeom prst="rect">
@@ -11711,7 +12674,7 @@
       </p:sp>
       <p:sp>
         <p:nvSpPr>
-          <p:cNvPr id="40" name="TextBox 39"/>
+          <p:cNvPr id="67" name="TextBox 66"/>
           <p:cNvSpPr txBox="1"/>
           <p:nvPr/>
         </p:nvSpPr>
@@ -11758,7 +12721,7 @@
       </p:sp>
       <p:sp>
         <p:nvSpPr>
-          <p:cNvPr id="41" name="Rounded Rectangle 40"/>
+          <p:cNvPr id="68" name="Rounded Rectangle 67"/>
           <p:cNvSpPr/>
           <p:nvPr/>
         </p:nvSpPr>
@@ -11806,7 +12769,7 @@
       </p:sp>
       <p:sp>
         <p:nvSpPr>
-          <p:cNvPr id="42" name="TextBox 41"/>
+          <p:cNvPr id="69" name="TextBox 68"/>
           <p:cNvSpPr txBox="1"/>
           <p:nvPr/>
         </p:nvSpPr>
@@ -11864,14 +12827,14 @@
       </p:sp>
       <p:sp>
         <p:nvSpPr>
-          <p:cNvPr id="43" name="Rectangle 42"/>
+          <p:cNvPr id="70" name="Rectangle 69"/>
           <p:cNvSpPr/>
           <p:nvPr/>
         </p:nvSpPr>
         <p:spPr>
           <a:xfrm>
-            <a:off x="1100138" y="4054792"/>
-            <a:ext cx="885825" cy="147638"/>
+            <a:off x="766762" y="4281488"/>
+            <a:ext cx="1285875" cy="214312"/>
           </a:xfrm>
           <a:prstGeom prst="rect">
             <a:avLst/>
@@ -11908,14 +12871,14 @@
       </p:sp>
       <p:sp>
         <p:nvSpPr>
-          <p:cNvPr id="44" name="TextBox 43"/>
+          <p:cNvPr id="71" name="TextBox 70"/>
           <p:cNvSpPr txBox="1"/>
           <p:nvPr/>
         </p:nvSpPr>
         <p:spPr>
           <a:xfrm>
-            <a:off x="1123760" y="4072509"/>
-            <a:ext cx="590550" cy="118110"/>
+            <a:off x="801052" y="4307205"/>
+            <a:ext cx="857250" cy="171450"/>
           </a:xfrm>
           <a:prstGeom prst="rect">
             <a:avLst/>
@@ -11955,14 +12918,14 @@
       </p:sp>
       <p:sp>
         <p:nvSpPr>
-          <p:cNvPr id="45" name="TextBox 44"/>
+          <p:cNvPr id="72" name="TextBox 71"/>
           <p:cNvSpPr txBox="1"/>
           <p:nvPr/>
         </p:nvSpPr>
         <p:spPr>
           <a:xfrm>
-            <a:off x="1306830" y="3948494"/>
-            <a:ext cx="679132" cy="100394"/>
+            <a:off x="1066800" y="4127182"/>
+            <a:ext cx="985838" cy="145732"/>
           </a:xfrm>
           <a:prstGeom prst="rect">
             <a:avLst/>
@@ -12002,18 +12965,18 @@
       </p:sp>
       <p:sp>
         <p:nvSpPr>
-          <p:cNvPr id="46" name="Rounded Rectangle 45"/>
+          <p:cNvPr id="73" name="Rounded Rectangle 72"/>
           <p:cNvSpPr/>
           <p:nvPr/>
         </p:nvSpPr>
         <p:spPr>
           <a:xfrm>
-            <a:off x="1159192" y="3789045"/>
-            <a:ext cx="832676" cy="147638"/>
+            <a:off x="852488" y="3895725"/>
+            <a:ext cx="1208722" cy="214312"/>
           </a:xfrm>
           <a:prstGeom prst="roundRect">
             <a:avLst>
-              <a:gd name="adj" fmla="val 38709"/>
+              <a:gd name="adj" fmla="val 26666"/>
             </a:avLst>
           </a:prstGeom>
           <a:solidFill>
@@ -12050,18 +13013,18 @@
       </p:sp>
       <p:sp>
         <p:nvSpPr>
-          <p:cNvPr id="47" name="Rounded Rectangle 46"/>
+          <p:cNvPr id="74" name="Rounded Rectangle 73"/>
           <p:cNvSpPr/>
           <p:nvPr/>
         </p:nvSpPr>
         <p:spPr>
           <a:xfrm>
-            <a:off x="1974152" y="3774281"/>
-            <a:ext cx="212598" cy="177165"/>
+            <a:off x="2035493" y="3874294"/>
+            <a:ext cx="308610" cy="257175"/>
           </a:xfrm>
           <a:prstGeom prst="roundRect">
             <a:avLst>
-              <a:gd name="adj" fmla="val 37634"/>
+              <a:gd name="adj" fmla="val 25925"/>
             </a:avLst>
           </a:prstGeom>
           <a:solidFill>
@@ -12098,14 +13061,14 @@
       </p:sp>
       <p:cxnSp>
         <p:nvCxnSpPr>
-          <p:cNvPr id="48" name="Connector 47"/>
+          <p:cNvPr id="75" name="Connector 74"/>
           <p:cNvCxnSpPr/>
           <p:nvPr/>
         </p:nvCxnSpPr>
         <p:spPr>
           <a:xfrm flipV="1">
-            <a:off x="2263521" y="3611880"/>
-            <a:ext cx="0" cy="236220"/>
+            <a:off x="2455545" y="3638550"/>
+            <a:ext cx="0" cy="342900"/>
           </a:xfrm>
           <a:prstGeom prst="line">
             <a:avLst/>
@@ -12120,14 +13083,14 @@
       </p:cxnSp>
       <p:sp>
         <p:nvSpPr>
-          <p:cNvPr id="49" name="TextBox 48"/>
+          <p:cNvPr id="76" name="TextBox 75"/>
           <p:cNvSpPr txBox="1"/>
           <p:nvPr/>
         </p:nvSpPr>
         <p:spPr>
           <a:xfrm>
-            <a:off x="1407224" y="3942588"/>
-            <a:ext cx="944880" cy="118110"/>
+            <a:off x="1212533" y="4118610"/>
+            <a:ext cx="1371600" cy="171450"/>
           </a:xfrm>
           <a:prstGeom prst="rect">
             <a:avLst/>
@@ -12167,18 +13130,18 @@
       </p:sp>
       <p:sp>
         <p:nvSpPr>
-          <p:cNvPr id="50" name="Rounded Rectangle 49"/>
+          <p:cNvPr id="77" name="Rounded Rectangle 76"/>
           <p:cNvSpPr/>
           <p:nvPr/>
         </p:nvSpPr>
         <p:spPr>
           <a:xfrm>
-            <a:off x="1962340" y="3703415"/>
-            <a:ext cx="236220" cy="64960"/>
+            <a:off x="2018348" y="3771424"/>
+            <a:ext cx="342900" cy="94298"/>
           </a:xfrm>
           <a:prstGeom prst="roundRect">
             <a:avLst>
-              <a:gd name="adj" fmla="val 43988"/>
+              <a:gd name="adj" fmla="val 30303"/>
             </a:avLst>
           </a:prstGeom>
           <a:solidFill>
@@ -12213,14 +13176,14 @@
       </p:sp>
       <p:cxnSp>
         <p:nvCxnSpPr>
-          <p:cNvPr id="51" name="Connector 50"/>
+          <p:cNvPr id="78" name="Connector 77"/>
           <p:cNvCxnSpPr/>
           <p:nvPr/>
         </p:nvCxnSpPr>
         <p:spPr>
           <a:xfrm>
-            <a:off x="2080450" y="3538061"/>
-            <a:ext cx="0" cy="153543"/>
+            <a:off x="2189798" y="3531394"/>
+            <a:ext cx="0" cy="222885"/>
           </a:xfrm>
           <a:prstGeom prst="line">
             <a:avLst/>
@@ -12235,14 +13198,14 @@
       </p:cxnSp>
       <p:sp>
         <p:nvSpPr>
-          <p:cNvPr id="52" name="TextBox 51"/>
+          <p:cNvPr id="79" name="TextBox 78"/>
           <p:cNvSpPr txBox="1"/>
           <p:nvPr/>
         </p:nvSpPr>
         <p:spPr>
           <a:xfrm>
-            <a:off x="1430846" y="3549872"/>
-            <a:ext cx="605314" cy="100394"/>
+            <a:off x="1246822" y="3548539"/>
+            <a:ext cx="878681" cy="145732"/>
           </a:xfrm>
           <a:prstGeom prst="rect">
             <a:avLst/>
@@ -12282,13 +13245,13 @@
       </p:sp>
       <p:sp>
         <p:nvSpPr>
-          <p:cNvPr id="53" name="TextBox 52"/>
+          <p:cNvPr id="80" name="TextBox 79"/>
           <p:cNvSpPr txBox="1"/>
           <p:nvPr/>
         </p:nvSpPr>
         <p:spPr>
           <a:xfrm>
-            <a:off x="647700" y="4250055"/>
+            <a:off x="647700" y="4543425"/>
             <a:ext cx="2381250" cy="381000"/>
           </a:xfrm>
           <a:prstGeom prst="rect">
@@ -12329,7 +13292,7 @@
       </p:sp>
       <p:sp>
         <p:nvSpPr>
-          <p:cNvPr id="54" name="TextBox 53"/>
+          <p:cNvPr id="81" name="TextBox 80"/>
           <p:cNvSpPr txBox="1"/>
           <p:nvPr/>
         </p:nvSpPr>
@@ -12376,7 +13339,7 @@
       </p:sp>
       <p:sp>
         <p:nvSpPr>
-          <p:cNvPr id="55" name="Rounded Rectangle 54"/>
+          <p:cNvPr id="82" name="Rounded Rectangle 81"/>
           <p:cNvSpPr/>
           <p:nvPr/>
         </p:nvSpPr>
@@ -12424,7 +13387,7 @@
       </p:sp>
       <p:sp>
         <p:nvSpPr>
-          <p:cNvPr id="56" name="TextBox 55"/>
+          <p:cNvPr id="83" name="TextBox 82"/>
           <p:cNvSpPr txBox="1"/>
           <p:nvPr/>
         </p:nvSpPr>
@@ -12482,14 +13445,14 @@
       </p:sp>
       <p:sp>
         <p:nvSpPr>
-          <p:cNvPr id="57" name="Rectangle 56"/>
+          <p:cNvPr id="84" name="Rectangle 83"/>
           <p:cNvSpPr/>
           <p:nvPr/>
         </p:nvSpPr>
         <p:spPr>
           <a:xfrm>
-            <a:off x="3805238" y="4054792"/>
-            <a:ext cx="885825" cy="147638"/>
+            <a:off x="3471862" y="4281488"/>
+            <a:ext cx="1285875" cy="214312"/>
           </a:xfrm>
           <a:prstGeom prst="rect">
             <a:avLst/>
@@ -12526,14 +13489,14 @@
       </p:sp>
       <p:sp>
         <p:nvSpPr>
-          <p:cNvPr id="58" name="TextBox 57"/>
+          <p:cNvPr id="85" name="TextBox 84"/>
           <p:cNvSpPr txBox="1"/>
           <p:nvPr/>
         </p:nvSpPr>
         <p:spPr>
           <a:xfrm>
-            <a:off x="3828860" y="4072509"/>
-            <a:ext cx="590550" cy="118110"/>
+            <a:off x="3506152" y="4307205"/>
+            <a:ext cx="857250" cy="171450"/>
           </a:xfrm>
           <a:prstGeom prst="rect">
             <a:avLst/>
@@ -12573,14 +13536,14 @@
       </p:sp>
       <p:sp>
         <p:nvSpPr>
-          <p:cNvPr id="59" name="TextBox 58"/>
+          <p:cNvPr id="86" name="TextBox 85"/>
           <p:cNvSpPr txBox="1"/>
           <p:nvPr/>
         </p:nvSpPr>
         <p:spPr>
           <a:xfrm>
-            <a:off x="4011930" y="3948494"/>
-            <a:ext cx="679132" cy="100394"/>
+            <a:off x="3771900" y="4127182"/>
+            <a:ext cx="985838" cy="145732"/>
           </a:xfrm>
           <a:prstGeom prst="rect">
             <a:avLst/>
@@ -12620,18 +13583,18 @@
       </p:sp>
       <p:sp>
         <p:nvSpPr>
-          <p:cNvPr id="60" name="Rounded Rectangle 59"/>
+          <p:cNvPr id="87" name="Rounded Rectangle 86"/>
           <p:cNvSpPr/>
           <p:nvPr/>
         </p:nvSpPr>
         <p:spPr>
           <a:xfrm>
-            <a:off x="3864292" y="3789045"/>
-            <a:ext cx="832676" cy="147638"/>
+            <a:off x="3557588" y="3895725"/>
+            <a:ext cx="1208722" cy="214312"/>
           </a:xfrm>
           <a:prstGeom prst="roundRect">
             <a:avLst>
-              <a:gd name="adj" fmla="val 38709"/>
+              <a:gd name="adj" fmla="val 26666"/>
             </a:avLst>
           </a:prstGeom>
           <a:solidFill>
@@ -12668,18 +13631,18 @@
       </p:sp>
       <p:sp>
         <p:nvSpPr>
-          <p:cNvPr id="61" name="Rounded Rectangle 60"/>
+          <p:cNvPr id="88" name="Rounded Rectangle 87"/>
           <p:cNvSpPr/>
           <p:nvPr/>
         </p:nvSpPr>
         <p:spPr>
           <a:xfrm>
-            <a:off x="4679252" y="3812667"/>
-            <a:ext cx="442912" cy="100394"/>
+            <a:off x="4740593" y="3930015"/>
+            <a:ext cx="642938" cy="145732"/>
           </a:xfrm>
           <a:prstGeom prst="roundRect">
             <a:avLst>
-              <a:gd name="adj" fmla="val 50000"/>
+              <a:gd name="adj" fmla="val 45751"/>
             </a:avLst>
           </a:prstGeom>
           <a:solidFill>
@@ -12716,14 +13679,14 @@
       </p:sp>
       <p:cxnSp>
         <p:nvCxnSpPr>
-          <p:cNvPr id="62" name="Connector 61"/>
+          <p:cNvPr id="89" name="Connector 88"/>
           <p:cNvCxnSpPr/>
           <p:nvPr/>
         </p:nvCxnSpPr>
         <p:spPr>
           <a:xfrm flipV="1">
-            <a:off x="5193030" y="3611880"/>
-            <a:ext cx="0" cy="236220"/>
+            <a:off x="5486400" y="3638550"/>
+            <a:ext cx="0" cy="342900"/>
           </a:xfrm>
           <a:prstGeom prst="line">
             <a:avLst/>
@@ -12738,18 +13701,18 @@
       </p:cxnSp>
       <p:sp>
         <p:nvSpPr>
-          <p:cNvPr id="63" name="Rounded Rectangle 62"/>
+          <p:cNvPr id="90" name="Rounded Rectangle 89"/>
           <p:cNvSpPr/>
           <p:nvPr/>
         </p:nvSpPr>
         <p:spPr>
           <a:xfrm>
-            <a:off x="4782598" y="3741801"/>
-            <a:ext cx="236220" cy="64960"/>
+            <a:off x="4890611" y="3827145"/>
+            <a:ext cx="342900" cy="94298"/>
           </a:xfrm>
           <a:prstGeom prst="roundRect">
             <a:avLst>
-              <a:gd name="adj" fmla="val 43988"/>
+              <a:gd name="adj" fmla="val 30303"/>
             </a:avLst>
           </a:prstGeom>
           <a:solidFill>
@@ -12784,14 +13747,14 @@
       </p:sp>
       <p:cxnSp>
         <p:nvCxnSpPr>
-          <p:cNvPr id="64" name="Connector 63"/>
+          <p:cNvPr id="91" name="Connector 90"/>
           <p:cNvCxnSpPr/>
           <p:nvPr/>
         </p:nvCxnSpPr>
         <p:spPr>
           <a:xfrm>
-            <a:off x="4900708" y="3576447"/>
-            <a:ext cx="0" cy="153543"/>
+            <a:off x="5062061" y="3587115"/>
+            <a:ext cx="0" cy="222885"/>
           </a:xfrm>
           <a:prstGeom prst="line">
             <a:avLst/>
@@ -12806,14 +13769,14 @@
       </p:cxnSp>
       <p:sp>
         <p:nvSpPr>
-          <p:cNvPr id="65" name="TextBox 64"/>
+          <p:cNvPr id="92" name="TextBox 91"/>
           <p:cNvSpPr txBox="1"/>
           <p:nvPr/>
         </p:nvSpPr>
         <p:spPr>
           <a:xfrm>
-            <a:off x="4251103" y="3588258"/>
-            <a:ext cx="605314" cy="100394"/>
+            <a:off x="4119086" y="3604260"/>
+            <a:ext cx="878681" cy="145732"/>
           </a:xfrm>
           <a:prstGeom prst="rect">
             <a:avLst/>
@@ -12853,13 +13816,13 @@
       </p:sp>
       <p:sp>
         <p:nvSpPr>
-          <p:cNvPr id="66" name="TextBox 65"/>
+          <p:cNvPr id="93" name="TextBox 92"/>
           <p:cNvSpPr txBox="1"/>
           <p:nvPr/>
         </p:nvSpPr>
         <p:spPr>
           <a:xfrm>
-            <a:off x="3352800" y="4250055"/>
+            <a:off x="3352800" y="4543425"/>
             <a:ext cx="2381250" cy="381000"/>
           </a:xfrm>
           <a:prstGeom prst="rect">
@@ -12900,7 +13863,7 @@
       </p:sp>
       <p:sp>
         <p:nvSpPr>
-          <p:cNvPr id="67" name="TextBox 66"/>
+          <p:cNvPr id="94" name="TextBox 93"/>
           <p:cNvSpPr txBox="1"/>
           <p:nvPr/>
         </p:nvSpPr>
@@ -12947,7 +13910,7 @@
       </p:sp>
       <p:sp>
         <p:nvSpPr>
-          <p:cNvPr id="68" name="Rounded Rectangle 67"/>
+          <p:cNvPr id="95" name="Rounded Rectangle 94"/>
           <p:cNvSpPr/>
           <p:nvPr/>
         </p:nvSpPr>
@@ -12995,7 +13958,7 @@
       </p:sp>
       <p:sp>
         <p:nvSpPr>
-          <p:cNvPr id="69" name="TextBox 68"/>
+          <p:cNvPr id="96" name="TextBox 95"/>
           <p:cNvSpPr txBox="1"/>
           <p:nvPr/>
         </p:nvSpPr>
@@ -13053,14 +14016,14 @@
       </p:sp>
       <p:sp>
         <p:nvSpPr>
-          <p:cNvPr id="70" name="Rectangle 69"/>
+          <p:cNvPr id="97" name="Rectangle 96"/>
           <p:cNvSpPr/>
           <p:nvPr/>
         </p:nvSpPr>
         <p:spPr>
           <a:xfrm>
-            <a:off x="6510338" y="4054792"/>
-            <a:ext cx="885825" cy="147638"/>
+            <a:off x="6176962" y="4281488"/>
+            <a:ext cx="1285875" cy="214312"/>
           </a:xfrm>
           <a:prstGeom prst="rect">
             <a:avLst/>
@@ -13097,14 +14060,14 @@
       </p:sp>
       <p:sp>
         <p:nvSpPr>
-          <p:cNvPr id="71" name="TextBox 70"/>
+          <p:cNvPr id="98" name="TextBox 97"/>
           <p:cNvSpPr txBox="1"/>
           <p:nvPr/>
         </p:nvSpPr>
         <p:spPr>
           <a:xfrm>
-            <a:off x="6533960" y="4072509"/>
-            <a:ext cx="590550" cy="118110"/>
+            <a:off x="6211252" y="4307205"/>
+            <a:ext cx="857250" cy="171450"/>
           </a:xfrm>
           <a:prstGeom prst="rect">
             <a:avLst/>
@@ -13144,14 +14107,14 @@
       </p:sp>
       <p:sp>
         <p:nvSpPr>
-          <p:cNvPr id="72" name="TextBox 71"/>
+          <p:cNvPr id="99" name="TextBox 98"/>
           <p:cNvSpPr txBox="1"/>
           <p:nvPr/>
         </p:nvSpPr>
         <p:spPr>
           <a:xfrm>
-            <a:off x="6717030" y="3948494"/>
-            <a:ext cx="679132" cy="100394"/>
+            <a:off x="6477000" y="4127182"/>
+            <a:ext cx="985838" cy="145732"/>
           </a:xfrm>
           <a:prstGeom prst="rect">
             <a:avLst/>
@@ -13191,18 +14154,18 @@
       </p:sp>
       <p:sp>
         <p:nvSpPr>
-          <p:cNvPr id="73" name="Rounded Rectangle 72"/>
+          <p:cNvPr id="100" name="Rounded Rectangle 99"/>
           <p:cNvSpPr/>
           <p:nvPr/>
         </p:nvSpPr>
         <p:spPr>
           <a:xfrm>
-            <a:off x="6569392" y="3789045"/>
-            <a:ext cx="832676" cy="147638"/>
+            <a:off x="6262688" y="3895725"/>
+            <a:ext cx="1208722" cy="214312"/>
           </a:xfrm>
           <a:prstGeom prst="roundRect">
             <a:avLst>
-              <a:gd name="adj" fmla="val 38709"/>
+              <a:gd name="adj" fmla="val 26666"/>
             </a:avLst>
           </a:prstGeom>
           <a:solidFill>
@@ -13239,18 +14202,18 @@
       </p:sp>
       <p:sp>
         <p:nvSpPr>
-          <p:cNvPr id="74" name="Rounded Rectangle 73"/>
+          <p:cNvPr id="101" name="Rounded Rectangle 100"/>
           <p:cNvSpPr/>
           <p:nvPr/>
         </p:nvSpPr>
         <p:spPr>
           <a:xfrm>
-            <a:off x="7384352" y="3774281"/>
-            <a:ext cx="212598" cy="177165"/>
+            <a:off x="7445692" y="3874294"/>
+            <a:ext cx="308610" cy="257175"/>
           </a:xfrm>
           <a:prstGeom prst="roundRect">
             <a:avLst>
-              <a:gd name="adj" fmla="val 37634"/>
+              <a:gd name="adj" fmla="val 25925"/>
             </a:avLst>
           </a:prstGeom>
           <a:solidFill>
@@ -13287,14 +14250,14 @@
       </p:sp>
       <p:cxnSp>
         <p:nvCxnSpPr>
-          <p:cNvPr id="75" name="Connector 74"/>
+          <p:cNvPr id="102" name="Connector 101"/>
           <p:cNvCxnSpPr/>
           <p:nvPr/>
         </p:nvCxnSpPr>
         <p:spPr>
           <a:xfrm flipV="1">
-            <a:off x="7673721" y="3611880"/>
-            <a:ext cx="0" cy="236220"/>
+            <a:off x="7865745" y="3638550"/>
+            <a:ext cx="0" cy="342900"/>
           </a:xfrm>
           <a:prstGeom prst="line">
             <a:avLst/>
@@ -13309,14 +14272,14 @@
       </p:cxnSp>
       <p:sp>
         <p:nvSpPr>
-          <p:cNvPr id="76" name="Rectangle 75"/>
+          <p:cNvPr id="103" name="Rectangle 102"/>
           <p:cNvSpPr/>
           <p:nvPr/>
         </p:nvSpPr>
         <p:spPr>
           <a:xfrm>
-            <a:off x="7189470" y="3697510"/>
-            <a:ext cx="590550" cy="64960"/>
+            <a:off x="7162800" y="3762851"/>
+            <a:ext cx="857250" cy="94298"/>
           </a:xfrm>
           <a:prstGeom prst="rect">
             <a:avLst/>
@@ -13353,14 +14316,14 @@
       </p:sp>
       <p:sp>
         <p:nvSpPr>
-          <p:cNvPr id="77" name="TextBox 76"/>
+          <p:cNvPr id="104" name="TextBox 103"/>
           <p:cNvSpPr txBox="1"/>
           <p:nvPr/>
         </p:nvSpPr>
         <p:spPr>
           <a:xfrm>
-            <a:off x="6805612" y="3673888"/>
-            <a:ext cx="369094" cy="88582"/>
+            <a:off x="6605588" y="3728561"/>
+            <a:ext cx="535781" cy="128588"/>
           </a:xfrm>
           <a:prstGeom prst="rect">
             <a:avLst/>
@@ -13400,13 +14363,13 @@
       </p:sp>
       <p:sp>
         <p:nvSpPr>
-          <p:cNvPr id="78" name="TextBox 77"/>
+          <p:cNvPr id="105" name="TextBox 104"/>
           <p:cNvSpPr txBox="1"/>
           <p:nvPr/>
         </p:nvSpPr>
         <p:spPr>
           <a:xfrm>
-            <a:off x="6057900" y="4250055"/>
+            <a:off x="6057900" y="4543425"/>
             <a:ext cx="2381250" cy="381000"/>
           </a:xfrm>
           <a:prstGeom prst="rect">
@@ -13447,7 +14410,7 @@
       </p:sp>
       <p:sp>
         <p:nvSpPr>
-          <p:cNvPr id="79" name="TextBox 78"/>
+          <p:cNvPr id="106" name="TextBox 105"/>
           <p:cNvSpPr txBox="1"/>
           <p:nvPr/>
         </p:nvSpPr>

</xml_diff>

<commit_message>
Add backup slides that list the papers read
Co-Authored-By: Claude Opus 5.5 <noreply@anthropic.com>
</commit_message>
<xml_diff>
--- a/docs/progress/slides/2026-10-08.pptx
+++ b/docs/progress/slides/2026-10-08.pptx
@@ -17,6 +17,8 @@
     <p:sldId id="265" r:id="rId17"/>
     <p:sldId id="266" r:id="rId18"/>
     <p:sldId id="267" r:id="rId19"/>
+    <p:sldId id="268" r:id="rId20"/>
+    <p:sldId id="269" r:id="rId21"/>
   </p:sldIdLst>
   <p:sldSz cx="9144000" cy="5143500" type="screen4x3"/>
   <p:notesSz cx="6858000" cy="9144000"/>
@@ -806,6 +808,169 @@
           <a:p>
             <a:r>
               <a:t>来週は、伸展・屈曲の MVC を確かめて、6 か所で本番データを取ります。</a:t>
+            </a:r>
+          </a:p>
+        </p:txBody>
+      </p:sp>
+      <p:sp>
+        <p:nvSpPr>
+          <p:cNvPr id="4" name="Slide Number Placeholder 3"/>
+          <p:cNvSpPr>
+            <a:spLocks noGrp="1"/>
+          </p:cNvSpPr>
+          <p:nvPr>
+            <p:ph type="sldNum" idx="5" sz="quarter"/>
+          </p:nvPr>
+        </p:nvSpPr>
+        <p:spPr/>
+      </p:sp>
+    </p:spTree>
+  </p:cSld>
+  <p:clrMapOvr>
+    <a:masterClrMapping/>
+  </p:clrMapOvr>
+</p:notes>
+</file>
+
+<file path=ppt/notesSlides/notesSlide13.xml><?xml version="1.0" encoding="utf-8"?>
+<p:notes xmlns:a="http://schemas.openxmlformats.org/drawingml/2006/main" xmlns:p="http://schemas.openxmlformats.org/presentationml/2006/main" xmlns:r="http://schemas.openxmlformats.org/officeDocument/2006/relationships">
+  <p:cSld>
+    <p:spTree>
+      <p:nvGrpSpPr>
+        <p:cNvPr id="1" name=""/>
+        <p:cNvGrpSpPr/>
+        <p:nvPr/>
+      </p:nvGrpSpPr>
+      <p:grpSpPr>
+        <a:xfrm>
+          <a:off x="0" y="0"/>
+          <a:ext cx="0" cy="0"/>
+          <a:chOff x="0" y="0"/>
+          <a:chExt cx="0" cy="0"/>
+        </a:xfrm>
+      </p:grpSpPr>
+      <p:sp>
+        <p:nvSpPr>
+          <p:cNvPr id="2" name="Slide Image Placeholder 1"/>
+          <p:cNvSpPr>
+            <a:spLocks noGrp="1"/>
+          </p:cNvSpPr>
+          <p:nvPr>
+            <p:ph type="sldImg" idx="2"/>
+          </p:nvPr>
+        </p:nvSpPr>
+        <p:spPr/>
+      </p:sp>
+      <p:sp>
+        <p:nvSpPr>
+          <p:cNvPr id="3" name="Notes Placeholder 2"/>
+          <p:cNvSpPr>
+            <a:spLocks noGrp="1"/>
+          </p:cNvSpPr>
+          <p:nvPr>
+            <p:ph type="body" idx="3" sz="quarter"/>
+          </p:nvPr>
+        </p:nvSpPr>
+        <p:spPr/>
+        <p:txBody>
+          <a:bodyPr/>
+          <a:lstStyle/>
+          <a:p>
+            <a:r>
+              <a:t>（予備）手持ちの 13 本です。右の列は、MVC をどう扱っていたかです。</a:t>
+            </a:r>
+          </a:p>
+          <a:p/>
+          <a:p>
+            <a:r>
+              <a:t>筋ごとの手順まで書いてあったのは Lacelle だけで、G. N. Forman の 3 本は手順を別の論文に任せていました。Wang は「解剖ガイド（Perotto 2011）に従った」とだけ書いています。残りの 8 本は MVC を使っていません（別の正規化か、EMG を測っていない）。</a:t>
+            </a:r>
+          </a:p>
+        </p:txBody>
+      </p:sp>
+      <p:sp>
+        <p:nvSpPr>
+          <p:cNvPr id="4" name="Slide Number Placeholder 3"/>
+          <p:cNvSpPr>
+            <a:spLocks noGrp="1"/>
+          </p:cNvSpPr>
+          <p:nvPr>
+            <p:ph type="sldNum" idx="5" sz="quarter"/>
+          </p:nvPr>
+        </p:nvSpPr>
+        <p:spPr/>
+      </p:sp>
+    </p:spTree>
+  </p:cSld>
+  <p:clrMapOvr>
+    <a:masterClrMapping/>
+  </p:clrMapOvr>
+</p:notes>
+</file>
+
+<file path=ppt/notesSlides/notesSlide14.xml><?xml version="1.0" encoding="utf-8"?>
+<p:notes xmlns:a="http://schemas.openxmlformats.org/drawingml/2006/main" xmlns:p="http://schemas.openxmlformats.org/presentationml/2006/main" xmlns:r="http://schemas.openxmlformats.org/officeDocument/2006/relationships">
+  <p:cSld>
+    <p:spTree>
+      <p:nvGrpSpPr>
+        <p:cNvPr id="1" name=""/>
+        <p:cNvGrpSpPr/>
+        <p:nvPr/>
+      </p:nvGrpSpPr>
+      <p:grpSpPr>
+        <a:xfrm>
+          <a:off x="0" y="0"/>
+          <a:ext cx="0" cy="0"/>
+          <a:chOff x="0" y="0"/>
+          <a:chExt cx="0" cy="0"/>
+        </a:xfrm>
+      </p:grpSpPr>
+      <p:sp>
+        <p:nvSpPr>
+          <p:cNvPr id="2" name="Slide Image Placeholder 1"/>
+          <p:cNvSpPr>
+            <a:spLocks noGrp="1"/>
+          </p:cNvSpPr>
+          <p:nvPr>
+            <p:ph type="sldImg" idx="2"/>
+          </p:nvPr>
+        </p:nvSpPr>
+        <p:spPr/>
+      </p:sp>
+      <p:sp>
+        <p:nvSpPr>
+          <p:cNvPr id="3" name="Notes Placeholder 2"/>
+          <p:cNvSpPr>
+            <a:spLocks noGrp="1"/>
+          </p:cNvSpPr>
+          <p:nvPr>
+            <p:ph type="body" idx="3" sz="quarter"/>
+          </p:nvPr>
+        </p:nvSpPr>
+        <p:spPr/>
+        <p:txBody>
+          <a:bodyPr/>
+          <a:lstStyle/>
+          <a:p>
+            <a:r>
+              <a:t>（予備）手順を任せていた論文の引用をたどって読んだものです。Forman 2025 → Forman 2020</a:t>
+            </a:r>
+          </a:p>
+          <a:p>
+            <a:r>
+              <a:t>Sci Rep→ Forman 2019 の Table 1、の順にたどりました。</a:t>
+            </a:r>
+          </a:p>
+          <a:p/>
+          <a:p>
+            <a:r>
+              <a:t>Forman 2019 は有料でしたが、著者 D. A. Forman の博論（2020、公開）の 3 章が同じ論文で、表 3.1 に同じ表があります。</a:t>
+            </a:r>
+          </a:p>
+          <a:p/>
+          <a:p>
+            <a:r>
+              <a:t>Forman は 2 人います。G. N. Forman（Brock University）と D. A. Forman（博論は Ontario Tech University）です。</a:t>
             </a:r>
           </a:p>
         </p:txBody>
@@ -6799,6 +6964,4131 @@
           </a:p>
         </p:txBody>
       </p:sp>
+    </p:spTree>
+  </p:cSld>
+  <p:clrMapOvr>
+    <a:masterClrMapping/>
+  </p:clrMapOvr>
+</p:sld>
+</file>
+
+<file path=ppt/slides/slide13.xml><?xml version="1.0" encoding="utf-8"?>
+<p:sld xmlns:a="http://schemas.openxmlformats.org/drawingml/2006/main" xmlns:p="http://schemas.openxmlformats.org/presentationml/2006/main" xmlns:r="http://schemas.openxmlformats.org/officeDocument/2006/relationships">
+  <p:cSld>
+    <p:spTree>
+      <p:nvGrpSpPr>
+        <p:cNvPr id="1" name=""/>
+        <p:cNvGrpSpPr/>
+        <p:nvPr/>
+      </p:nvGrpSpPr>
+      <p:grpSpPr/>
+      <p:sp>
+        <p:nvSpPr>
+          <p:cNvPr id="2" name="TextBox 1"/>
+          <p:cNvSpPr txBox="1"/>
+          <p:nvPr/>
+        </p:nvSpPr>
+        <p:spPr>
+          <a:xfrm>
+            <a:off x="552450" y="381000"/>
+            <a:ext cx="7143750" cy="476250"/>
+          </a:xfrm>
+          <a:prstGeom prst="rect">
+            <a:avLst/>
+          </a:prstGeom>
+          <a:noFill/>
+        </p:spPr>
+        <p:txBody>
+          <a:bodyPr wrap="square" tIns="0" rIns="0" bIns="0" lIns="0">
+            <a:spAutoFit/>
+          </a:bodyPr>
+          <a:lstStyle/>
+          <a:p>
+            <a:pPr algn="l">
+              <a:lnSpc>
+                <a:spcPct val="120000"/>
+              </a:lnSpc>
+              <a:spcBef>
+                <a:spcPts val="0"/>
+              </a:spcBef>
+              <a:spcAft>
+                <a:spcPts val="0"/>
+              </a:spcAft>
+            </a:pPr>
+            <a:r>
+              <a:rPr sz="3000" b="1">
+                <a:solidFill>
+                  <a:srgbClr val="1A1A1A"/>
+                </a:solidFill>
+                <a:latin typeface="Meiryo"/>
+                <a:ea typeface="Meiryo"/>
+                <a:cs typeface="Meiryo"/>
+              </a:rPr>
+              <a:t>予備：読んだ文献（手持ちの 13 本）</a:t>
+            </a:r>
+          </a:p>
+        </p:txBody>
+      </p:sp>
+      <p:sp>
+        <p:nvSpPr>
+          <p:cNvPr id="3" name="TextBox 2"/>
+          <p:cNvSpPr txBox="1"/>
+          <p:nvPr/>
+        </p:nvSpPr>
+        <p:spPr>
+          <a:xfrm>
+            <a:off x="7953375" y="476250"/>
+            <a:ext cx="581025" cy="190500"/>
+          </a:xfrm>
+          <a:prstGeom prst="rect">
+            <a:avLst/>
+          </a:prstGeom>
+          <a:noFill/>
+        </p:spPr>
+        <p:txBody>
+          <a:bodyPr wrap="square" tIns="0" rIns="0" bIns="0" lIns="0">
+            <a:spAutoFit/>
+          </a:bodyPr>
+          <a:lstStyle/>
+          <a:p>
+            <a:pPr algn="r">
+              <a:lnSpc>
+                <a:spcPct val="120000"/>
+              </a:lnSpc>
+              <a:spcBef>
+                <a:spcPts val="0"/>
+              </a:spcBef>
+              <a:spcAft>
+                <a:spcPts val="0"/>
+              </a:spcAft>
+            </a:pPr>
+            <a:r>
+              <a:rPr sz="1200" b="0">
+                <a:solidFill>
+                  <a:srgbClr val="6B6B6B"/>
+                </a:solidFill>
+                <a:latin typeface="Meiryo"/>
+                <a:ea typeface="Meiryo"/>
+                <a:cs typeface="Meiryo"/>
+              </a:rPr>
+              <a:t>12</a:t>
+            </a:r>
+          </a:p>
+        </p:txBody>
+      </p:sp>
+      <p:sp>
+        <p:nvSpPr>
+          <p:cNvPr id="4" name="TextBox 3"/>
+          <p:cNvSpPr txBox="1"/>
+          <p:nvPr/>
+        </p:nvSpPr>
+        <p:spPr>
+          <a:xfrm>
+            <a:off x="552450" y="981075"/>
+            <a:ext cx="1571625" cy="171450"/>
+          </a:xfrm>
+          <a:prstGeom prst="rect">
+            <a:avLst/>
+          </a:prstGeom>
+          <a:noFill/>
+        </p:spPr>
+        <p:txBody>
+          <a:bodyPr wrap="square" tIns="0" rIns="0" bIns="0" lIns="0">
+            <a:spAutoFit/>
+          </a:bodyPr>
+          <a:lstStyle/>
+          <a:p>
+            <a:pPr algn="l">
+              <a:lnSpc>
+                <a:spcPct val="120000"/>
+              </a:lnSpc>
+              <a:spcBef>
+                <a:spcPts val="0"/>
+              </a:spcBef>
+              <a:spcAft>
+                <a:spcPts val="0"/>
+              </a:spcAft>
+            </a:pPr>
+            <a:r>
+              <a:rPr sz="825" b="1">
+                <a:solidFill>
+                  <a:srgbClr val="6B6B6B"/>
+                </a:solidFill>
+                <a:latin typeface="Meiryo"/>
+                <a:ea typeface="Meiryo"/>
+                <a:cs typeface="Meiryo"/>
+              </a:rPr>
+              <a:t>著者</a:t>
+            </a:r>
+          </a:p>
+        </p:txBody>
+      </p:sp>
+      <p:sp>
+        <p:nvSpPr>
+          <p:cNvPr id="5" name="TextBox 4"/>
+          <p:cNvSpPr txBox="1"/>
+          <p:nvPr/>
+        </p:nvSpPr>
+        <p:spPr>
+          <a:xfrm>
+            <a:off x="2152650" y="981075"/>
+            <a:ext cx="381000" cy="171450"/>
+          </a:xfrm>
+          <a:prstGeom prst="rect">
+            <a:avLst/>
+          </a:prstGeom>
+          <a:noFill/>
+        </p:spPr>
+        <p:txBody>
+          <a:bodyPr wrap="square" tIns="0" rIns="0" bIns="0" lIns="0">
+            <a:spAutoFit/>
+          </a:bodyPr>
+          <a:lstStyle/>
+          <a:p>
+            <a:pPr algn="l">
+              <a:lnSpc>
+                <a:spcPct val="120000"/>
+              </a:lnSpc>
+              <a:spcBef>
+                <a:spcPts val="0"/>
+              </a:spcBef>
+              <a:spcAft>
+                <a:spcPts val="0"/>
+              </a:spcAft>
+            </a:pPr>
+            <a:r>
+              <a:rPr sz="825" b="1">
+                <a:solidFill>
+                  <a:srgbClr val="6B6B6B"/>
+                </a:solidFill>
+                <a:latin typeface="Meiryo"/>
+                <a:ea typeface="Meiryo"/>
+                <a:cs typeface="Meiryo"/>
+              </a:rPr>
+              <a:t>年</a:t>
+            </a:r>
+          </a:p>
+        </p:txBody>
+      </p:sp>
+      <p:sp>
+        <p:nvSpPr>
+          <p:cNvPr id="6" name="TextBox 5"/>
+          <p:cNvSpPr txBox="1"/>
+          <p:nvPr/>
+        </p:nvSpPr>
+        <p:spPr>
+          <a:xfrm>
+            <a:off x="2571750" y="981075"/>
+            <a:ext cx="4762500" cy="171450"/>
+          </a:xfrm>
+          <a:prstGeom prst="rect">
+            <a:avLst/>
+          </a:prstGeom>
+          <a:noFill/>
+        </p:spPr>
+        <p:txBody>
+          <a:bodyPr wrap="square" tIns="0" rIns="0" bIns="0" lIns="0">
+            <a:spAutoFit/>
+          </a:bodyPr>
+          <a:lstStyle/>
+          <a:p>
+            <a:pPr algn="l">
+              <a:lnSpc>
+                <a:spcPct val="120000"/>
+              </a:lnSpc>
+              <a:spcBef>
+                <a:spcPts val="0"/>
+              </a:spcBef>
+              <a:spcAft>
+                <a:spcPts val="0"/>
+              </a:spcAft>
+            </a:pPr>
+            <a:r>
+              <a:rPr sz="825" b="1">
+                <a:solidFill>
+                  <a:srgbClr val="6B6B6B"/>
+                </a:solidFill>
+                <a:latin typeface="Meiryo"/>
+                <a:ea typeface="Meiryo"/>
+                <a:cs typeface="Meiryo"/>
+              </a:rPr>
+              <a:t>タイトル</a:t>
+            </a:r>
+          </a:p>
+        </p:txBody>
+      </p:sp>
+      <p:sp>
+        <p:nvSpPr>
+          <p:cNvPr id="7" name="TextBox 6"/>
+          <p:cNvSpPr txBox="1"/>
+          <p:nvPr/>
+        </p:nvSpPr>
+        <p:spPr>
+          <a:xfrm>
+            <a:off x="7410450" y="981075"/>
+            <a:ext cx="1123950" cy="171450"/>
+          </a:xfrm>
+          <a:prstGeom prst="rect">
+            <a:avLst/>
+          </a:prstGeom>
+          <a:noFill/>
+        </p:spPr>
+        <p:txBody>
+          <a:bodyPr wrap="square" tIns="0" rIns="0" bIns="0" lIns="0">
+            <a:spAutoFit/>
+          </a:bodyPr>
+          <a:lstStyle/>
+          <a:p>
+            <a:pPr algn="l">
+              <a:lnSpc>
+                <a:spcPct val="120000"/>
+              </a:lnSpc>
+              <a:spcBef>
+                <a:spcPts val="0"/>
+              </a:spcBef>
+              <a:spcAft>
+                <a:spcPts val="0"/>
+              </a:spcAft>
+            </a:pPr>
+            <a:r>
+              <a:rPr sz="825" b="1">
+                <a:solidFill>
+                  <a:srgbClr val="6B6B6B"/>
+                </a:solidFill>
+                <a:latin typeface="Meiryo"/>
+                <a:ea typeface="Meiryo"/>
+                <a:cs typeface="Meiryo"/>
+              </a:rPr>
+              <a:t>MVC の扱い</a:t>
+            </a:r>
+          </a:p>
+        </p:txBody>
+      </p:sp>
+      <p:cxnSp>
+        <p:nvCxnSpPr>
+          <p:cNvPr id="8" name="Connector 7"/>
+          <p:cNvCxnSpPr/>
+          <p:nvPr/>
+        </p:nvCxnSpPr>
+        <p:spPr>
+          <a:xfrm>
+            <a:off x="552450" y="1190625"/>
+            <a:ext cx="7981950" cy="0"/>
+          </a:xfrm>
+          <a:prstGeom prst="line">
+            <a:avLst/>
+          </a:prstGeom>
+          <a:ln w="7143">
+            <a:solidFill>
+              <a:srgbClr val="DDDDDD"/>
+            </a:solidFill>
+          </a:ln>
+        </p:spPr>
+      </p:cxnSp>
+      <p:sp>
+        <p:nvSpPr>
+          <p:cNvPr id="9" name="TextBox 8"/>
+          <p:cNvSpPr txBox="1"/>
+          <p:nvPr/>
+        </p:nvSpPr>
+        <p:spPr>
+          <a:xfrm>
+            <a:off x="552450" y="1190625"/>
+            <a:ext cx="1514475" cy="285750"/>
+          </a:xfrm>
+          <a:prstGeom prst="rect">
+            <a:avLst/>
+          </a:prstGeom>
+          <a:noFill/>
+        </p:spPr>
+        <p:txBody>
+          <a:bodyPr wrap="square" tIns="0" rIns="0" bIns="0" lIns="0" anchor="ctr">
+            <a:spAutoFit/>
+          </a:bodyPr>
+          <a:lstStyle/>
+          <a:p>
+            <a:pPr algn="l">
+              <a:lnSpc>
+                <a:spcPct val="105000"/>
+              </a:lnSpc>
+              <a:spcBef>
+                <a:spcPts val="0"/>
+              </a:spcBef>
+              <a:spcAft>
+                <a:spcPts val="0"/>
+              </a:spcAft>
+            </a:pPr>
+            <a:r>
+              <a:rPr sz="750" b="0">
+                <a:solidFill>
+                  <a:srgbClr val="1A1A1A"/>
+                </a:solidFill>
+                <a:latin typeface="Meiryo"/>
+                <a:ea typeface="Meiryo"/>
+                <a:cs typeface="Meiryo"/>
+              </a:rPr>
+              <a:t>Lacelle</a:t>
+            </a:r>
+          </a:p>
+        </p:txBody>
+      </p:sp>
+      <p:sp>
+        <p:nvSpPr>
+          <p:cNvPr id="10" name="TextBox 9"/>
+          <p:cNvSpPr txBox="1"/>
+          <p:nvPr/>
+        </p:nvSpPr>
+        <p:spPr>
+          <a:xfrm>
+            <a:off x="2152650" y="1190625"/>
+            <a:ext cx="323850" cy="285750"/>
+          </a:xfrm>
+          <a:prstGeom prst="rect">
+            <a:avLst/>
+          </a:prstGeom>
+          <a:noFill/>
+        </p:spPr>
+        <p:txBody>
+          <a:bodyPr wrap="square" tIns="0" rIns="0" bIns="0" lIns="0" anchor="ctr">
+            <a:spAutoFit/>
+          </a:bodyPr>
+          <a:lstStyle/>
+          <a:p>
+            <a:pPr algn="l">
+              <a:lnSpc>
+                <a:spcPct val="105000"/>
+              </a:lnSpc>
+              <a:spcBef>
+                <a:spcPts val="0"/>
+              </a:spcBef>
+              <a:spcAft>
+                <a:spcPts val="0"/>
+              </a:spcAft>
+            </a:pPr>
+            <a:r>
+              <a:rPr sz="750" b="0">
+                <a:solidFill>
+                  <a:srgbClr val="1A1A1A"/>
+                </a:solidFill>
+                <a:latin typeface="Meiryo"/>
+                <a:ea typeface="Meiryo"/>
+                <a:cs typeface="Meiryo"/>
+              </a:rPr>
+              <a:t>2025</a:t>
+            </a:r>
+          </a:p>
+        </p:txBody>
+      </p:sp>
+      <p:sp>
+        <p:nvSpPr>
+          <p:cNvPr id="11" name="TextBox 10"/>
+          <p:cNvSpPr txBox="1"/>
+          <p:nvPr/>
+        </p:nvSpPr>
+        <p:spPr>
+          <a:xfrm>
+            <a:off x="2571750" y="1190625"/>
+            <a:ext cx="4705350" cy="285750"/>
+          </a:xfrm>
+          <a:prstGeom prst="rect">
+            <a:avLst/>
+          </a:prstGeom>
+          <a:noFill/>
+        </p:spPr>
+        <p:txBody>
+          <a:bodyPr wrap="square" tIns="0" rIns="0" bIns="0" lIns="0" anchor="ctr">
+            <a:spAutoFit/>
+          </a:bodyPr>
+          <a:lstStyle/>
+          <a:p>
+            <a:pPr algn="l">
+              <a:lnSpc>
+                <a:spcPct val="105000"/>
+              </a:lnSpc>
+              <a:spcBef>
+                <a:spcPts val="0"/>
+              </a:spcBef>
+              <a:spcAft>
+                <a:spcPts val="0"/>
+              </a:spcAft>
+            </a:pPr>
+            <a:r>
+              <a:rPr sz="750" b="0">
+                <a:solidFill>
+                  <a:srgbClr val="1A1A1A"/>
+                </a:solidFill>
+                <a:latin typeface="Meiryo"/>
+                <a:ea typeface="Meiryo"/>
+                <a:cs typeface="Meiryo"/>
+              </a:rPr>
+              <a:t>Vertical computer mice and gaming: effect of mouse orientation on muscle activation and performance（修士論文）</a:t>
+            </a:r>
+          </a:p>
+        </p:txBody>
+      </p:sp>
+      <p:sp>
+        <p:nvSpPr>
+          <p:cNvPr id="12" name="TextBox 11"/>
+          <p:cNvSpPr txBox="1"/>
+          <p:nvPr/>
+        </p:nvSpPr>
+        <p:spPr>
+          <a:xfrm>
+            <a:off x="7410450" y="1190625"/>
+            <a:ext cx="1066800" cy="285750"/>
+          </a:xfrm>
+          <a:prstGeom prst="rect">
+            <a:avLst/>
+          </a:prstGeom>
+          <a:noFill/>
+        </p:spPr>
+        <p:txBody>
+          <a:bodyPr wrap="square" tIns="0" rIns="0" bIns="0" lIns="0" anchor="ctr">
+            <a:spAutoFit/>
+          </a:bodyPr>
+          <a:lstStyle/>
+          <a:p>
+            <a:pPr algn="l">
+              <a:lnSpc>
+                <a:spcPct val="105000"/>
+              </a:lnSpc>
+              <a:spcBef>
+                <a:spcPts val="0"/>
+              </a:spcBef>
+              <a:spcAft>
+                <a:spcPts val="0"/>
+              </a:spcAft>
+            </a:pPr>
+            <a:r>
+              <a:rPr sz="750" b="0">
+                <a:solidFill>
+                  <a:srgbClr val="1A1A1A"/>
+                </a:solidFill>
+                <a:latin typeface="Meiryo"/>
+                <a:ea typeface="Meiryo"/>
+                <a:cs typeface="Meiryo"/>
+              </a:rPr>
+              <a:t>筋ごとの手順</a:t>
+            </a:r>
+          </a:p>
+        </p:txBody>
+      </p:sp>
+      <p:cxnSp>
+        <p:nvCxnSpPr>
+          <p:cNvPr id="13" name="Connector 12"/>
+          <p:cNvCxnSpPr/>
+          <p:nvPr/>
+        </p:nvCxnSpPr>
+        <p:spPr>
+          <a:xfrm>
+            <a:off x="552450" y="1476375"/>
+            <a:ext cx="7981950" cy="0"/>
+          </a:xfrm>
+          <a:prstGeom prst="line">
+            <a:avLst/>
+          </a:prstGeom>
+          <a:ln w="7143">
+            <a:solidFill>
+              <a:srgbClr val="DDDDDD"/>
+            </a:solidFill>
+          </a:ln>
+        </p:spPr>
+      </p:cxnSp>
+      <p:sp>
+        <p:nvSpPr>
+          <p:cNvPr id="14" name="TextBox 13"/>
+          <p:cNvSpPr txBox="1"/>
+          <p:nvPr/>
+        </p:nvSpPr>
+        <p:spPr>
+          <a:xfrm>
+            <a:off x="552450" y="1476375"/>
+            <a:ext cx="1514475" cy="285750"/>
+          </a:xfrm>
+          <a:prstGeom prst="rect">
+            <a:avLst/>
+          </a:prstGeom>
+          <a:noFill/>
+        </p:spPr>
+        <p:txBody>
+          <a:bodyPr wrap="square" tIns="0" rIns="0" bIns="0" lIns="0" anchor="ctr">
+            <a:spAutoFit/>
+          </a:bodyPr>
+          <a:lstStyle/>
+          <a:p>
+            <a:pPr algn="l">
+              <a:lnSpc>
+                <a:spcPct val="105000"/>
+              </a:lnSpc>
+              <a:spcBef>
+                <a:spcPts val="0"/>
+              </a:spcBef>
+              <a:spcAft>
+                <a:spcPts val="0"/>
+              </a:spcAft>
+            </a:pPr>
+            <a:r>
+              <a:rPr sz="750" b="0">
+                <a:solidFill>
+                  <a:srgbClr val="1A1A1A"/>
+                </a:solidFill>
+                <a:latin typeface="Meiryo"/>
+                <a:ea typeface="Meiryo"/>
+                <a:cs typeface="Meiryo"/>
+              </a:rPr>
+              <a:t>Forman, G. N.</a:t>
+            </a:r>
+          </a:p>
+        </p:txBody>
+      </p:sp>
+      <p:sp>
+        <p:nvSpPr>
+          <p:cNvPr id="15" name="TextBox 14"/>
+          <p:cNvSpPr txBox="1"/>
+          <p:nvPr/>
+        </p:nvSpPr>
+        <p:spPr>
+          <a:xfrm>
+            <a:off x="2152650" y="1476375"/>
+            <a:ext cx="323850" cy="285750"/>
+          </a:xfrm>
+          <a:prstGeom prst="rect">
+            <a:avLst/>
+          </a:prstGeom>
+          <a:noFill/>
+        </p:spPr>
+        <p:txBody>
+          <a:bodyPr wrap="square" tIns="0" rIns="0" bIns="0" lIns="0" anchor="ctr">
+            <a:spAutoFit/>
+          </a:bodyPr>
+          <a:lstStyle/>
+          <a:p>
+            <a:pPr algn="l">
+              <a:lnSpc>
+                <a:spcPct val="105000"/>
+              </a:lnSpc>
+              <a:spcBef>
+                <a:spcPts val="0"/>
+              </a:spcBef>
+              <a:spcAft>
+                <a:spcPts val="0"/>
+              </a:spcAft>
+            </a:pPr>
+            <a:r>
+              <a:rPr sz="750" b="0">
+                <a:solidFill>
+                  <a:srgbClr val="1A1A1A"/>
+                </a:solidFill>
+                <a:latin typeface="Meiryo"/>
+                <a:ea typeface="Meiryo"/>
+                <a:cs typeface="Meiryo"/>
+              </a:rPr>
+              <a:t>2023</a:t>
+            </a:r>
+          </a:p>
+        </p:txBody>
+      </p:sp>
+      <p:sp>
+        <p:nvSpPr>
+          <p:cNvPr id="16" name="TextBox 15"/>
+          <p:cNvSpPr txBox="1"/>
+          <p:nvPr/>
+        </p:nvSpPr>
+        <p:spPr>
+          <a:xfrm>
+            <a:off x="2571750" y="1476375"/>
+            <a:ext cx="4705350" cy="285750"/>
+          </a:xfrm>
+          <a:prstGeom prst="rect">
+            <a:avLst/>
+          </a:prstGeom>
+          <a:noFill/>
+        </p:spPr>
+        <p:txBody>
+          <a:bodyPr wrap="square" tIns="0" rIns="0" bIns="0" lIns="0" anchor="ctr">
+            <a:spAutoFit/>
+          </a:bodyPr>
+          <a:lstStyle/>
+          <a:p>
+            <a:pPr algn="l">
+              <a:lnSpc>
+                <a:spcPct val="105000"/>
+              </a:lnSpc>
+              <a:spcBef>
+                <a:spcPts val="0"/>
+              </a:spcBef>
+              <a:spcAft>
+                <a:spcPts val="0"/>
+              </a:spcAft>
+            </a:pPr>
+            <a:r>
+              <a:rPr sz="750" b="0">
+                <a:solidFill>
+                  <a:srgbClr val="1A1A1A"/>
+                </a:solidFill>
+                <a:latin typeface="Meiryo"/>
+                <a:ea typeface="Meiryo"/>
+                <a:cs typeface="Meiryo"/>
+              </a:rPr>
+              <a:t>On the Physical Demands of Gaming: Quantifying Pain, Muscle Activity, Kinematics, and Performance Changes（博士論文）</a:t>
+            </a:r>
+          </a:p>
+        </p:txBody>
+      </p:sp>
+      <p:sp>
+        <p:nvSpPr>
+          <p:cNvPr id="17" name="TextBox 16"/>
+          <p:cNvSpPr txBox="1"/>
+          <p:nvPr/>
+        </p:nvSpPr>
+        <p:spPr>
+          <a:xfrm>
+            <a:off x="7410450" y="1476375"/>
+            <a:ext cx="1066800" cy="285750"/>
+          </a:xfrm>
+          <a:prstGeom prst="rect">
+            <a:avLst/>
+          </a:prstGeom>
+          <a:noFill/>
+        </p:spPr>
+        <p:txBody>
+          <a:bodyPr wrap="square" tIns="0" rIns="0" bIns="0" lIns="0" anchor="ctr">
+            <a:spAutoFit/>
+          </a:bodyPr>
+          <a:lstStyle/>
+          <a:p>
+            <a:pPr algn="l">
+              <a:lnSpc>
+                <a:spcPct val="105000"/>
+              </a:lnSpc>
+              <a:spcBef>
+                <a:spcPts val="0"/>
+              </a:spcBef>
+              <a:spcAft>
+                <a:spcPts val="0"/>
+              </a:spcAft>
+            </a:pPr>
+            <a:r>
+              <a:rPr sz="750" b="0">
+                <a:solidFill>
+                  <a:srgbClr val="1A1A1A"/>
+                </a:solidFill>
+                <a:latin typeface="Meiryo"/>
+                <a:ea typeface="Meiryo"/>
+                <a:cs typeface="Meiryo"/>
+              </a:rPr>
+              <a:t>別の論文へ</a:t>
+            </a:r>
+          </a:p>
+        </p:txBody>
+      </p:sp>
+      <p:cxnSp>
+        <p:nvCxnSpPr>
+          <p:cNvPr id="18" name="Connector 17"/>
+          <p:cNvCxnSpPr/>
+          <p:nvPr/>
+        </p:nvCxnSpPr>
+        <p:spPr>
+          <a:xfrm>
+            <a:off x="552450" y="1762125"/>
+            <a:ext cx="7981950" cy="0"/>
+          </a:xfrm>
+          <a:prstGeom prst="line">
+            <a:avLst/>
+          </a:prstGeom>
+          <a:ln w="7143">
+            <a:solidFill>
+              <a:srgbClr val="DDDDDD"/>
+            </a:solidFill>
+          </a:ln>
+        </p:spPr>
+      </p:cxnSp>
+      <p:sp>
+        <p:nvSpPr>
+          <p:cNvPr id="19" name="TextBox 18"/>
+          <p:cNvSpPr txBox="1"/>
+          <p:nvPr/>
+        </p:nvSpPr>
+        <p:spPr>
+          <a:xfrm>
+            <a:off x="552450" y="1762125"/>
+            <a:ext cx="1514475" cy="285750"/>
+          </a:xfrm>
+          <a:prstGeom prst="rect">
+            <a:avLst/>
+          </a:prstGeom>
+          <a:noFill/>
+        </p:spPr>
+        <p:txBody>
+          <a:bodyPr wrap="square" tIns="0" rIns="0" bIns="0" lIns="0" anchor="ctr">
+            <a:spAutoFit/>
+          </a:bodyPr>
+          <a:lstStyle/>
+          <a:p>
+            <a:pPr algn="l">
+              <a:lnSpc>
+                <a:spcPct val="105000"/>
+              </a:lnSpc>
+              <a:spcBef>
+                <a:spcPts val="0"/>
+              </a:spcBef>
+              <a:spcAft>
+                <a:spcPts val="0"/>
+              </a:spcAft>
+            </a:pPr>
+            <a:r>
+              <a:rPr sz="750" b="0">
+                <a:solidFill>
+                  <a:srgbClr val="1A1A1A"/>
+                </a:solidFill>
+                <a:latin typeface="Meiryo"/>
+                <a:ea typeface="Meiryo"/>
+                <a:cs typeface="Meiryo"/>
+              </a:rPr>
+              <a:t>Forman, G. N. ほか</a:t>
+            </a:r>
+          </a:p>
+        </p:txBody>
+      </p:sp>
+      <p:sp>
+        <p:nvSpPr>
+          <p:cNvPr id="20" name="TextBox 19"/>
+          <p:cNvSpPr txBox="1"/>
+          <p:nvPr/>
+        </p:nvSpPr>
+        <p:spPr>
+          <a:xfrm>
+            <a:off x="2152650" y="1762125"/>
+            <a:ext cx="323850" cy="285750"/>
+          </a:xfrm>
+          <a:prstGeom prst="rect">
+            <a:avLst/>
+          </a:prstGeom>
+          <a:noFill/>
+        </p:spPr>
+        <p:txBody>
+          <a:bodyPr wrap="square" tIns="0" rIns="0" bIns="0" lIns="0" anchor="ctr">
+            <a:spAutoFit/>
+          </a:bodyPr>
+          <a:lstStyle/>
+          <a:p>
+            <a:pPr algn="l">
+              <a:lnSpc>
+                <a:spcPct val="105000"/>
+              </a:lnSpc>
+              <a:spcBef>
+                <a:spcPts val="0"/>
+              </a:spcBef>
+              <a:spcAft>
+                <a:spcPts val="0"/>
+              </a:spcAft>
+            </a:pPr>
+            <a:r>
+              <a:rPr sz="750" b="0">
+                <a:solidFill>
+                  <a:srgbClr val="1A1A1A"/>
+                </a:solidFill>
+                <a:latin typeface="Meiryo"/>
+                <a:ea typeface="Meiryo"/>
+                <a:cs typeface="Meiryo"/>
+              </a:rPr>
+              <a:t>2025</a:t>
+            </a:r>
+          </a:p>
+        </p:txBody>
+      </p:sp>
+      <p:sp>
+        <p:nvSpPr>
+          <p:cNvPr id="21" name="TextBox 20"/>
+          <p:cNvSpPr txBox="1"/>
+          <p:nvPr/>
+        </p:nvSpPr>
+        <p:spPr>
+          <a:xfrm>
+            <a:off x="2571750" y="1762125"/>
+            <a:ext cx="4705350" cy="285750"/>
+          </a:xfrm>
+          <a:prstGeom prst="rect">
+            <a:avLst/>
+          </a:prstGeom>
+          <a:noFill/>
+        </p:spPr>
+        <p:txBody>
+          <a:bodyPr wrap="square" tIns="0" rIns="0" bIns="0" lIns="0" anchor="ctr">
+            <a:spAutoFit/>
+          </a:bodyPr>
+          <a:lstStyle/>
+          <a:p>
+            <a:pPr algn="l">
+              <a:lnSpc>
+                <a:spcPct val="105000"/>
+              </a:lnSpc>
+              <a:spcBef>
+                <a:spcPts val="0"/>
+              </a:spcBef>
+              <a:spcAft>
+                <a:spcPts val="0"/>
+              </a:spcAft>
+            </a:pPr>
+            <a:r>
+              <a:rPr sz="750" b="0">
+                <a:solidFill>
+                  <a:srgbClr val="1A1A1A"/>
+                </a:solidFill>
+                <a:latin typeface="Meiryo"/>
+                <a:ea typeface="Meiryo"/>
+                <a:cs typeface="Meiryo"/>
+              </a:rPr>
+              <a:t>Impact of repetitive mouse aiming on muscle fatigue and fine motor performance of the distal upper limb</a:t>
+            </a:r>
+          </a:p>
+        </p:txBody>
+      </p:sp>
+      <p:sp>
+        <p:nvSpPr>
+          <p:cNvPr id="22" name="TextBox 21"/>
+          <p:cNvSpPr txBox="1"/>
+          <p:nvPr/>
+        </p:nvSpPr>
+        <p:spPr>
+          <a:xfrm>
+            <a:off x="7410450" y="1762125"/>
+            <a:ext cx="1066800" cy="285750"/>
+          </a:xfrm>
+          <a:prstGeom prst="rect">
+            <a:avLst/>
+          </a:prstGeom>
+          <a:noFill/>
+        </p:spPr>
+        <p:txBody>
+          <a:bodyPr wrap="square" tIns="0" rIns="0" bIns="0" lIns="0" anchor="ctr">
+            <a:spAutoFit/>
+          </a:bodyPr>
+          <a:lstStyle/>
+          <a:p>
+            <a:pPr algn="l">
+              <a:lnSpc>
+                <a:spcPct val="105000"/>
+              </a:lnSpc>
+              <a:spcBef>
+                <a:spcPts val="0"/>
+              </a:spcBef>
+              <a:spcAft>
+                <a:spcPts val="0"/>
+              </a:spcAft>
+            </a:pPr>
+            <a:r>
+              <a:rPr sz="750" b="0">
+                <a:solidFill>
+                  <a:srgbClr val="1A1A1A"/>
+                </a:solidFill>
+                <a:latin typeface="Meiryo"/>
+                <a:ea typeface="Meiryo"/>
+                <a:cs typeface="Meiryo"/>
+              </a:rPr>
+              <a:t>別の論文へ</a:t>
+            </a:r>
+          </a:p>
+        </p:txBody>
+      </p:sp>
+      <p:cxnSp>
+        <p:nvCxnSpPr>
+          <p:cNvPr id="23" name="Connector 22"/>
+          <p:cNvCxnSpPr/>
+          <p:nvPr/>
+        </p:nvCxnSpPr>
+        <p:spPr>
+          <a:xfrm>
+            <a:off x="552450" y="2047875"/>
+            <a:ext cx="7981950" cy="0"/>
+          </a:xfrm>
+          <a:prstGeom prst="line">
+            <a:avLst/>
+          </a:prstGeom>
+          <a:ln w="7143">
+            <a:solidFill>
+              <a:srgbClr val="DDDDDD"/>
+            </a:solidFill>
+          </a:ln>
+        </p:spPr>
+      </p:cxnSp>
+      <p:sp>
+        <p:nvSpPr>
+          <p:cNvPr id="24" name="TextBox 23"/>
+          <p:cNvSpPr txBox="1"/>
+          <p:nvPr/>
+        </p:nvSpPr>
+        <p:spPr>
+          <a:xfrm>
+            <a:off x="552450" y="2047875"/>
+            <a:ext cx="1514475" cy="285750"/>
+          </a:xfrm>
+          <a:prstGeom prst="rect">
+            <a:avLst/>
+          </a:prstGeom>
+          <a:noFill/>
+        </p:spPr>
+        <p:txBody>
+          <a:bodyPr wrap="square" tIns="0" rIns="0" bIns="0" lIns="0" anchor="ctr">
+            <a:spAutoFit/>
+          </a:bodyPr>
+          <a:lstStyle/>
+          <a:p>
+            <a:pPr algn="l">
+              <a:lnSpc>
+                <a:spcPct val="105000"/>
+              </a:lnSpc>
+              <a:spcBef>
+                <a:spcPts val="0"/>
+              </a:spcBef>
+              <a:spcAft>
+                <a:spcPts val="0"/>
+              </a:spcAft>
+            </a:pPr>
+            <a:r>
+              <a:rPr sz="750" b="0">
+                <a:solidFill>
+                  <a:srgbClr val="1A1A1A"/>
+                </a:solidFill>
+                <a:latin typeface="Meiryo"/>
+                <a:ea typeface="Meiryo"/>
+                <a:cs typeface="Meiryo"/>
+              </a:rPr>
+              <a:t>Forman, G. N. ほか</a:t>
+            </a:r>
+          </a:p>
+        </p:txBody>
+      </p:sp>
+      <p:sp>
+        <p:nvSpPr>
+          <p:cNvPr id="25" name="TextBox 24"/>
+          <p:cNvSpPr txBox="1"/>
+          <p:nvPr/>
+        </p:nvSpPr>
+        <p:spPr>
+          <a:xfrm>
+            <a:off x="2152650" y="2047875"/>
+            <a:ext cx="323850" cy="285750"/>
+          </a:xfrm>
+          <a:prstGeom prst="rect">
+            <a:avLst/>
+          </a:prstGeom>
+          <a:noFill/>
+        </p:spPr>
+        <p:txBody>
+          <a:bodyPr wrap="square" tIns="0" rIns="0" bIns="0" lIns="0" anchor="ctr">
+            <a:spAutoFit/>
+          </a:bodyPr>
+          <a:lstStyle/>
+          <a:p>
+            <a:pPr algn="l">
+              <a:lnSpc>
+                <a:spcPct val="105000"/>
+              </a:lnSpc>
+              <a:spcBef>
+                <a:spcPts val="0"/>
+              </a:spcBef>
+              <a:spcAft>
+                <a:spcPts val="0"/>
+              </a:spcAft>
+            </a:pPr>
+            <a:r>
+              <a:rPr sz="750" b="0">
+                <a:solidFill>
+                  <a:srgbClr val="1A1A1A"/>
+                </a:solidFill>
+                <a:latin typeface="Meiryo"/>
+                <a:ea typeface="Meiryo"/>
+                <a:cs typeface="Meiryo"/>
+              </a:rPr>
+              <a:t>2025</a:t>
+            </a:r>
+          </a:p>
+        </p:txBody>
+      </p:sp>
+      <p:sp>
+        <p:nvSpPr>
+          <p:cNvPr id="26" name="TextBox 25"/>
+          <p:cNvSpPr txBox="1"/>
+          <p:nvPr/>
+        </p:nvSpPr>
+        <p:spPr>
+          <a:xfrm>
+            <a:off x="2571750" y="2047875"/>
+            <a:ext cx="4705350" cy="285750"/>
+          </a:xfrm>
+          <a:prstGeom prst="rect">
+            <a:avLst/>
+          </a:prstGeom>
+          <a:noFill/>
+        </p:spPr>
+        <p:txBody>
+          <a:bodyPr wrap="square" tIns="0" rIns="0" bIns="0" lIns="0" anchor="ctr">
+            <a:spAutoFit/>
+          </a:bodyPr>
+          <a:lstStyle/>
+          <a:p>
+            <a:pPr algn="l">
+              <a:lnSpc>
+                <a:spcPct val="105000"/>
+              </a:lnSpc>
+              <a:spcBef>
+                <a:spcPts val="0"/>
+              </a:spcBef>
+              <a:spcAft>
+                <a:spcPts val="0"/>
+              </a:spcAft>
+            </a:pPr>
+            <a:r>
+              <a:rPr sz="750" b="0">
+                <a:solidFill>
+                  <a:srgbClr val="1A1A1A"/>
+                </a:solidFill>
+                <a:latin typeface="Meiryo"/>
+                <a:ea typeface="Meiryo"/>
+                <a:cs typeface="Meiryo"/>
+              </a:rPr>
+              <a:t>Quantifying the Physical Demands of Tactical First-Person Shooter Gameplay: Muscle Activity and Movement Characteristics During Competitive Valorant</a:t>
+            </a:r>
+          </a:p>
+        </p:txBody>
+      </p:sp>
+      <p:sp>
+        <p:nvSpPr>
+          <p:cNvPr id="27" name="TextBox 26"/>
+          <p:cNvSpPr txBox="1"/>
+          <p:nvPr/>
+        </p:nvSpPr>
+        <p:spPr>
+          <a:xfrm>
+            <a:off x="7410450" y="2047875"/>
+            <a:ext cx="1066800" cy="285750"/>
+          </a:xfrm>
+          <a:prstGeom prst="rect">
+            <a:avLst/>
+          </a:prstGeom>
+          <a:noFill/>
+        </p:spPr>
+        <p:txBody>
+          <a:bodyPr wrap="square" tIns="0" rIns="0" bIns="0" lIns="0" anchor="ctr">
+            <a:spAutoFit/>
+          </a:bodyPr>
+          <a:lstStyle/>
+          <a:p>
+            <a:pPr algn="l">
+              <a:lnSpc>
+                <a:spcPct val="105000"/>
+              </a:lnSpc>
+              <a:spcBef>
+                <a:spcPts val="0"/>
+              </a:spcBef>
+              <a:spcAft>
+                <a:spcPts val="0"/>
+              </a:spcAft>
+            </a:pPr>
+            <a:r>
+              <a:rPr sz="750" b="0">
+                <a:solidFill>
+                  <a:srgbClr val="1A1A1A"/>
+                </a:solidFill>
+                <a:latin typeface="Meiryo"/>
+                <a:ea typeface="Meiryo"/>
+                <a:cs typeface="Meiryo"/>
+              </a:rPr>
+              <a:t>別の論文へ</a:t>
+            </a:r>
+          </a:p>
+        </p:txBody>
+      </p:sp>
+      <p:cxnSp>
+        <p:nvCxnSpPr>
+          <p:cNvPr id="28" name="Connector 27"/>
+          <p:cNvCxnSpPr/>
+          <p:nvPr/>
+        </p:nvCxnSpPr>
+        <p:spPr>
+          <a:xfrm>
+            <a:off x="552450" y="2333625"/>
+            <a:ext cx="7981950" cy="0"/>
+          </a:xfrm>
+          <a:prstGeom prst="line">
+            <a:avLst/>
+          </a:prstGeom>
+          <a:ln w="7143">
+            <a:solidFill>
+              <a:srgbClr val="DDDDDD"/>
+            </a:solidFill>
+          </a:ln>
+        </p:spPr>
+      </p:cxnSp>
+      <p:sp>
+        <p:nvSpPr>
+          <p:cNvPr id="29" name="TextBox 28"/>
+          <p:cNvSpPr txBox="1"/>
+          <p:nvPr/>
+        </p:nvSpPr>
+        <p:spPr>
+          <a:xfrm>
+            <a:off x="552450" y="2333625"/>
+            <a:ext cx="1514475" cy="285750"/>
+          </a:xfrm>
+          <a:prstGeom prst="rect">
+            <a:avLst/>
+          </a:prstGeom>
+          <a:noFill/>
+        </p:spPr>
+        <p:txBody>
+          <a:bodyPr wrap="square" tIns="0" rIns="0" bIns="0" lIns="0" anchor="ctr">
+            <a:spAutoFit/>
+          </a:bodyPr>
+          <a:lstStyle/>
+          <a:p>
+            <a:pPr algn="l">
+              <a:lnSpc>
+                <a:spcPct val="105000"/>
+              </a:lnSpc>
+              <a:spcBef>
+                <a:spcPts val="0"/>
+              </a:spcBef>
+              <a:spcAft>
+                <a:spcPts val="0"/>
+              </a:spcAft>
+            </a:pPr>
+            <a:r>
+              <a:rPr sz="750" b="0">
+                <a:solidFill>
+                  <a:srgbClr val="1A1A1A"/>
+                </a:solidFill>
+                <a:latin typeface="Meiryo"/>
+                <a:ea typeface="Meiryo"/>
+                <a:cs typeface="Meiryo"/>
+              </a:rPr>
+              <a:t>Wang ほか</a:t>
+            </a:r>
+          </a:p>
+        </p:txBody>
+      </p:sp>
+      <p:sp>
+        <p:nvSpPr>
+          <p:cNvPr id="30" name="TextBox 29"/>
+          <p:cNvSpPr txBox="1"/>
+          <p:nvPr/>
+        </p:nvSpPr>
+        <p:spPr>
+          <a:xfrm>
+            <a:off x="2152650" y="2333625"/>
+            <a:ext cx="323850" cy="285750"/>
+          </a:xfrm>
+          <a:prstGeom prst="rect">
+            <a:avLst/>
+          </a:prstGeom>
+          <a:noFill/>
+        </p:spPr>
+        <p:txBody>
+          <a:bodyPr wrap="square" tIns="0" rIns="0" bIns="0" lIns="0" anchor="ctr">
+            <a:spAutoFit/>
+          </a:bodyPr>
+          <a:lstStyle/>
+          <a:p>
+            <a:pPr algn="l">
+              <a:lnSpc>
+                <a:spcPct val="105000"/>
+              </a:lnSpc>
+              <a:spcBef>
+                <a:spcPts val="0"/>
+              </a:spcBef>
+              <a:spcAft>
+                <a:spcPts val="0"/>
+              </a:spcAft>
+            </a:pPr>
+            <a:r>
+              <a:rPr sz="750" b="0">
+                <a:solidFill>
+                  <a:srgbClr val="1A1A1A"/>
+                </a:solidFill>
+                <a:latin typeface="Meiryo"/>
+                <a:ea typeface="Meiryo"/>
+                <a:cs typeface="Meiryo"/>
+              </a:rPr>
+              <a:t>2023</a:t>
+            </a:r>
+          </a:p>
+        </p:txBody>
+      </p:sp>
+      <p:sp>
+        <p:nvSpPr>
+          <p:cNvPr id="31" name="TextBox 30"/>
+          <p:cNvSpPr txBox="1"/>
+          <p:nvPr/>
+        </p:nvSpPr>
+        <p:spPr>
+          <a:xfrm>
+            <a:off x="2571750" y="2333625"/>
+            <a:ext cx="4705350" cy="285750"/>
+          </a:xfrm>
+          <a:prstGeom prst="rect">
+            <a:avLst/>
+          </a:prstGeom>
+          <a:noFill/>
+        </p:spPr>
+        <p:txBody>
+          <a:bodyPr wrap="square" tIns="0" rIns="0" bIns="0" lIns="0" anchor="ctr">
+            <a:spAutoFit/>
+          </a:bodyPr>
+          <a:lstStyle/>
+          <a:p>
+            <a:pPr algn="l">
+              <a:lnSpc>
+                <a:spcPct val="105000"/>
+              </a:lnSpc>
+              <a:spcBef>
+                <a:spcPts val="0"/>
+              </a:spcBef>
+              <a:spcAft>
+                <a:spcPts val="0"/>
+              </a:spcAft>
+            </a:pPr>
+            <a:r>
+              <a:rPr sz="750" b="0">
+                <a:solidFill>
+                  <a:srgbClr val="1A1A1A"/>
+                </a:solidFill>
+                <a:latin typeface="Meiryo"/>
+                <a:ea typeface="Meiryo"/>
+                <a:cs typeface="Meiryo"/>
+              </a:rPr>
+              <a:t>The effects of mouse weight and connection type on performance, muscle activity, and preferences among professional gamers</a:t>
+            </a:r>
+          </a:p>
+        </p:txBody>
+      </p:sp>
+      <p:sp>
+        <p:nvSpPr>
+          <p:cNvPr id="32" name="TextBox 31"/>
+          <p:cNvSpPr txBox="1"/>
+          <p:nvPr/>
+        </p:nvSpPr>
+        <p:spPr>
+          <a:xfrm>
+            <a:off x="7410450" y="2333625"/>
+            <a:ext cx="1066800" cy="285750"/>
+          </a:xfrm>
+          <a:prstGeom prst="rect">
+            <a:avLst/>
+          </a:prstGeom>
+          <a:noFill/>
+        </p:spPr>
+        <p:txBody>
+          <a:bodyPr wrap="square" tIns="0" rIns="0" bIns="0" lIns="0" anchor="ctr">
+            <a:spAutoFit/>
+          </a:bodyPr>
+          <a:lstStyle/>
+          <a:p>
+            <a:pPr algn="l">
+              <a:lnSpc>
+                <a:spcPct val="105000"/>
+              </a:lnSpc>
+              <a:spcBef>
+                <a:spcPts val="0"/>
+              </a:spcBef>
+              <a:spcAft>
+                <a:spcPts val="0"/>
+              </a:spcAft>
+            </a:pPr>
+            <a:r>
+              <a:rPr sz="750" b="0">
+                <a:solidFill>
+                  <a:srgbClr val="1A1A1A"/>
+                </a:solidFill>
+                <a:latin typeface="Meiryo"/>
+                <a:ea typeface="Meiryo"/>
+                <a:cs typeface="Meiryo"/>
+              </a:rPr>
+              <a:t>解剖ガイドのみ</a:t>
+            </a:r>
+          </a:p>
+        </p:txBody>
+      </p:sp>
+      <p:cxnSp>
+        <p:nvCxnSpPr>
+          <p:cNvPr id="33" name="Connector 32"/>
+          <p:cNvCxnSpPr/>
+          <p:nvPr/>
+        </p:nvCxnSpPr>
+        <p:spPr>
+          <a:xfrm>
+            <a:off x="552450" y="2619375"/>
+            <a:ext cx="7981950" cy="0"/>
+          </a:xfrm>
+          <a:prstGeom prst="line">
+            <a:avLst/>
+          </a:prstGeom>
+          <a:ln w="7143">
+            <a:solidFill>
+              <a:srgbClr val="DDDDDD"/>
+            </a:solidFill>
+          </a:ln>
+        </p:spPr>
+      </p:cxnSp>
+      <p:sp>
+        <p:nvSpPr>
+          <p:cNvPr id="34" name="TextBox 33"/>
+          <p:cNvSpPr txBox="1"/>
+          <p:nvPr/>
+        </p:nvSpPr>
+        <p:spPr>
+          <a:xfrm>
+            <a:off x="552450" y="2619375"/>
+            <a:ext cx="1514475" cy="285750"/>
+          </a:xfrm>
+          <a:prstGeom prst="rect">
+            <a:avLst/>
+          </a:prstGeom>
+          <a:noFill/>
+        </p:spPr>
+        <p:txBody>
+          <a:bodyPr wrap="square" tIns="0" rIns="0" bIns="0" lIns="0" anchor="ctr">
+            <a:spAutoFit/>
+          </a:bodyPr>
+          <a:lstStyle/>
+          <a:p>
+            <a:pPr algn="l">
+              <a:lnSpc>
+                <a:spcPct val="105000"/>
+              </a:lnSpc>
+              <a:spcBef>
+                <a:spcPts val="0"/>
+              </a:spcBef>
+              <a:spcAft>
+                <a:spcPts val="0"/>
+              </a:spcAft>
+            </a:pPr>
+            <a:r>
+              <a:rPr sz="750" b="0">
+                <a:solidFill>
+                  <a:srgbClr val="6B6B6B"/>
+                </a:solidFill>
+                <a:latin typeface="Meiryo"/>
+                <a:ea typeface="Meiryo"/>
+                <a:cs typeface="Meiryo"/>
+              </a:rPr>
+              <a:t>Park ほか</a:t>
+            </a:r>
+          </a:p>
+        </p:txBody>
+      </p:sp>
+      <p:sp>
+        <p:nvSpPr>
+          <p:cNvPr id="35" name="TextBox 34"/>
+          <p:cNvSpPr txBox="1"/>
+          <p:nvPr/>
+        </p:nvSpPr>
+        <p:spPr>
+          <a:xfrm>
+            <a:off x="2152650" y="2619375"/>
+            <a:ext cx="323850" cy="285750"/>
+          </a:xfrm>
+          <a:prstGeom prst="rect">
+            <a:avLst/>
+          </a:prstGeom>
+          <a:noFill/>
+        </p:spPr>
+        <p:txBody>
+          <a:bodyPr wrap="square" tIns="0" rIns="0" bIns="0" lIns="0" anchor="ctr">
+            <a:spAutoFit/>
+          </a:bodyPr>
+          <a:lstStyle/>
+          <a:p>
+            <a:pPr algn="l">
+              <a:lnSpc>
+                <a:spcPct val="105000"/>
+              </a:lnSpc>
+              <a:spcBef>
+                <a:spcPts val="0"/>
+              </a:spcBef>
+              <a:spcAft>
+                <a:spcPts val="0"/>
+              </a:spcAft>
+            </a:pPr>
+            <a:r>
+              <a:rPr sz="750" b="0">
+                <a:solidFill>
+                  <a:srgbClr val="6B6B6B"/>
+                </a:solidFill>
+                <a:latin typeface="Meiryo"/>
+                <a:ea typeface="Meiryo"/>
+                <a:cs typeface="Meiryo"/>
+              </a:rPr>
+              <a:t>2021</a:t>
+            </a:r>
+          </a:p>
+        </p:txBody>
+      </p:sp>
+      <p:sp>
+        <p:nvSpPr>
+          <p:cNvPr id="36" name="TextBox 35"/>
+          <p:cNvSpPr txBox="1"/>
+          <p:nvPr/>
+        </p:nvSpPr>
+        <p:spPr>
+          <a:xfrm>
+            <a:off x="2571750" y="2619375"/>
+            <a:ext cx="4705350" cy="285750"/>
+          </a:xfrm>
+          <a:prstGeom prst="rect">
+            <a:avLst/>
+          </a:prstGeom>
+          <a:noFill/>
+        </p:spPr>
+        <p:txBody>
+          <a:bodyPr wrap="square" tIns="0" rIns="0" bIns="0" lIns="0" anchor="ctr">
+            <a:spAutoFit/>
+          </a:bodyPr>
+          <a:lstStyle/>
+          <a:p>
+            <a:pPr algn="l">
+              <a:lnSpc>
+                <a:spcPct val="105000"/>
+              </a:lnSpc>
+              <a:spcBef>
+                <a:spcPts val="0"/>
+              </a:spcBef>
+              <a:spcAft>
+                <a:spcPts val="0"/>
+              </a:spcAft>
+            </a:pPr>
+            <a:r>
+              <a:rPr sz="750" b="0">
+                <a:solidFill>
+                  <a:srgbClr val="6B6B6B"/>
+                </a:solidFill>
+                <a:latin typeface="Meiryo"/>
+                <a:ea typeface="Meiryo"/>
+                <a:cs typeface="Meiryo"/>
+              </a:rPr>
+              <a:t>Secrets of Gosu: Understanding Physical Combat Skills of Professional Players in First-Person Shooters</a:t>
+            </a:r>
+          </a:p>
+        </p:txBody>
+      </p:sp>
+      <p:sp>
+        <p:nvSpPr>
+          <p:cNvPr id="37" name="TextBox 36"/>
+          <p:cNvSpPr txBox="1"/>
+          <p:nvPr/>
+        </p:nvSpPr>
+        <p:spPr>
+          <a:xfrm>
+            <a:off x="7410450" y="2619375"/>
+            <a:ext cx="1066800" cy="285750"/>
+          </a:xfrm>
+          <a:prstGeom prst="rect">
+            <a:avLst/>
+          </a:prstGeom>
+          <a:noFill/>
+        </p:spPr>
+        <p:txBody>
+          <a:bodyPr wrap="square" tIns="0" rIns="0" bIns="0" lIns="0" anchor="ctr">
+            <a:spAutoFit/>
+          </a:bodyPr>
+          <a:lstStyle/>
+          <a:p>
+            <a:pPr algn="l">
+              <a:lnSpc>
+                <a:spcPct val="105000"/>
+              </a:lnSpc>
+              <a:spcBef>
+                <a:spcPts val="0"/>
+              </a:spcBef>
+              <a:spcAft>
+                <a:spcPts val="0"/>
+              </a:spcAft>
+            </a:pPr>
+            <a:r>
+              <a:rPr sz="750" b="0">
+                <a:solidFill>
+                  <a:srgbClr val="6B6B6B"/>
+                </a:solidFill>
+                <a:latin typeface="Meiryo"/>
+                <a:ea typeface="Meiryo"/>
+                <a:cs typeface="Meiryo"/>
+              </a:rPr>
+              <a:t>MVC なし</a:t>
+            </a:r>
+          </a:p>
+        </p:txBody>
+      </p:sp>
+      <p:cxnSp>
+        <p:nvCxnSpPr>
+          <p:cNvPr id="38" name="Connector 37"/>
+          <p:cNvCxnSpPr/>
+          <p:nvPr/>
+        </p:nvCxnSpPr>
+        <p:spPr>
+          <a:xfrm>
+            <a:off x="552450" y="2905125"/>
+            <a:ext cx="7981950" cy="0"/>
+          </a:xfrm>
+          <a:prstGeom prst="line">
+            <a:avLst/>
+          </a:prstGeom>
+          <a:ln w="7143">
+            <a:solidFill>
+              <a:srgbClr val="DDDDDD"/>
+            </a:solidFill>
+          </a:ln>
+        </p:spPr>
+      </p:cxnSp>
+      <p:sp>
+        <p:nvSpPr>
+          <p:cNvPr id="39" name="TextBox 38"/>
+          <p:cNvSpPr txBox="1"/>
+          <p:nvPr/>
+        </p:nvSpPr>
+        <p:spPr>
+          <a:xfrm>
+            <a:off x="552450" y="2905125"/>
+            <a:ext cx="1514475" cy="285750"/>
+          </a:xfrm>
+          <a:prstGeom prst="rect">
+            <a:avLst/>
+          </a:prstGeom>
+          <a:noFill/>
+        </p:spPr>
+        <p:txBody>
+          <a:bodyPr wrap="square" tIns="0" rIns="0" bIns="0" lIns="0" anchor="ctr">
+            <a:spAutoFit/>
+          </a:bodyPr>
+          <a:lstStyle/>
+          <a:p>
+            <a:pPr algn="l">
+              <a:lnSpc>
+                <a:spcPct val="105000"/>
+              </a:lnSpc>
+              <a:spcBef>
+                <a:spcPts val="0"/>
+              </a:spcBef>
+              <a:spcAft>
+                <a:spcPts val="0"/>
+              </a:spcAft>
+            </a:pPr>
+            <a:r>
+              <a:rPr sz="750" b="0">
+                <a:solidFill>
+                  <a:srgbClr val="6B6B6B"/>
+                </a:solidFill>
+                <a:latin typeface="Meiryo"/>
+                <a:ea typeface="Meiryo"/>
+                <a:cs typeface="Meiryo"/>
+              </a:rPr>
+              <a:t>Prajapati ほか</a:t>
+            </a:r>
+          </a:p>
+        </p:txBody>
+      </p:sp>
+      <p:sp>
+        <p:nvSpPr>
+          <p:cNvPr id="40" name="TextBox 39"/>
+          <p:cNvSpPr txBox="1"/>
+          <p:nvPr/>
+        </p:nvSpPr>
+        <p:spPr>
+          <a:xfrm>
+            <a:off x="2152650" y="2905125"/>
+            <a:ext cx="323850" cy="285750"/>
+          </a:xfrm>
+          <a:prstGeom prst="rect">
+            <a:avLst/>
+          </a:prstGeom>
+          <a:noFill/>
+        </p:spPr>
+        <p:txBody>
+          <a:bodyPr wrap="square" tIns="0" rIns="0" bIns="0" lIns="0" anchor="ctr">
+            <a:spAutoFit/>
+          </a:bodyPr>
+          <a:lstStyle/>
+          <a:p>
+            <a:pPr algn="l">
+              <a:lnSpc>
+                <a:spcPct val="105000"/>
+              </a:lnSpc>
+              <a:spcBef>
+                <a:spcPts val="0"/>
+              </a:spcBef>
+              <a:spcAft>
+                <a:spcPts val="0"/>
+              </a:spcAft>
+            </a:pPr>
+            <a:r>
+              <a:rPr sz="750" b="0">
+                <a:solidFill>
+                  <a:srgbClr val="6B6B6B"/>
+                </a:solidFill>
+                <a:latin typeface="Meiryo"/>
+                <a:ea typeface="Meiryo"/>
+                <a:cs typeface="Meiryo"/>
+              </a:rPr>
+              <a:t>2024</a:t>
+            </a:r>
+          </a:p>
+        </p:txBody>
+      </p:sp>
+      <p:sp>
+        <p:nvSpPr>
+          <p:cNvPr id="41" name="TextBox 40"/>
+          <p:cNvSpPr txBox="1"/>
+          <p:nvPr/>
+        </p:nvSpPr>
+        <p:spPr>
+          <a:xfrm>
+            <a:off x="2571750" y="2905125"/>
+            <a:ext cx="4705350" cy="285750"/>
+          </a:xfrm>
+          <a:prstGeom prst="rect">
+            <a:avLst/>
+          </a:prstGeom>
+          <a:noFill/>
+        </p:spPr>
+        <p:txBody>
+          <a:bodyPr wrap="square" tIns="0" rIns="0" bIns="0" lIns="0" anchor="ctr">
+            <a:spAutoFit/>
+          </a:bodyPr>
+          <a:lstStyle/>
+          <a:p>
+            <a:pPr algn="l">
+              <a:lnSpc>
+                <a:spcPct val="105000"/>
+              </a:lnSpc>
+              <a:spcBef>
+                <a:spcPts val="0"/>
+              </a:spcBef>
+              <a:spcAft>
+                <a:spcPts val="0"/>
+              </a:spcAft>
+            </a:pPr>
+            <a:r>
+              <a:rPr sz="750" b="0">
+                <a:solidFill>
+                  <a:srgbClr val="6B6B6B"/>
+                </a:solidFill>
+                <a:latin typeface="Meiryo"/>
+                <a:ea typeface="Meiryo"/>
+                <a:cs typeface="Meiryo"/>
+              </a:rPr>
+              <a:t>Relating Muscle Activity and Mouse Sensitivity in FPS Game Players Using Surface EMG Signals</a:t>
+            </a:r>
+          </a:p>
+        </p:txBody>
+      </p:sp>
+      <p:sp>
+        <p:nvSpPr>
+          <p:cNvPr id="42" name="TextBox 41"/>
+          <p:cNvSpPr txBox="1"/>
+          <p:nvPr/>
+        </p:nvSpPr>
+        <p:spPr>
+          <a:xfrm>
+            <a:off x="7410450" y="2905125"/>
+            <a:ext cx="1066800" cy="285750"/>
+          </a:xfrm>
+          <a:prstGeom prst="rect">
+            <a:avLst/>
+          </a:prstGeom>
+          <a:noFill/>
+        </p:spPr>
+        <p:txBody>
+          <a:bodyPr wrap="square" tIns="0" rIns="0" bIns="0" lIns="0" anchor="ctr">
+            <a:spAutoFit/>
+          </a:bodyPr>
+          <a:lstStyle/>
+          <a:p>
+            <a:pPr algn="l">
+              <a:lnSpc>
+                <a:spcPct val="105000"/>
+              </a:lnSpc>
+              <a:spcBef>
+                <a:spcPts val="0"/>
+              </a:spcBef>
+              <a:spcAft>
+                <a:spcPts val="0"/>
+              </a:spcAft>
+            </a:pPr>
+            <a:r>
+              <a:rPr sz="750" b="0">
+                <a:solidFill>
+                  <a:srgbClr val="6B6B6B"/>
+                </a:solidFill>
+                <a:latin typeface="Meiryo"/>
+                <a:ea typeface="Meiryo"/>
+                <a:cs typeface="Meiryo"/>
+              </a:rPr>
+              <a:t>MVC なし</a:t>
+            </a:r>
+          </a:p>
+        </p:txBody>
+      </p:sp>
+      <p:cxnSp>
+        <p:nvCxnSpPr>
+          <p:cNvPr id="43" name="Connector 42"/>
+          <p:cNvCxnSpPr/>
+          <p:nvPr/>
+        </p:nvCxnSpPr>
+        <p:spPr>
+          <a:xfrm>
+            <a:off x="552450" y="3190875"/>
+            <a:ext cx="7981950" cy="0"/>
+          </a:xfrm>
+          <a:prstGeom prst="line">
+            <a:avLst/>
+          </a:prstGeom>
+          <a:ln w="7143">
+            <a:solidFill>
+              <a:srgbClr val="DDDDDD"/>
+            </a:solidFill>
+          </a:ln>
+        </p:spPr>
+      </p:cxnSp>
+      <p:sp>
+        <p:nvSpPr>
+          <p:cNvPr id="44" name="TextBox 43"/>
+          <p:cNvSpPr txBox="1"/>
+          <p:nvPr/>
+        </p:nvSpPr>
+        <p:spPr>
+          <a:xfrm>
+            <a:off x="552450" y="3190875"/>
+            <a:ext cx="1514475" cy="285750"/>
+          </a:xfrm>
+          <a:prstGeom prst="rect">
+            <a:avLst/>
+          </a:prstGeom>
+          <a:noFill/>
+        </p:spPr>
+        <p:txBody>
+          <a:bodyPr wrap="square" tIns="0" rIns="0" bIns="0" lIns="0" anchor="ctr">
+            <a:spAutoFit/>
+          </a:bodyPr>
+          <a:lstStyle/>
+          <a:p>
+            <a:pPr algn="l">
+              <a:lnSpc>
+                <a:spcPct val="105000"/>
+              </a:lnSpc>
+              <a:spcBef>
+                <a:spcPts val="0"/>
+              </a:spcBef>
+              <a:spcAft>
+                <a:spcPts val="0"/>
+              </a:spcAft>
+            </a:pPr>
+            <a:r>
+              <a:rPr sz="750" b="0">
+                <a:solidFill>
+                  <a:srgbClr val="6B6B6B"/>
+                </a:solidFill>
+                <a:latin typeface="Meiryo"/>
+                <a:ea typeface="Meiryo"/>
+                <a:cs typeface="Meiryo"/>
+              </a:rPr>
+              <a:t>Kuikkaniemi ほか</a:t>
+            </a:r>
+          </a:p>
+        </p:txBody>
+      </p:sp>
+      <p:sp>
+        <p:nvSpPr>
+          <p:cNvPr id="45" name="TextBox 44"/>
+          <p:cNvSpPr txBox="1"/>
+          <p:nvPr/>
+        </p:nvSpPr>
+        <p:spPr>
+          <a:xfrm>
+            <a:off x="2152650" y="3190875"/>
+            <a:ext cx="323850" cy="285750"/>
+          </a:xfrm>
+          <a:prstGeom prst="rect">
+            <a:avLst/>
+          </a:prstGeom>
+          <a:noFill/>
+        </p:spPr>
+        <p:txBody>
+          <a:bodyPr wrap="square" tIns="0" rIns="0" bIns="0" lIns="0" anchor="ctr">
+            <a:spAutoFit/>
+          </a:bodyPr>
+          <a:lstStyle/>
+          <a:p>
+            <a:pPr algn="l">
+              <a:lnSpc>
+                <a:spcPct val="105000"/>
+              </a:lnSpc>
+              <a:spcBef>
+                <a:spcPts val="0"/>
+              </a:spcBef>
+              <a:spcAft>
+                <a:spcPts val="0"/>
+              </a:spcAft>
+            </a:pPr>
+            <a:r>
+              <a:rPr sz="750" b="0">
+                <a:solidFill>
+                  <a:srgbClr val="6B6B6B"/>
+                </a:solidFill>
+                <a:latin typeface="Meiryo"/>
+                <a:ea typeface="Meiryo"/>
+                <a:cs typeface="Meiryo"/>
+              </a:rPr>
+              <a:t>2010</a:t>
+            </a:r>
+          </a:p>
+        </p:txBody>
+      </p:sp>
+      <p:sp>
+        <p:nvSpPr>
+          <p:cNvPr id="46" name="TextBox 45"/>
+          <p:cNvSpPr txBox="1"/>
+          <p:nvPr/>
+        </p:nvSpPr>
+        <p:spPr>
+          <a:xfrm>
+            <a:off x="2571750" y="3190875"/>
+            <a:ext cx="4705350" cy="285750"/>
+          </a:xfrm>
+          <a:prstGeom prst="rect">
+            <a:avLst/>
+          </a:prstGeom>
+          <a:noFill/>
+        </p:spPr>
+        <p:txBody>
+          <a:bodyPr wrap="square" tIns="0" rIns="0" bIns="0" lIns="0" anchor="ctr">
+            <a:spAutoFit/>
+          </a:bodyPr>
+          <a:lstStyle/>
+          <a:p>
+            <a:pPr algn="l">
+              <a:lnSpc>
+                <a:spcPct val="105000"/>
+              </a:lnSpc>
+              <a:spcBef>
+                <a:spcPts val="0"/>
+              </a:spcBef>
+              <a:spcAft>
+                <a:spcPts val="0"/>
+              </a:spcAft>
+            </a:pPr>
+            <a:r>
+              <a:rPr sz="750" b="0">
+                <a:solidFill>
+                  <a:srgbClr val="6B6B6B"/>
+                </a:solidFill>
+                <a:latin typeface="Meiryo"/>
+                <a:ea typeface="Meiryo"/>
+                <a:cs typeface="Meiryo"/>
+              </a:rPr>
+              <a:t>The influence of implicit and explicit biofeedback in first-person shooter games</a:t>
+            </a:r>
+          </a:p>
+        </p:txBody>
+      </p:sp>
+      <p:sp>
+        <p:nvSpPr>
+          <p:cNvPr id="47" name="TextBox 46"/>
+          <p:cNvSpPr txBox="1"/>
+          <p:nvPr/>
+        </p:nvSpPr>
+        <p:spPr>
+          <a:xfrm>
+            <a:off x="7410450" y="3190875"/>
+            <a:ext cx="1066800" cy="285750"/>
+          </a:xfrm>
+          <a:prstGeom prst="rect">
+            <a:avLst/>
+          </a:prstGeom>
+          <a:noFill/>
+        </p:spPr>
+        <p:txBody>
+          <a:bodyPr wrap="square" tIns="0" rIns="0" bIns="0" lIns="0" anchor="ctr">
+            <a:spAutoFit/>
+          </a:bodyPr>
+          <a:lstStyle/>
+          <a:p>
+            <a:pPr algn="l">
+              <a:lnSpc>
+                <a:spcPct val="105000"/>
+              </a:lnSpc>
+              <a:spcBef>
+                <a:spcPts val="0"/>
+              </a:spcBef>
+              <a:spcAft>
+                <a:spcPts val="0"/>
+              </a:spcAft>
+            </a:pPr>
+            <a:r>
+              <a:rPr sz="750" b="0">
+                <a:solidFill>
+                  <a:srgbClr val="6B6B6B"/>
+                </a:solidFill>
+                <a:latin typeface="Meiryo"/>
+                <a:ea typeface="Meiryo"/>
+                <a:cs typeface="Meiryo"/>
+              </a:rPr>
+              <a:t>MVC なし</a:t>
+            </a:r>
+          </a:p>
+        </p:txBody>
+      </p:sp>
+      <p:cxnSp>
+        <p:nvCxnSpPr>
+          <p:cNvPr id="48" name="Connector 47"/>
+          <p:cNvCxnSpPr/>
+          <p:nvPr/>
+        </p:nvCxnSpPr>
+        <p:spPr>
+          <a:xfrm>
+            <a:off x="552450" y="3476625"/>
+            <a:ext cx="7981950" cy="0"/>
+          </a:xfrm>
+          <a:prstGeom prst="line">
+            <a:avLst/>
+          </a:prstGeom>
+          <a:ln w="7143">
+            <a:solidFill>
+              <a:srgbClr val="DDDDDD"/>
+            </a:solidFill>
+          </a:ln>
+        </p:spPr>
+      </p:cxnSp>
+      <p:sp>
+        <p:nvSpPr>
+          <p:cNvPr id="49" name="TextBox 48"/>
+          <p:cNvSpPr txBox="1"/>
+          <p:nvPr/>
+        </p:nvSpPr>
+        <p:spPr>
+          <a:xfrm>
+            <a:off x="552450" y="3476625"/>
+            <a:ext cx="1514475" cy="285750"/>
+          </a:xfrm>
+          <a:prstGeom prst="rect">
+            <a:avLst/>
+          </a:prstGeom>
+          <a:noFill/>
+        </p:spPr>
+        <p:txBody>
+          <a:bodyPr wrap="square" tIns="0" rIns="0" bIns="0" lIns="0" anchor="ctr">
+            <a:spAutoFit/>
+          </a:bodyPr>
+          <a:lstStyle/>
+          <a:p>
+            <a:pPr algn="l">
+              <a:lnSpc>
+                <a:spcPct val="105000"/>
+              </a:lnSpc>
+              <a:spcBef>
+                <a:spcPts val="0"/>
+              </a:spcBef>
+              <a:spcAft>
+                <a:spcPts val="0"/>
+              </a:spcAft>
+            </a:pPr>
+            <a:r>
+              <a:rPr sz="750" b="0">
+                <a:solidFill>
+                  <a:srgbClr val="6B6B6B"/>
+                </a:solidFill>
+                <a:latin typeface="Meiryo"/>
+                <a:ea typeface="Meiryo"/>
+                <a:cs typeface="Meiryo"/>
+              </a:rPr>
+              <a:t>Okinaka &amp; Wada</a:t>
+            </a:r>
+          </a:p>
+        </p:txBody>
+      </p:sp>
+      <p:sp>
+        <p:nvSpPr>
+          <p:cNvPr id="50" name="TextBox 49"/>
+          <p:cNvSpPr txBox="1"/>
+          <p:nvPr/>
+        </p:nvSpPr>
+        <p:spPr>
+          <a:xfrm>
+            <a:off x="2152650" y="3476625"/>
+            <a:ext cx="323850" cy="285750"/>
+          </a:xfrm>
+          <a:prstGeom prst="rect">
+            <a:avLst/>
+          </a:prstGeom>
+          <a:noFill/>
+        </p:spPr>
+        <p:txBody>
+          <a:bodyPr wrap="square" tIns="0" rIns="0" bIns="0" lIns="0" anchor="ctr">
+            <a:spAutoFit/>
+          </a:bodyPr>
+          <a:lstStyle/>
+          <a:p>
+            <a:pPr algn="l">
+              <a:lnSpc>
+                <a:spcPct val="105000"/>
+              </a:lnSpc>
+              <a:spcBef>
+                <a:spcPts val="0"/>
+              </a:spcBef>
+              <a:spcAft>
+                <a:spcPts val="0"/>
+              </a:spcAft>
+            </a:pPr>
+            <a:r>
+              <a:rPr sz="750" b="0">
+                <a:solidFill>
+                  <a:srgbClr val="6B6B6B"/>
+                </a:solidFill>
+                <a:latin typeface="Meiryo"/>
+                <a:ea typeface="Meiryo"/>
+                <a:cs typeface="Meiryo"/>
+              </a:rPr>
+              <a:t>2023</a:t>
+            </a:r>
+          </a:p>
+        </p:txBody>
+      </p:sp>
+      <p:sp>
+        <p:nvSpPr>
+          <p:cNvPr id="51" name="TextBox 50"/>
+          <p:cNvSpPr txBox="1"/>
+          <p:nvPr/>
+        </p:nvSpPr>
+        <p:spPr>
+          <a:xfrm>
+            <a:off x="2571750" y="3476625"/>
+            <a:ext cx="4705350" cy="285750"/>
+          </a:xfrm>
+          <a:prstGeom prst="rect">
+            <a:avLst/>
+          </a:prstGeom>
+          <a:noFill/>
+        </p:spPr>
+        <p:txBody>
+          <a:bodyPr wrap="square" tIns="0" rIns="0" bIns="0" lIns="0" anchor="ctr">
+            <a:spAutoFit/>
+          </a:bodyPr>
+          <a:lstStyle/>
+          <a:p>
+            <a:pPr algn="l">
+              <a:lnSpc>
+                <a:spcPct val="105000"/>
+              </a:lnSpc>
+              <a:spcBef>
+                <a:spcPts val="0"/>
+              </a:spcBef>
+              <a:spcAft>
+                <a:spcPts val="0"/>
+              </a:spcAft>
+            </a:pPr>
+            <a:r>
+              <a:rPr sz="750" b="0">
+                <a:solidFill>
+                  <a:srgbClr val="6B6B6B"/>
+                </a:solidFill>
+                <a:latin typeface="Meiryo"/>
+                <a:ea typeface="Meiryo"/>
+                <a:cs typeface="Meiryo"/>
+              </a:rPr>
+              <a:t>Evaluation of performance of key hits using input data, electromyography, and video analysis</a:t>
+            </a:r>
+          </a:p>
+        </p:txBody>
+      </p:sp>
+      <p:sp>
+        <p:nvSpPr>
+          <p:cNvPr id="52" name="TextBox 51"/>
+          <p:cNvSpPr txBox="1"/>
+          <p:nvPr/>
+        </p:nvSpPr>
+        <p:spPr>
+          <a:xfrm>
+            <a:off x="7410450" y="3476625"/>
+            <a:ext cx="1066800" cy="285750"/>
+          </a:xfrm>
+          <a:prstGeom prst="rect">
+            <a:avLst/>
+          </a:prstGeom>
+          <a:noFill/>
+        </p:spPr>
+        <p:txBody>
+          <a:bodyPr wrap="square" tIns="0" rIns="0" bIns="0" lIns="0" anchor="ctr">
+            <a:spAutoFit/>
+          </a:bodyPr>
+          <a:lstStyle/>
+          <a:p>
+            <a:pPr algn="l">
+              <a:lnSpc>
+                <a:spcPct val="105000"/>
+              </a:lnSpc>
+              <a:spcBef>
+                <a:spcPts val="0"/>
+              </a:spcBef>
+              <a:spcAft>
+                <a:spcPts val="0"/>
+              </a:spcAft>
+            </a:pPr>
+            <a:r>
+              <a:rPr sz="750" b="0">
+                <a:solidFill>
+                  <a:srgbClr val="6B6B6B"/>
+                </a:solidFill>
+                <a:latin typeface="Meiryo"/>
+                <a:ea typeface="Meiryo"/>
+                <a:cs typeface="Meiryo"/>
+              </a:rPr>
+              <a:t>MVC なし</a:t>
+            </a:r>
+          </a:p>
+        </p:txBody>
+      </p:sp>
+      <p:cxnSp>
+        <p:nvCxnSpPr>
+          <p:cNvPr id="53" name="Connector 52"/>
+          <p:cNvCxnSpPr/>
+          <p:nvPr/>
+        </p:nvCxnSpPr>
+        <p:spPr>
+          <a:xfrm>
+            <a:off x="552450" y="3762375"/>
+            <a:ext cx="7981950" cy="0"/>
+          </a:xfrm>
+          <a:prstGeom prst="line">
+            <a:avLst/>
+          </a:prstGeom>
+          <a:ln w="7143">
+            <a:solidFill>
+              <a:srgbClr val="DDDDDD"/>
+            </a:solidFill>
+          </a:ln>
+        </p:spPr>
+      </p:cxnSp>
+      <p:sp>
+        <p:nvSpPr>
+          <p:cNvPr id="54" name="TextBox 53"/>
+          <p:cNvSpPr txBox="1"/>
+          <p:nvPr/>
+        </p:nvSpPr>
+        <p:spPr>
+          <a:xfrm>
+            <a:off x="552450" y="3762375"/>
+            <a:ext cx="1514475" cy="285750"/>
+          </a:xfrm>
+          <a:prstGeom prst="rect">
+            <a:avLst/>
+          </a:prstGeom>
+          <a:noFill/>
+        </p:spPr>
+        <p:txBody>
+          <a:bodyPr wrap="square" tIns="0" rIns="0" bIns="0" lIns="0" anchor="ctr">
+            <a:spAutoFit/>
+          </a:bodyPr>
+          <a:lstStyle/>
+          <a:p>
+            <a:pPr algn="l">
+              <a:lnSpc>
+                <a:spcPct val="105000"/>
+              </a:lnSpc>
+              <a:spcBef>
+                <a:spcPts val="0"/>
+              </a:spcBef>
+              <a:spcAft>
+                <a:spcPts val="0"/>
+              </a:spcAft>
+            </a:pPr>
+            <a:r>
+              <a:rPr sz="750" b="0">
+                <a:solidFill>
+                  <a:srgbClr val="6B6B6B"/>
+                </a:solidFill>
+                <a:latin typeface="Meiryo"/>
+                <a:ea typeface="Meiryo"/>
+                <a:cs typeface="Meiryo"/>
+              </a:rPr>
+              <a:t>Jeong ほか</a:t>
+            </a:r>
+          </a:p>
+        </p:txBody>
+      </p:sp>
+      <p:sp>
+        <p:nvSpPr>
+          <p:cNvPr id="55" name="TextBox 54"/>
+          <p:cNvSpPr txBox="1"/>
+          <p:nvPr/>
+        </p:nvSpPr>
+        <p:spPr>
+          <a:xfrm>
+            <a:off x="2152650" y="3762375"/>
+            <a:ext cx="323850" cy="285750"/>
+          </a:xfrm>
+          <a:prstGeom prst="rect">
+            <a:avLst/>
+          </a:prstGeom>
+          <a:noFill/>
+        </p:spPr>
+        <p:txBody>
+          <a:bodyPr wrap="square" tIns="0" rIns="0" bIns="0" lIns="0" anchor="ctr">
+            <a:spAutoFit/>
+          </a:bodyPr>
+          <a:lstStyle/>
+          <a:p>
+            <a:pPr algn="l">
+              <a:lnSpc>
+                <a:spcPct val="105000"/>
+              </a:lnSpc>
+              <a:spcBef>
+                <a:spcPts val="0"/>
+              </a:spcBef>
+              <a:spcAft>
+                <a:spcPts val="0"/>
+              </a:spcAft>
+            </a:pPr>
+            <a:r>
+              <a:rPr sz="750" b="0">
+                <a:solidFill>
+                  <a:srgbClr val="6B6B6B"/>
+                </a:solidFill>
+                <a:latin typeface="Meiryo"/>
+                <a:ea typeface="Meiryo"/>
+                <a:cs typeface="Meiryo"/>
+              </a:rPr>
+              <a:t>2024</a:t>
+            </a:r>
+          </a:p>
+        </p:txBody>
+      </p:sp>
+      <p:sp>
+        <p:nvSpPr>
+          <p:cNvPr id="56" name="TextBox 55"/>
+          <p:cNvSpPr txBox="1"/>
+          <p:nvPr/>
+        </p:nvSpPr>
+        <p:spPr>
+          <a:xfrm>
+            <a:off x="2571750" y="3762375"/>
+            <a:ext cx="4705350" cy="285750"/>
+          </a:xfrm>
+          <a:prstGeom prst="rect">
+            <a:avLst/>
+          </a:prstGeom>
+          <a:noFill/>
+        </p:spPr>
+        <p:txBody>
+          <a:bodyPr wrap="square" tIns="0" rIns="0" bIns="0" lIns="0" anchor="ctr">
+            <a:spAutoFit/>
+          </a:bodyPr>
+          <a:lstStyle/>
+          <a:p>
+            <a:pPr algn="l">
+              <a:lnSpc>
+                <a:spcPct val="105000"/>
+              </a:lnSpc>
+              <a:spcBef>
+                <a:spcPts val="0"/>
+              </a:spcBef>
+              <a:spcAft>
+                <a:spcPts val="0"/>
+              </a:spcAft>
+            </a:pPr>
+            <a:r>
+              <a:rPr sz="750" b="0">
+                <a:solidFill>
+                  <a:srgbClr val="6B6B6B"/>
+                </a:solidFill>
+                <a:latin typeface="Meiryo"/>
+                <a:ea typeface="Meiryo"/>
+                <a:cs typeface="Meiryo"/>
+              </a:rPr>
+              <a:t>e スポーツプレイヤーのパフォーマンスと筋活動の相関関係について</a:t>
+            </a:r>
+          </a:p>
+        </p:txBody>
+      </p:sp>
+      <p:sp>
+        <p:nvSpPr>
+          <p:cNvPr id="57" name="TextBox 56"/>
+          <p:cNvSpPr txBox="1"/>
+          <p:nvPr/>
+        </p:nvSpPr>
+        <p:spPr>
+          <a:xfrm>
+            <a:off x="7410450" y="3762375"/>
+            <a:ext cx="1066800" cy="285750"/>
+          </a:xfrm>
+          <a:prstGeom prst="rect">
+            <a:avLst/>
+          </a:prstGeom>
+          <a:noFill/>
+        </p:spPr>
+        <p:txBody>
+          <a:bodyPr wrap="square" tIns="0" rIns="0" bIns="0" lIns="0" anchor="ctr">
+            <a:spAutoFit/>
+          </a:bodyPr>
+          <a:lstStyle/>
+          <a:p>
+            <a:pPr algn="l">
+              <a:lnSpc>
+                <a:spcPct val="105000"/>
+              </a:lnSpc>
+              <a:spcBef>
+                <a:spcPts val="0"/>
+              </a:spcBef>
+              <a:spcAft>
+                <a:spcPts val="0"/>
+              </a:spcAft>
+            </a:pPr>
+            <a:r>
+              <a:rPr sz="750" b="0">
+                <a:solidFill>
+                  <a:srgbClr val="6B6B6B"/>
+                </a:solidFill>
+                <a:latin typeface="Meiryo"/>
+                <a:ea typeface="Meiryo"/>
+                <a:cs typeface="Meiryo"/>
+              </a:rPr>
+              <a:t>MVC なし</a:t>
+            </a:r>
+          </a:p>
+        </p:txBody>
+      </p:sp>
+      <p:cxnSp>
+        <p:nvCxnSpPr>
+          <p:cNvPr id="58" name="Connector 57"/>
+          <p:cNvCxnSpPr/>
+          <p:nvPr/>
+        </p:nvCxnSpPr>
+        <p:spPr>
+          <a:xfrm>
+            <a:off x="552450" y="4048125"/>
+            <a:ext cx="7981950" cy="0"/>
+          </a:xfrm>
+          <a:prstGeom prst="line">
+            <a:avLst/>
+          </a:prstGeom>
+          <a:ln w="7143">
+            <a:solidFill>
+              <a:srgbClr val="DDDDDD"/>
+            </a:solidFill>
+          </a:ln>
+        </p:spPr>
+      </p:cxnSp>
+      <p:sp>
+        <p:nvSpPr>
+          <p:cNvPr id="59" name="TextBox 58"/>
+          <p:cNvSpPr txBox="1"/>
+          <p:nvPr/>
+        </p:nvSpPr>
+        <p:spPr>
+          <a:xfrm>
+            <a:off x="552450" y="4048125"/>
+            <a:ext cx="1514475" cy="285750"/>
+          </a:xfrm>
+          <a:prstGeom prst="rect">
+            <a:avLst/>
+          </a:prstGeom>
+          <a:noFill/>
+        </p:spPr>
+        <p:txBody>
+          <a:bodyPr wrap="square" tIns="0" rIns="0" bIns="0" lIns="0" anchor="ctr">
+            <a:spAutoFit/>
+          </a:bodyPr>
+          <a:lstStyle/>
+          <a:p>
+            <a:pPr algn="l">
+              <a:lnSpc>
+                <a:spcPct val="105000"/>
+              </a:lnSpc>
+              <a:spcBef>
+                <a:spcPts val="0"/>
+              </a:spcBef>
+              <a:spcAft>
+                <a:spcPts val="0"/>
+              </a:spcAft>
+            </a:pPr>
+            <a:r>
+              <a:rPr sz="750" b="0">
+                <a:solidFill>
+                  <a:srgbClr val="6B6B6B"/>
+                </a:solidFill>
+                <a:latin typeface="Meiryo"/>
+                <a:ea typeface="Meiryo"/>
+                <a:cs typeface="Meiryo"/>
+              </a:rPr>
+              <a:t>Donovan &amp; Heeger</a:t>
+            </a:r>
+          </a:p>
+        </p:txBody>
+      </p:sp>
+      <p:sp>
+        <p:nvSpPr>
+          <p:cNvPr id="60" name="TextBox 59"/>
+          <p:cNvSpPr txBox="1"/>
+          <p:nvPr/>
+        </p:nvSpPr>
+        <p:spPr>
+          <a:xfrm>
+            <a:off x="2152650" y="4048125"/>
+            <a:ext cx="323850" cy="285750"/>
+          </a:xfrm>
+          <a:prstGeom prst="rect">
+            <a:avLst/>
+          </a:prstGeom>
+          <a:noFill/>
+        </p:spPr>
+        <p:txBody>
+          <a:bodyPr wrap="square" tIns="0" rIns="0" bIns="0" lIns="0" anchor="ctr">
+            <a:spAutoFit/>
+          </a:bodyPr>
+          <a:lstStyle/>
+          <a:p>
+            <a:pPr algn="l">
+              <a:lnSpc>
+                <a:spcPct val="105000"/>
+              </a:lnSpc>
+              <a:spcBef>
+                <a:spcPts val="0"/>
+              </a:spcBef>
+              <a:spcAft>
+                <a:spcPts val="0"/>
+              </a:spcAft>
+            </a:pPr>
+            <a:r>
+              <a:rPr sz="750" b="0">
+                <a:solidFill>
+                  <a:srgbClr val="6B6B6B"/>
+                </a:solidFill>
+                <a:latin typeface="Meiryo"/>
+                <a:ea typeface="Meiryo"/>
+                <a:cs typeface="Meiryo"/>
+              </a:rPr>
+              <a:t>2022</a:t>
+            </a:r>
+          </a:p>
+        </p:txBody>
+      </p:sp>
+      <p:sp>
+        <p:nvSpPr>
+          <p:cNvPr id="61" name="TextBox 60"/>
+          <p:cNvSpPr txBox="1"/>
+          <p:nvPr/>
+        </p:nvSpPr>
+        <p:spPr>
+          <a:xfrm>
+            <a:off x="2571750" y="4048125"/>
+            <a:ext cx="4705350" cy="285750"/>
+          </a:xfrm>
+          <a:prstGeom prst="rect">
+            <a:avLst/>
+          </a:prstGeom>
+          <a:noFill/>
+        </p:spPr>
+        <p:txBody>
+          <a:bodyPr wrap="square" tIns="0" rIns="0" bIns="0" lIns="0" anchor="ctr">
+            <a:spAutoFit/>
+          </a:bodyPr>
+          <a:lstStyle/>
+          <a:p>
+            <a:pPr algn="l">
+              <a:lnSpc>
+                <a:spcPct val="105000"/>
+              </a:lnSpc>
+              <a:spcBef>
+                <a:spcPts val="0"/>
+              </a:spcBef>
+              <a:spcAft>
+                <a:spcPts val="0"/>
+              </a:spcAft>
+            </a:pPr>
+            <a:r>
+              <a:rPr sz="750" b="0">
+                <a:solidFill>
+                  <a:srgbClr val="6B6B6B"/>
+                </a:solidFill>
+                <a:latin typeface="Meiryo"/>
+                <a:ea typeface="Meiryo"/>
+                <a:cs typeface="Meiryo"/>
+              </a:rPr>
+              <a:t>Assessment of human expertise and movement kinematics in first-person shooter games</a:t>
+            </a:r>
+          </a:p>
+        </p:txBody>
+      </p:sp>
+      <p:sp>
+        <p:nvSpPr>
+          <p:cNvPr id="62" name="TextBox 61"/>
+          <p:cNvSpPr txBox="1"/>
+          <p:nvPr/>
+        </p:nvSpPr>
+        <p:spPr>
+          <a:xfrm>
+            <a:off x="7410450" y="4048125"/>
+            <a:ext cx="1066800" cy="285750"/>
+          </a:xfrm>
+          <a:prstGeom prst="rect">
+            <a:avLst/>
+          </a:prstGeom>
+          <a:noFill/>
+        </p:spPr>
+        <p:txBody>
+          <a:bodyPr wrap="square" tIns="0" rIns="0" bIns="0" lIns="0" anchor="ctr">
+            <a:spAutoFit/>
+          </a:bodyPr>
+          <a:lstStyle/>
+          <a:p>
+            <a:pPr algn="l">
+              <a:lnSpc>
+                <a:spcPct val="105000"/>
+              </a:lnSpc>
+              <a:spcBef>
+                <a:spcPts val="0"/>
+              </a:spcBef>
+              <a:spcAft>
+                <a:spcPts val="0"/>
+              </a:spcAft>
+            </a:pPr>
+            <a:r>
+              <a:rPr sz="750" b="0">
+                <a:solidFill>
+                  <a:srgbClr val="6B6B6B"/>
+                </a:solidFill>
+                <a:latin typeface="Meiryo"/>
+                <a:ea typeface="Meiryo"/>
+                <a:cs typeface="Meiryo"/>
+              </a:rPr>
+              <a:t>EMG なし</a:t>
+            </a:r>
+          </a:p>
+        </p:txBody>
+      </p:sp>
+      <p:cxnSp>
+        <p:nvCxnSpPr>
+          <p:cNvPr id="63" name="Connector 62"/>
+          <p:cNvCxnSpPr/>
+          <p:nvPr/>
+        </p:nvCxnSpPr>
+        <p:spPr>
+          <a:xfrm>
+            <a:off x="552450" y="4333875"/>
+            <a:ext cx="7981950" cy="0"/>
+          </a:xfrm>
+          <a:prstGeom prst="line">
+            <a:avLst/>
+          </a:prstGeom>
+          <a:ln w="7143">
+            <a:solidFill>
+              <a:srgbClr val="DDDDDD"/>
+            </a:solidFill>
+          </a:ln>
+        </p:spPr>
+      </p:cxnSp>
+      <p:sp>
+        <p:nvSpPr>
+          <p:cNvPr id="64" name="TextBox 63"/>
+          <p:cNvSpPr txBox="1"/>
+          <p:nvPr/>
+        </p:nvSpPr>
+        <p:spPr>
+          <a:xfrm>
+            <a:off x="552450" y="4333875"/>
+            <a:ext cx="1514475" cy="285750"/>
+          </a:xfrm>
+          <a:prstGeom prst="rect">
+            <a:avLst/>
+          </a:prstGeom>
+          <a:noFill/>
+        </p:spPr>
+        <p:txBody>
+          <a:bodyPr wrap="square" tIns="0" rIns="0" bIns="0" lIns="0" anchor="ctr">
+            <a:spAutoFit/>
+          </a:bodyPr>
+          <a:lstStyle/>
+          <a:p>
+            <a:pPr algn="l">
+              <a:lnSpc>
+                <a:spcPct val="105000"/>
+              </a:lnSpc>
+              <a:spcBef>
+                <a:spcPts val="0"/>
+              </a:spcBef>
+              <a:spcAft>
+                <a:spcPts val="0"/>
+              </a:spcAft>
+            </a:pPr>
+            <a:r>
+              <a:rPr sz="750" b="0">
+                <a:solidFill>
+                  <a:srgbClr val="6B6B6B"/>
+                </a:solidFill>
+                <a:latin typeface="Meiryo"/>
+                <a:ea typeface="Meiryo"/>
+                <a:cs typeface="Meiryo"/>
+              </a:rPr>
+              <a:t>Dupuy ほか</a:t>
+            </a:r>
+          </a:p>
+        </p:txBody>
+      </p:sp>
+      <p:sp>
+        <p:nvSpPr>
+          <p:cNvPr id="65" name="TextBox 64"/>
+          <p:cNvSpPr txBox="1"/>
+          <p:nvPr/>
+        </p:nvSpPr>
+        <p:spPr>
+          <a:xfrm>
+            <a:off x="2152650" y="4333875"/>
+            <a:ext cx="323850" cy="285750"/>
+          </a:xfrm>
+          <a:prstGeom prst="rect">
+            <a:avLst/>
+          </a:prstGeom>
+          <a:noFill/>
+        </p:spPr>
+        <p:txBody>
+          <a:bodyPr wrap="square" tIns="0" rIns="0" bIns="0" lIns="0" anchor="ctr">
+            <a:spAutoFit/>
+          </a:bodyPr>
+          <a:lstStyle/>
+          <a:p>
+            <a:pPr algn="l">
+              <a:lnSpc>
+                <a:spcPct val="105000"/>
+              </a:lnSpc>
+              <a:spcBef>
+                <a:spcPts val="0"/>
+              </a:spcBef>
+              <a:spcAft>
+                <a:spcPts val="0"/>
+              </a:spcAft>
+            </a:pPr>
+            <a:r>
+              <a:rPr sz="750" b="0">
+                <a:solidFill>
+                  <a:srgbClr val="6B6B6B"/>
+                </a:solidFill>
+                <a:latin typeface="Meiryo"/>
+                <a:ea typeface="Meiryo"/>
+                <a:cs typeface="Meiryo"/>
+              </a:rPr>
+              <a:t>2024</a:t>
+            </a:r>
+          </a:p>
+        </p:txBody>
+      </p:sp>
+      <p:sp>
+        <p:nvSpPr>
+          <p:cNvPr id="66" name="TextBox 65"/>
+          <p:cNvSpPr txBox="1"/>
+          <p:nvPr/>
+        </p:nvSpPr>
+        <p:spPr>
+          <a:xfrm>
+            <a:off x="2571750" y="4333875"/>
+            <a:ext cx="4705350" cy="285750"/>
+          </a:xfrm>
+          <a:prstGeom prst="rect">
+            <a:avLst/>
+          </a:prstGeom>
+          <a:noFill/>
+        </p:spPr>
+        <p:txBody>
+          <a:bodyPr wrap="square" tIns="0" rIns="0" bIns="0" lIns="0" anchor="ctr">
+            <a:spAutoFit/>
+          </a:bodyPr>
+          <a:lstStyle/>
+          <a:p>
+            <a:pPr algn="l">
+              <a:lnSpc>
+                <a:spcPct val="105000"/>
+              </a:lnSpc>
+              <a:spcBef>
+                <a:spcPts val="0"/>
+              </a:spcBef>
+              <a:spcAft>
+                <a:spcPts val="0"/>
+              </a:spcAft>
+            </a:pPr>
+            <a:r>
+              <a:rPr sz="750" b="0">
+                <a:solidFill>
+                  <a:srgbClr val="6B6B6B"/>
+                </a:solidFill>
+                <a:latin typeface="Meiryo"/>
+                <a:ea typeface="Meiryo"/>
+                <a:cs typeface="Meiryo"/>
+              </a:rPr>
+              <a:t>On the necessity for biomechanics research in esports</a:t>
+            </a:r>
+          </a:p>
+        </p:txBody>
+      </p:sp>
+      <p:sp>
+        <p:nvSpPr>
+          <p:cNvPr id="67" name="TextBox 66"/>
+          <p:cNvSpPr txBox="1"/>
+          <p:nvPr/>
+        </p:nvSpPr>
+        <p:spPr>
+          <a:xfrm>
+            <a:off x="7410450" y="4333875"/>
+            <a:ext cx="1066800" cy="285750"/>
+          </a:xfrm>
+          <a:prstGeom prst="rect">
+            <a:avLst/>
+          </a:prstGeom>
+          <a:noFill/>
+        </p:spPr>
+        <p:txBody>
+          <a:bodyPr wrap="square" tIns="0" rIns="0" bIns="0" lIns="0" anchor="ctr">
+            <a:spAutoFit/>
+          </a:bodyPr>
+          <a:lstStyle/>
+          <a:p>
+            <a:pPr algn="l">
+              <a:lnSpc>
+                <a:spcPct val="105000"/>
+              </a:lnSpc>
+              <a:spcBef>
+                <a:spcPts val="0"/>
+              </a:spcBef>
+              <a:spcAft>
+                <a:spcPts val="0"/>
+              </a:spcAft>
+            </a:pPr>
+            <a:r>
+              <a:rPr sz="750" b="0">
+                <a:solidFill>
+                  <a:srgbClr val="6B6B6B"/>
+                </a:solidFill>
+                <a:latin typeface="Meiryo"/>
+                <a:ea typeface="Meiryo"/>
+                <a:cs typeface="Meiryo"/>
+              </a:rPr>
+              <a:t>EMG なし</a:t>
+            </a:r>
+          </a:p>
+        </p:txBody>
+      </p:sp>
+      <p:cxnSp>
+        <p:nvCxnSpPr>
+          <p:cNvPr id="68" name="Connector 67"/>
+          <p:cNvCxnSpPr/>
+          <p:nvPr/>
+        </p:nvCxnSpPr>
+        <p:spPr>
+          <a:xfrm>
+            <a:off x="552450" y="4619625"/>
+            <a:ext cx="7981950" cy="0"/>
+          </a:xfrm>
+          <a:prstGeom prst="line">
+            <a:avLst/>
+          </a:prstGeom>
+          <a:ln w="7143">
+            <a:solidFill>
+              <a:srgbClr val="DDDDDD"/>
+            </a:solidFill>
+          </a:ln>
+        </p:spPr>
+      </p:cxnSp>
+      <p:sp>
+        <p:nvSpPr>
+          <p:cNvPr id="69" name="TextBox 68"/>
+          <p:cNvSpPr txBox="1"/>
+          <p:nvPr/>
+        </p:nvSpPr>
+        <p:spPr>
+          <a:xfrm>
+            <a:off x="552450" y="4619625"/>
+            <a:ext cx="1514475" cy="285750"/>
+          </a:xfrm>
+          <a:prstGeom prst="rect">
+            <a:avLst/>
+          </a:prstGeom>
+          <a:noFill/>
+        </p:spPr>
+        <p:txBody>
+          <a:bodyPr wrap="square" tIns="0" rIns="0" bIns="0" lIns="0" anchor="ctr">
+            <a:spAutoFit/>
+          </a:bodyPr>
+          <a:lstStyle/>
+          <a:p>
+            <a:pPr algn="l">
+              <a:lnSpc>
+                <a:spcPct val="105000"/>
+              </a:lnSpc>
+              <a:spcBef>
+                <a:spcPts val="0"/>
+              </a:spcBef>
+              <a:spcAft>
+                <a:spcPts val="0"/>
+              </a:spcAft>
+            </a:pPr>
+            <a:r>
+              <a:rPr sz="750" b="0">
+                <a:solidFill>
+                  <a:srgbClr val="6B6B6B"/>
+                </a:solidFill>
+                <a:latin typeface="Meiryo"/>
+                <a:ea typeface="Meiryo"/>
+                <a:cs typeface="Meiryo"/>
+              </a:rPr>
+              <a:t>Dupuy ほか</a:t>
+            </a:r>
+          </a:p>
+        </p:txBody>
+      </p:sp>
+      <p:sp>
+        <p:nvSpPr>
+          <p:cNvPr id="70" name="TextBox 69"/>
+          <p:cNvSpPr txBox="1"/>
+          <p:nvPr/>
+        </p:nvSpPr>
+        <p:spPr>
+          <a:xfrm>
+            <a:off x="2152650" y="4619625"/>
+            <a:ext cx="323850" cy="285750"/>
+          </a:xfrm>
+          <a:prstGeom prst="rect">
+            <a:avLst/>
+          </a:prstGeom>
+          <a:noFill/>
+        </p:spPr>
+        <p:txBody>
+          <a:bodyPr wrap="square" tIns="0" rIns="0" bIns="0" lIns="0" anchor="ctr">
+            <a:spAutoFit/>
+          </a:bodyPr>
+          <a:lstStyle/>
+          <a:p>
+            <a:pPr algn="l">
+              <a:lnSpc>
+                <a:spcPct val="105000"/>
+              </a:lnSpc>
+              <a:spcBef>
+                <a:spcPts val="0"/>
+              </a:spcBef>
+              <a:spcAft>
+                <a:spcPts val="0"/>
+              </a:spcAft>
+            </a:pPr>
+            <a:r>
+              <a:rPr sz="750" b="0">
+                <a:solidFill>
+                  <a:srgbClr val="6B6B6B"/>
+                </a:solidFill>
+                <a:latin typeface="Meiryo"/>
+                <a:ea typeface="Meiryo"/>
+                <a:cs typeface="Meiryo"/>
+              </a:rPr>
+              <a:t>2025</a:t>
+            </a:r>
+          </a:p>
+        </p:txBody>
+      </p:sp>
+      <p:sp>
+        <p:nvSpPr>
+          <p:cNvPr id="71" name="TextBox 70"/>
+          <p:cNvSpPr txBox="1"/>
+          <p:nvPr/>
+        </p:nvSpPr>
+        <p:spPr>
+          <a:xfrm>
+            <a:off x="2571750" y="4619625"/>
+            <a:ext cx="4705350" cy="285750"/>
+          </a:xfrm>
+          <a:prstGeom prst="rect">
+            <a:avLst/>
+          </a:prstGeom>
+          <a:noFill/>
+        </p:spPr>
+        <p:txBody>
+          <a:bodyPr wrap="square" tIns="0" rIns="0" bIns="0" lIns="0" anchor="ctr">
+            <a:spAutoFit/>
+          </a:bodyPr>
+          <a:lstStyle/>
+          <a:p>
+            <a:pPr algn="l">
+              <a:lnSpc>
+                <a:spcPct val="105000"/>
+              </a:lnSpc>
+              <a:spcBef>
+                <a:spcPts val="0"/>
+              </a:spcBef>
+              <a:spcAft>
+                <a:spcPts val="0"/>
+              </a:spcAft>
+            </a:pPr>
+            <a:r>
+              <a:rPr sz="750" b="0">
+                <a:solidFill>
+                  <a:srgbClr val="6B6B6B"/>
+                </a:solidFill>
+                <a:latin typeface="Meiryo"/>
+                <a:ea typeface="Meiryo"/>
+                <a:cs typeface="Meiryo"/>
+              </a:rPr>
+              <a:t>Differentiating right upper limb movements of esports players who play different game genres</a:t>
+            </a:r>
+          </a:p>
+        </p:txBody>
+      </p:sp>
+      <p:sp>
+        <p:nvSpPr>
+          <p:cNvPr id="72" name="TextBox 71"/>
+          <p:cNvSpPr txBox="1"/>
+          <p:nvPr/>
+        </p:nvSpPr>
+        <p:spPr>
+          <a:xfrm>
+            <a:off x="7410450" y="4619625"/>
+            <a:ext cx="1066800" cy="285750"/>
+          </a:xfrm>
+          <a:prstGeom prst="rect">
+            <a:avLst/>
+          </a:prstGeom>
+          <a:noFill/>
+        </p:spPr>
+        <p:txBody>
+          <a:bodyPr wrap="square" tIns="0" rIns="0" bIns="0" lIns="0" anchor="ctr">
+            <a:spAutoFit/>
+          </a:bodyPr>
+          <a:lstStyle/>
+          <a:p>
+            <a:pPr algn="l">
+              <a:lnSpc>
+                <a:spcPct val="105000"/>
+              </a:lnSpc>
+              <a:spcBef>
+                <a:spcPts val="0"/>
+              </a:spcBef>
+              <a:spcAft>
+                <a:spcPts val="0"/>
+              </a:spcAft>
+            </a:pPr>
+            <a:r>
+              <a:rPr sz="750" b="0">
+                <a:solidFill>
+                  <a:srgbClr val="6B6B6B"/>
+                </a:solidFill>
+                <a:latin typeface="Meiryo"/>
+                <a:ea typeface="Meiryo"/>
+                <a:cs typeface="Meiryo"/>
+              </a:rPr>
+              <a:t>EMG なし</a:t>
+            </a:r>
+          </a:p>
+        </p:txBody>
+      </p:sp>
+      <p:cxnSp>
+        <p:nvCxnSpPr>
+          <p:cNvPr id="73" name="Connector 72"/>
+          <p:cNvCxnSpPr/>
+          <p:nvPr/>
+        </p:nvCxnSpPr>
+        <p:spPr>
+          <a:xfrm>
+            <a:off x="552450" y="4905375"/>
+            <a:ext cx="7981950" cy="0"/>
+          </a:xfrm>
+          <a:prstGeom prst="line">
+            <a:avLst/>
+          </a:prstGeom>
+          <a:ln w="7143">
+            <a:solidFill>
+              <a:srgbClr val="DDDDDD"/>
+            </a:solidFill>
+          </a:ln>
+        </p:spPr>
+      </p:cxnSp>
+    </p:spTree>
+  </p:cSld>
+  <p:clrMapOvr>
+    <a:masterClrMapping/>
+  </p:clrMapOvr>
+</p:sld>
+</file>
+
+<file path=ppt/slides/slide14.xml><?xml version="1.0" encoding="utf-8"?>
+<p:sld xmlns:a="http://schemas.openxmlformats.org/drawingml/2006/main" xmlns:p="http://schemas.openxmlformats.org/presentationml/2006/main" xmlns:r="http://schemas.openxmlformats.org/officeDocument/2006/relationships">
+  <p:cSld>
+    <p:spTree>
+      <p:nvGrpSpPr>
+        <p:cNvPr id="1" name=""/>
+        <p:cNvGrpSpPr/>
+        <p:nvPr/>
+      </p:nvGrpSpPr>
+      <p:grpSpPr/>
+      <p:sp>
+        <p:nvSpPr>
+          <p:cNvPr id="2" name="TextBox 1"/>
+          <p:cNvSpPr txBox="1"/>
+          <p:nvPr/>
+        </p:nvSpPr>
+        <p:spPr>
+          <a:xfrm>
+            <a:off x="552450" y="381000"/>
+            <a:ext cx="7143750" cy="476250"/>
+          </a:xfrm>
+          <a:prstGeom prst="rect">
+            <a:avLst/>
+          </a:prstGeom>
+          <a:noFill/>
+        </p:spPr>
+        <p:txBody>
+          <a:bodyPr wrap="square" tIns="0" rIns="0" bIns="0" lIns="0">
+            <a:spAutoFit/>
+          </a:bodyPr>
+          <a:lstStyle/>
+          <a:p>
+            <a:pPr algn="l">
+              <a:lnSpc>
+                <a:spcPct val="120000"/>
+              </a:lnSpc>
+              <a:spcBef>
+                <a:spcPts val="0"/>
+              </a:spcBef>
+              <a:spcAft>
+                <a:spcPts val="0"/>
+              </a:spcAft>
+            </a:pPr>
+            <a:r>
+              <a:rPr sz="3000" b="1">
+                <a:solidFill>
+                  <a:srgbClr val="1A1A1A"/>
+                </a:solidFill>
+                <a:latin typeface="Meiryo"/>
+                <a:ea typeface="Meiryo"/>
+                <a:cs typeface="Meiryo"/>
+              </a:rPr>
+              <a:t>予備：引用をたどって読んだ文献</a:t>
+            </a:r>
+          </a:p>
+        </p:txBody>
+      </p:sp>
+      <p:sp>
+        <p:nvSpPr>
+          <p:cNvPr id="3" name="TextBox 2"/>
+          <p:cNvSpPr txBox="1"/>
+          <p:nvPr/>
+        </p:nvSpPr>
+        <p:spPr>
+          <a:xfrm>
+            <a:off x="7953375" y="476250"/>
+            <a:ext cx="581025" cy="190500"/>
+          </a:xfrm>
+          <a:prstGeom prst="rect">
+            <a:avLst/>
+          </a:prstGeom>
+          <a:noFill/>
+        </p:spPr>
+        <p:txBody>
+          <a:bodyPr wrap="square" tIns="0" rIns="0" bIns="0" lIns="0">
+            <a:spAutoFit/>
+          </a:bodyPr>
+          <a:lstStyle/>
+          <a:p>
+            <a:pPr algn="r">
+              <a:lnSpc>
+                <a:spcPct val="120000"/>
+              </a:lnSpc>
+              <a:spcBef>
+                <a:spcPts val="0"/>
+              </a:spcBef>
+              <a:spcAft>
+                <a:spcPts val="0"/>
+              </a:spcAft>
+            </a:pPr>
+            <a:r>
+              <a:rPr sz="1200" b="0">
+                <a:solidFill>
+                  <a:srgbClr val="6B6B6B"/>
+                </a:solidFill>
+                <a:latin typeface="Meiryo"/>
+                <a:ea typeface="Meiryo"/>
+                <a:cs typeface="Meiryo"/>
+              </a:rPr>
+              <a:t>13</a:t>
+            </a:r>
+          </a:p>
+        </p:txBody>
+      </p:sp>
+      <p:sp>
+        <p:nvSpPr>
+          <p:cNvPr id="4" name="TextBox 3"/>
+          <p:cNvSpPr txBox="1"/>
+          <p:nvPr/>
+        </p:nvSpPr>
+        <p:spPr>
+          <a:xfrm>
+            <a:off x="552450" y="1171575"/>
+            <a:ext cx="1571625" cy="171450"/>
+          </a:xfrm>
+          <a:prstGeom prst="rect">
+            <a:avLst/>
+          </a:prstGeom>
+          <a:noFill/>
+        </p:spPr>
+        <p:txBody>
+          <a:bodyPr wrap="square" tIns="0" rIns="0" bIns="0" lIns="0">
+            <a:spAutoFit/>
+          </a:bodyPr>
+          <a:lstStyle/>
+          <a:p>
+            <a:pPr algn="l">
+              <a:lnSpc>
+                <a:spcPct val="120000"/>
+              </a:lnSpc>
+              <a:spcBef>
+                <a:spcPts val="0"/>
+              </a:spcBef>
+              <a:spcAft>
+                <a:spcPts val="0"/>
+              </a:spcAft>
+            </a:pPr>
+            <a:r>
+              <a:rPr sz="825" b="1">
+                <a:solidFill>
+                  <a:srgbClr val="6B6B6B"/>
+                </a:solidFill>
+                <a:latin typeface="Meiryo"/>
+                <a:ea typeface="Meiryo"/>
+                <a:cs typeface="Meiryo"/>
+              </a:rPr>
+              <a:t>著者</a:t>
+            </a:r>
+          </a:p>
+        </p:txBody>
+      </p:sp>
+      <p:sp>
+        <p:nvSpPr>
+          <p:cNvPr id="5" name="TextBox 4"/>
+          <p:cNvSpPr txBox="1"/>
+          <p:nvPr/>
+        </p:nvSpPr>
+        <p:spPr>
+          <a:xfrm>
+            <a:off x="2152650" y="1171575"/>
+            <a:ext cx="381000" cy="171450"/>
+          </a:xfrm>
+          <a:prstGeom prst="rect">
+            <a:avLst/>
+          </a:prstGeom>
+          <a:noFill/>
+        </p:spPr>
+        <p:txBody>
+          <a:bodyPr wrap="square" tIns="0" rIns="0" bIns="0" lIns="0">
+            <a:spAutoFit/>
+          </a:bodyPr>
+          <a:lstStyle/>
+          <a:p>
+            <a:pPr algn="l">
+              <a:lnSpc>
+                <a:spcPct val="120000"/>
+              </a:lnSpc>
+              <a:spcBef>
+                <a:spcPts val="0"/>
+              </a:spcBef>
+              <a:spcAft>
+                <a:spcPts val="0"/>
+              </a:spcAft>
+            </a:pPr>
+            <a:r>
+              <a:rPr sz="825" b="1">
+                <a:solidFill>
+                  <a:srgbClr val="6B6B6B"/>
+                </a:solidFill>
+                <a:latin typeface="Meiryo"/>
+                <a:ea typeface="Meiryo"/>
+                <a:cs typeface="Meiryo"/>
+              </a:rPr>
+              <a:t>年</a:t>
+            </a:r>
+          </a:p>
+        </p:txBody>
+      </p:sp>
+      <p:sp>
+        <p:nvSpPr>
+          <p:cNvPr id="6" name="TextBox 5"/>
+          <p:cNvSpPr txBox="1"/>
+          <p:nvPr/>
+        </p:nvSpPr>
+        <p:spPr>
+          <a:xfrm>
+            <a:off x="2571750" y="1171575"/>
+            <a:ext cx="5962650" cy="171450"/>
+          </a:xfrm>
+          <a:prstGeom prst="rect">
+            <a:avLst/>
+          </a:prstGeom>
+          <a:noFill/>
+        </p:spPr>
+        <p:txBody>
+          <a:bodyPr wrap="square" tIns="0" rIns="0" bIns="0" lIns="0">
+            <a:spAutoFit/>
+          </a:bodyPr>
+          <a:lstStyle/>
+          <a:p>
+            <a:pPr algn="l">
+              <a:lnSpc>
+                <a:spcPct val="120000"/>
+              </a:lnSpc>
+              <a:spcBef>
+                <a:spcPts val="0"/>
+              </a:spcBef>
+              <a:spcAft>
+                <a:spcPts val="0"/>
+              </a:spcAft>
+            </a:pPr>
+            <a:r>
+              <a:rPr sz="825" b="1">
+                <a:solidFill>
+                  <a:srgbClr val="6B6B6B"/>
+                </a:solidFill>
+                <a:latin typeface="Meiryo"/>
+                <a:ea typeface="Meiryo"/>
+                <a:cs typeface="Meiryo"/>
+              </a:rPr>
+              <a:t>タイトル</a:t>
+            </a:r>
+          </a:p>
+        </p:txBody>
+      </p:sp>
+      <p:cxnSp>
+        <p:nvCxnSpPr>
+          <p:cNvPr id="7" name="Connector 6"/>
+          <p:cNvCxnSpPr/>
+          <p:nvPr/>
+        </p:nvCxnSpPr>
+        <p:spPr>
+          <a:xfrm>
+            <a:off x="552450" y="1381125"/>
+            <a:ext cx="7981950" cy="0"/>
+          </a:xfrm>
+          <a:prstGeom prst="line">
+            <a:avLst/>
+          </a:prstGeom>
+          <a:ln w="7143">
+            <a:solidFill>
+              <a:srgbClr val="DDDDDD"/>
+            </a:solidFill>
+          </a:ln>
+        </p:spPr>
+      </p:cxnSp>
+      <p:sp>
+        <p:nvSpPr>
+          <p:cNvPr id="8" name="TextBox 7"/>
+          <p:cNvSpPr txBox="1"/>
+          <p:nvPr/>
+        </p:nvSpPr>
+        <p:spPr>
+          <a:xfrm>
+            <a:off x="552450" y="1381125"/>
+            <a:ext cx="1514475" cy="428625"/>
+          </a:xfrm>
+          <a:prstGeom prst="rect">
+            <a:avLst/>
+          </a:prstGeom>
+          <a:noFill/>
+        </p:spPr>
+        <p:txBody>
+          <a:bodyPr wrap="square" tIns="0" rIns="0" bIns="0" lIns="0" anchor="ctr">
+            <a:spAutoFit/>
+          </a:bodyPr>
+          <a:lstStyle/>
+          <a:p>
+            <a:pPr algn="l">
+              <a:lnSpc>
+                <a:spcPct val="105000"/>
+              </a:lnSpc>
+              <a:spcBef>
+                <a:spcPts val="0"/>
+              </a:spcBef>
+              <a:spcAft>
+                <a:spcPts val="0"/>
+              </a:spcAft>
+            </a:pPr>
+            <a:r>
+              <a:rPr sz="750" b="0">
+                <a:solidFill>
+                  <a:srgbClr val="1A1A1A"/>
+                </a:solidFill>
+                <a:latin typeface="Meiryo"/>
+                <a:ea typeface="Meiryo"/>
+                <a:cs typeface="Meiryo"/>
+              </a:rPr>
+              <a:t>Forman, D. A. ほか</a:t>
+            </a:r>
+          </a:p>
+        </p:txBody>
+      </p:sp>
+      <p:sp>
+        <p:nvSpPr>
+          <p:cNvPr id="9" name="TextBox 8"/>
+          <p:cNvSpPr txBox="1"/>
+          <p:nvPr/>
+        </p:nvSpPr>
+        <p:spPr>
+          <a:xfrm>
+            <a:off x="2152650" y="1381125"/>
+            <a:ext cx="323850" cy="428625"/>
+          </a:xfrm>
+          <a:prstGeom prst="rect">
+            <a:avLst/>
+          </a:prstGeom>
+          <a:noFill/>
+        </p:spPr>
+        <p:txBody>
+          <a:bodyPr wrap="square" tIns="0" rIns="0" bIns="0" lIns="0" anchor="ctr">
+            <a:spAutoFit/>
+          </a:bodyPr>
+          <a:lstStyle/>
+          <a:p>
+            <a:pPr algn="l">
+              <a:lnSpc>
+                <a:spcPct val="105000"/>
+              </a:lnSpc>
+              <a:spcBef>
+                <a:spcPts val="0"/>
+              </a:spcBef>
+              <a:spcAft>
+                <a:spcPts val="0"/>
+              </a:spcAft>
+            </a:pPr>
+            <a:r>
+              <a:rPr sz="750" b="0">
+                <a:solidFill>
+                  <a:srgbClr val="1A1A1A"/>
+                </a:solidFill>
+                <a:latin typeface="Meiryo"/>
+                <a:ea typeface="Meiryo"/>
+                <a:cs typeface="Meiryo"/>
+              </a:rPr>
+              <a:t>2019</a:t>
+            </a:r>
+          </a:p>
+        </p:txBody>
+      </p:sp>
+      <p:sp>
+        <p:nvSpPr>
+          <p:cNvPr id="10" name="TextBox 9"/>
+          <p:cNvSpPr txBox="1"/>
+          <p:nvPr/>
+        </p:nvSpPr>
+        <p:spPr>
+          <a:xfrm>
+            <a:off x="2571750" y="1381125"/>
+            <a:ext cx="5905500" cy="428625"/>
+          </a:xfrm>
+          <a:prstGeom prst="rect">
+            <a:avLst/>
+          </a:prstGeom>
+          <a:noFill/>
+        </p:spPr>
+        <p:txBody>
+          <a:bodyPr wrap="square" tIns="0" rIns="0" bIns="0" lIns="0" anchor="ctr">
+            <a:spAutoFit/>
+          </a:bodyPr>
+          <a:lstStyle/>
+          <a:p>
+            <a:pPr algn="l">
+              <a:lnSpc>
+                <a:spcPct val="105000"/>
+              </a:lnSpc>
+              <a:spcBef>
+                <a:spcPts val="0"/>
+              </a:spcBef>
+              <a:spcAft>
+                <a:spcPts val="0"/>
+              </a:spcAft>
+            </a:pPr>
+            <a:r>
+              <a:rPr sz="750" b="0">
+                <a:solidFill>
+                  <a:srgbClr val="1A1A1A"/>
+                </a:solidFill>
+                <a:latin typeface="Meiryo"/>
+                <a:ea typeface="Meiryo"/>
+                <a:cs typeface="Meiryo"/>
+              </a:rPr>
+              <a:t>The influence of simultaneous handgrip and wrist force on forearm muscle activity</a:t>
+            </a:r>
+          </a:p>
+        </p:txBody>
+      </p:sp>
+      <p:cxnSp>
+        <p:nvCxnSpPr>
+          <p:cNvPr id="11" name="Connector 10"/>
+          <p:cNvCxnSpPr/>
+          <p:nvPr/>
+        </p:nvCxnSpPr>
+        <p:spPr>
+          <a:xfrm>
+            <a:off x="552450" y="1809750"/>
+            <a:ext cx="7981950" cy="0"/>
+          </a:xfrm>
+          <a:prstGeom prst="line">
+            <a:avLst/>
+          </a:prstGeom>
+          <a:ln w="7143">
+            <a:solidFill>
+              <a:srgbClr val="DDDDDD"/>
+            </a:solidFill>
+          </a:ln>
+        </p:spPr>
+      </p:cxnSp>
+      <p:sp>
+        <p:nvSpPr>
+          <p:cNvPr id="12" name="TextBox 11"/>
+          <p:cNvSpPr txBox="1"/>
+          <p:nvPr/>
+        </p:nvSpPr>
+        <p:spPr>
+          <a:xfrm>
+            <a:off x="552450" y="1809750"/>
+            <a:ext cx="1514475" cy="428625"/>
+          </a:xfrm>
+          <a:prstGeom prst="rect">
+            <a:avLst/>
+          </a:prstGeom>
+          <a:noFill/>
+        </p:spPr>
+        <p:txBody>
+          <a:bodyPr wrap="square" tIns="0" rIns="0" bIns="0" lIns="0" anchor="ctr">
+            <a:spAutoFit/>
+          </a:bodyPr>
+          <a:lstStyle/>
+          <a:p>
+            <a:pPr algn="l">
+              <a:lnSpc>
+                <a:spcPct val="105000"/>
+              </a:lnSpc>
+              <a:spcBef>
+                <a:spcPts val="0"/>
+              </a:spcBef>
+              <a:spcAft>
+                <a:spcPts val="0"/>
+              </a:spcAft>
+            </a:pPr>
+            <a:r>
+              <a:rPr sz="750" b="0">
+                <a:solidFill>
+                  <a:srgbClr val="1A1A1A"/>
+                </a:solidFill>
+                <a:latin typeface="Meiryo"/>
+                <a:ea typeface="Meiryo"/>
+                <a:cs typeface="Meiryo"/>
+              </a:rPr>
+              <a:t>Forman, D. A.</a:t>
+            </a:r>
+          </a:p>
+        </p:txBody>
+      </p:sp>
+      <p:sp>
+        <p:nvSpPr>
+          <p:cNvPr id="13" name="TextBox 12"/>
+          <p:cNvSpPr txBox="1"/>
+          <p:nvPr/>
+        </p:nvSpPr>
+        <p:spPr>
+          <a:xfrm>
+            <a:off x="2152650" y="1809750"/>
+            <a:ext cx="323850" cy="428625"/>
+          </a:xfrm>
+          <a:prstGeom prst="rect">
+            <a:avLst/>
+          </a:prstGeom>
+          <a:noFill/>
+        </p:spPr>
+        <p:txBody>
+          <a:bodyPr wrap="square" tIns="0" rIns="0" bIns="0" lIns="0" anchor="ctr">
+            <a:spAutoFit/>
+          </a:bodyPr>
+          <a:lstStyle/>
+          <a:p>
+            <a:pPr algn="l">
+              <a:lnSpc>
+                <a:spcPct val="105000"/>
+              </a:lnSpc>
+              <a:spcBef>
+                <a:spcPts val="0"/>
+              </a:spcBef>
+              <a:spcAft>
+                <a:spcPts val="0"/>
+              </a:spcAft>
+            </a:pPr>
+            <a:r>
+              <a:rPr sz="750" b="0">
+                <a:solidFill>
+                  <a:srgbClr val="1A1A1A"/>
+                </a:solidFill>
+                <a:latin typeface="Meiryo"/>
+                <a:ea typeface="Meiryo"/>
+                <a:cs typeface="Meiryo"/>
+              </a:rPr>
+              <a:t>2020</a:t>
+            </a:r>
+          </a:p>
+        </p:txBody>
+      </p:sp>
+      <p:sp>
+        <p:nvSpPr>
+          <p:cNvPr id="14" name="TextBox 13"/>
+          <p:cNvSpPr txBox="1"/>
+          <p:nvPr/>
+        </p:nvSpPr>
+        <p:spPr>
+          <a:xfrm>
+            <a:off x="2571750" y="1809750"/>
+            <a:ext cx="5905500" cy="428625"/>
+          </a:xfrm>
+          <a:prstGeom prst="rect">
+            <a:avLst/>
+          </a:prstGeom>
+          <a:noFill/>
+        </p:spPr>
+        <p:txBody>
+          <a:bodyPr wrap="square" tIns="0" rIns="0" bIns="0" lIns="0" anchor="ctr">
+            <a:spAutoFit/>
+          </a:bodyPr>
+          <a:lstStyle/>
+          <a:p>
+            <a:pPr algn="l">
+              <a:lnSpc>
+                <a:spcPct val="105000"/>
+              </a:lnSpc>
+              <a:spcBef>
+                <a:spcPts val="0"/>
+              </a:spcBef>
+              <a:spcAft>
+                <a:spcPts val="0"/>
+              </a:spcAft>
+            </a:pPr>
+            <a:r>
+              <a:rPr sz="750" b="0">
+                <a:solidFill>
+                  <a:srgbClr val="1A1A1A"/>
+                </a:solidFill>
+                <a:latin typeface="Meiryo"/>
+                <a:ea typeface="Meiryo"/>
+                <a:cs typeface="Meiryo"/>
+              </a:rPr>
+              <a:t>Muscle fatigue and other factors influencing forearm muscle activity（博士論文。3 章が Forman 2019）</a:t>
+            </a:r>
+          </a:p>
+        </p:txBody>
+      </p:sp>
+      <p:cxnSp>
+        <p:nvCxnSpPr>
+          <p:cNvPr id="15" name="Connector 14"/>
+          <p:cNvCxnSpPr/>
+          <p:nvPr/>
+        </p:nvCxnSpPr>
+        <p:spPr>
+          <a:xfrm>
+            <a:off x="552450" y="2238375"/>
+            <a:ext cx="7981950" cy="0"/>
+          </a:xfrm>
+          <a:prstGeom prst="line">
+            <a:avLst/>
+          </a:prstGeom>
+          <a:ln w="7143">
+            <a:solidFill>
+              <a:srgbClr val="DDDDDD"/>
+            </a:solidFill>
+          </a:ln>
+        </p:spPr>
+      </p:cxnSp>
+      <p:sp>
+        <p:nvSpPr>
+          <p:cNvPr id="16" name="TextBox 15"/>
+          <p:cNvSpPr txBox="1"/>
+          <p:nvPr/>
+        </p:nvSpPr>
+        <p:spPr>
+          <a:xfrm>
+            <a:off x="552450" y="2238375"/>
+            <a:ext cx="1514475" cy="428625"/>
+          </a:xfrm>
+          <a:prstGeom prst="rect">
+            <a:avLst/>
+          </a:prstGeom>
+          <a:noFill/>
+        </p:spPr>
+        <p:txBody>
+          <a:bodyPr wrap="square" tIns="0" rIns="0" bIns="0" lIns="0" anchor="ctr">
+            <a:spAutoFit/>
+          </a:bodyPr>
+          <a:lstStyle/>
+          <a:p>
+            <a:pPr algn="l">
+              <a:lnSpc>
+                <a:spcPct val="105000"/>
+              </a:lnSpc>
+              <a:spcBef>
+                <a:spcPts val="0"/>
+              </a:spcBef>
+              <a:spcAft>
+                <a:spcPts val="0"/>
+              </a:spcAft>
+            </a:pPr>
+            <a:r>
+              <a:rPr sz="750" b="0">
+                <a:solidFill>
+                  <a:srgbClr val="1A1A1A"/>
+                </a:solidFill>
+                <a:latin typeface="Meiryo"/>
+                <a:ea typeface="Meiryo"/>
+                <a:cs typeface="Meiryo"/>
+              </a:rPr>
+              <a:t>Forman, G. N. ほか</a:t>
+            </a:r>
+          </a:p>
+        </p:txBody>
+      </p:sp>
+      <p:sp>
+        <p:nvSpPr>
+          <p:cNvPr id="17" name="TextBox 16"/>
+          <p:cNvSpPr txBox="1"/>
+          <p:nvPr/>
+        </p:nvSpPr>
+        <p:spPr>
+          <a:xfrm>
+            <a:off x="2152650" y="2238375"/>
+            <a:ext cx="323850" cy="428625"/>
+          </a:xfrm>
+          <a:prstGeom prst="rect">
+            <a:avLst/>
+          </a:prstGeom>
+          <a:noFill/>
+        </p:spPr>
+        <p:txBody>
+          <a:bodyPr wrap="square" tIns="0" rIns="0" bIns="0" lIns="0" anchor="ctr">
+            <a:spAutoFit/>
+          </a:bodyPr>
+          <a:lstStyle/>
+          <a:p>
+            <a:pPr algn="l">
+              <a:lnSpc>
+                <a:spcPct val="105000"/>
+              </a:lnSpc>
+              <a:spcBef>
+                <a:spcPts val="0"/>
+              </a:spcBef>
+              <a:spcAft>
+                <a:spcPts val="0"/>
+              </a:spcAft>
+            </a:pPr>
+            <a:r>
+              <a:rPr sz="750" b="0">
+                <a:solidFill>
+                  <a:srgbClr val="1A1A1A"/>
+                </a:solidFill>
+                <a:latin typeface="Meiryo"/>
+                <a:ea typeface="Meiryo"/>
+                <a:cs typeface="Meiryo"/>
+              </a:rPr>
+              <a:t>2020</a:t>
+            </a:r>
+          </a:p>
+        </p:txBody>
+      </p:sp>
+      <p:sp>
+        <p:nvSpPr>
+          <p:cNvPr id="18" name="TextBox 17"/>
+          <p:cNvSpPr txBox="1"/>
+          <p:nvPr/>
+        </p:nvSpPr>
+        <p:spPr>
+          <a:xfrm>
+            <a:off x="2571750" y="2238375"/>
+            <a:ext cx="5905500" cy="428625"/>
+          </a:xfrm>
+          <a:prstGeom prst="rect">
+            <a:avLst/>
+          </a:prstGeom>
+          <a:noFill/>
+        </p:spPr>
+        <p:txBody>
+          <a:bodyPr wrap="square" tIns="0" rIns="0" bIns="0" lIns="0" anchor="ctr">
+            <a:spAutoFit/>
+          </a:bodyPr>
+          <a:lstStyle/>
+          <a:p>
+            <a:pPr algn="l">
+              <a:lnSpc>
+                <a:spcPct val="105000"/>
+              </a:lnSpc>
+              <a:spcBef>
+                <a:spcPts val="0"/>
+              </a:spcBef>
+              <a:spcAft>
+                <a:spcPts val="0"/>
+              </a:spcAft>
+            </a:pPr>
+            <a:r>
+              <a:rPr sz="750" b="0">
+                <a:solidFill>
+                  <a:srgbClr val="1A1A1A"/>
+                </a:solidFill>
+                <a:latin typeface="Meiryo"/>
+                <a:ea typeface="Meiryo"/>
+                <a:cs typeface="Meiryo"/>
+              </a:rPr>
+              <a:t>Investigating the Muscular and Kinematic Responses to Sudden Wrist Perturbations During a Dynamic Tracking Task
+Sci Rep</a:t>
+            </a:r>
+          </a:p>
+        </p:txBody>
+      </p:sp>
+      <p:cxnSp>
+        <p:nvCxnSpPr>
+          <p:cNvPr id="19" name="Connector 18"/>
+          <p:cNvCxnSpPr/>
+          <p:nvPr/>
+        </p:nvCxnSpPr>
+        <p:spPr>
+          <a:xfrm>
+            <a:off x="552450" y="2667000"/>
+            <a:ext cx="7981950" cy="0"/>
+          </a:xfrm>
+          <a:prstGeom prst="line">
+            <a:avLst/>
+          </a:prstGeom>
+          <a:ln w="7143">
+            <a:solidFill>
+              <a:srgbClr val="DDDDDD"/>
+            </a:solidFill>
+          </a:ln>
+        </p:spPr>
+      </p:cxnSp>
+      <p:sp>
+        <p:nvSpPr>
+          <p:cNvPr id="20" name="TextBox 19"/>
+          <p:cNvSpPr txBox="1"/>
+          <p:nvPr/>
+        </p:nvSpPr>
+        <p:spPr>
+          <a:xfrm>
+            <a:off x="552450" y="2667000"/>
+            <a:ext cx="1514475" cy="428625"/>
+          </a:xfrm>
+          <a:prstGeom prst="rect">
+            <a:avLst/>
+          </a:prstGeom>
+          <a:noFill/>
+        </p:spPr>
+        <p:txBody>
+          <a:bodyPr wrap="square" tIns="0" rIns="0" bIns="0" lIns="0" anchor="ctr">
+            <a:spAutoFit/>
+          </a:bodyPr>
+          <a:lstStyle/>
+          <a:p>
+            <a:pPr algn="l">
+              <a:lnSpc>
+                <a:spcPct val="105000"/>
+              </a:lnSpc>
+              <a:spcBef>
+                <a:spcPts val="0"/>
+              </a:spcBef>
+              <a:spcAft>
+                <a:spcPts val="0"/>
+              </a:spcAft>
+            </a:pPr>
+            <a:r>
+              <a:rPr sz="750" b="0">
+                <a:solidFill>
+                  <a:srgbClr val="1A1A1A"/>
+                </a:solidFill>
+                <a:latin typeface="Meiryo"/>
+                <a:ea typeface="Meiryo"/>
+                <a:cs typeface="Meiryo"/>
+              </a:rPr>
+              <a:t>Forman, D. A. ほか</a:t>
+            </a:r>
+          </a:p>
+        </p:txBody>
+      </p:sp>
+      <p:sp>
+        <p:nvSpPr>
+          <p:cNvPr id="21" name="TextBox 20"/>
+          <p:cNvSpPr txBox="1"/>
+          <p:nvPr/>
+        </p:nvSpPr>
+        <p:spPr>
+          <a:xfrm>
+            <a:off x="2152650" y="2667000"/>
+            <a:ext cx="323850" cy="428625"/>
+          </a:xfrm>
+          <a:prstGeom prst="rect">
+            <a:avLst/>
+          </a:prstGeom>
+          <a:noFill/>
+        </p:spPr>
+        <p:txBody>
+          <a:bodyPr wrap="square" tIns="0" rIns="0" bIns="0" lIns="0" anchor="ctr">
+            <a:spAutoFit/>
+          </a:bodyPr>
+          <a:lstStyle/>
+          <a:p>
+            <a:pPr algn="l">
+              <a:lnSpc>
+                <a:spcPct val="105000"/>
+              </a:lnSpc>
+              <a:spcBef>
+                <a:spcPts val="0"/>
+              </a:spcBef>
+              <a:spcAft>
+                <a:spcPts val="0"/>
+              </a:spcAft>
+            </a:pPr>
+            <a:r>
+              <a:rPr sz="750" b="0">
+                <a:solidFill>
+                  <a:srgbClr val="1A1A1A"/>
+                </a:solidFill>
+                <a:latin typeface="Meiryo"/>
+                <a:ea typeface="Meiryo"/>
+                <a:cs typeface="Meiryo"/>
+              </a:rPr>
+              <a:t>2020</a:t>
+            </a:r>
+          </a:p>
+        </p:txBody>
+      </p:sp>
+      <p:sp>
+        <p:nvSpPr>
+          <p:cNvPr id="22" name="TextBox 21"/>
+          <p:cNvSpPr txBox="1"/>
+          <p:nvPr/>
+        </p:nvSpPr>
+        <p:spPr>
+          <a:xfrm>
+            <a:off x="2571750" y="2667000"/>
+            <a:ext cx="5905500" cy="428625"/>
+          </a:xfrm>
+          <a:prstGeom prst="rect">
+            <a:avLst/>
+          </a:prstGeom>
+          <a:noFill/>
+        </p:spPr>
+        <p:txBody>
+          <a:bodyPr wrap="square" tIns="0" rIns="0" bIns="0" lIns="0" anchor="ctr">
+            <a:spAutoFit/>
+          </a:bodyPr>
+          <a:lstStyle/>
+          <a:p>
+            <a:pPr algn="l">
+              <a:lnSpc>
+                <a:spcPct val="105000"/>
+              </a:lnSpc>
+              <a:spcBef>
+                <a:spcPts val="0"/>
+              </a:spcBef>
+              <a:spcAft>
+                <a:spcPts val="0"/>
+              </a:spcAft>
+            </a:pPr>
+            <a:r>
+              <a:rPr sz="750" b="0">
+                <a:solidFill>
+                  <a:srgbClr val="1A1A1A"/>
+                </a:solidFill>
+                <a:latin typeface="Meiryo"/>
+                <a:ea typeface="Meiryo"/>
+                <a:cs typeface="Meiryo"/>
+              </a:rPr>
+              <a:t>Sustained Isometric Wrist Flexion and Extension Maximal Voluntary Contractions Similarly Impair Hand-Tracking Accuracy in Young Adults Using a Wrist Robot
+Front Sports Act Living</a:t>
+            </a:r>
+          </a:p>
+        </p:txBody>
+      </p:sp>
+      <p:cxnSp>
+        <p:nvCxnSpPr>
+          <p:cNvPr id="23" name="Connector 22"/>
+          <p:cNvCxnSpPr/>
+          <p:nvPr/>
+        </p:nvCxnSpPr>
+        <p:spPr>
+          <a:xfrm>
+            <a:off x="552450" y="3095625"/>
+            <a:ext cx="7981950" cy="0"/>
+          </a:xfrm>
+          <a:prstGeom prst="line">
+            <a:avLst/>
+          </a:prstGeom>
+          <a:ln w="7143">
+            <a:solidFill>
+              <a:srgbClr val="DDDDDD"/>
+            </a:solidFill>
+          </a:ln>
+        </p:spPr>
+      </p:cxnSp>
+      <p:sp>
+        <p:nvSpPr>
+          <p:cNvPr id="24" name="TextBox 23"/>
+          <p:cNvSpPr txBox="1"/>
+          <p:nvPr/>
+        </p:nvSpPr>
+        <p:spPr>
+          <a:xfrm>
+            <a:off x="552450" y="3095625"/>
+            <a:ext cx="1514475" cy="428625"/>
+          </a:xfrm>
+          <a:prstGeom prst="rect">
+            <a:avLst/>
+          </a:prstGeom>
+          <a:noFill/>
+        </p:spPr>
+        <p:txBody>
+          <a:bodyPr wrap="square" tIns="0" rIns="0" bIns="0" lIns="0" anchor="ctr">
+            <a:spAutoFit/>
+          </a:bodyPr>
+          <a:lstStyle/>
+          <a:p>
+            <a:pPr algn="l">
+              <a:lnSpc>
+                <a:spcPct val="105000"/>
+              </a:lnSpc>
+              <a:spcBef>
+                <a:spcPts val="0"/>
+              </a:spcBef>
+              <a:spcAft>
+                <a:spcPts val="0"/>
+              </a:spcAft>
+            </a:pPr>
+            <a:r>
+              <a:rPr sz="750" b="0">
+                <a:solidFill>
+                  <a:srgbClr val="1A1A1A"/>
+                </a:solidFill>
+                <a:latin typeface="Meiryo"/>
+                <a:ea typeface="Meiryo"/>
+                <a:cs typeface="Meiryo"/>
+              </a:rPr>
+              <a:t>Holmes ほか</a:t>
+            </a:r>
+          </a:p>
+        </p:txBody>
+      </p:sp>
+      <p:sp>
+        <p:nvSpPr>
+          <p:cNvPr id="25" name="TextBox 24"/>
+          <p:cNvSpPr txBox="1"/>
+          <p:nvPr/>
+        </p:nvSpPr>
+        <p:spPr>
+          <a:xfrm>
+            <a:off x="2152650" y="3095625"/>
+            <a:ext cx="323850" cy="428625"/>
+          </a:xfrm>
+          <a:prstGeom prst="rect">
+            <a:avLst/>
+          </a:prstGeom>
+          <a:noFill/>
+        </p:spPr>
+        <p:txBody>
+          <a:bodyPr wrap="square" tIns="0" rIns="0" bIns="0" lIns="0" anchor="ctr">
+            <a:spAutoFit/>
+          </a:bodyPr>
+          <a:lstStyle/>
+          <a:p>
+            <a:pPr algn="l">
+              <a:lnSpc>
+                <a:spcPct val="105000"/>
+              </a:lnSpc>
+              <a:spcBef>
+                <a:spcPts val="0"/>
+              </a:spcBef>
+              <a:spcAft>
+                <a:spcPts val="0"/>
+              </a:spcAft>
+            </a:pPr>
+            <a:r>
+              <a:rPr sz="750" b="0">
+                <a:solidFill>
+                  <a:srgbClr val="1A1A1A"/>
+                </a:solidFill>
+                <a:latin typeface="Meiryo"/>
+                <a:ea typeface="Meiryo"/>
+                <a:cs typeface="Meiryo"/>
+              </a:rPr>
+              <a:t>2022</a:t>
+            </a:r>
+          </a:p>
+        </p:txBody>
+      </p:sp>
+      <p:sp>
+        <p:nvSpPr>
+          <p:cNvPr id="26" name="TextBox 25"/>
+          <p:cNvSpPr txBox="1"/>
+          <p:nvPr/>
+        </p:nvSpPr>
+        <p:spPr>
+          <a:xfrm>
+            <a:off x="2571750" y="3095625"/>
+            <a:ext cx="5905500" cy="428625"/>
+          </a:xfrm>
+          <a:prstGeom prst="rect">
+            <a:avLst/>
+          </a:prstGeom>
+          <a:noFill/>
+        </p:spPr>
+        <p:txBody>
+          <a:bodyPr wrap="square" tIns="0" rIns="0" bIns="0" lIns="0" anchor="ctr">
+            <a:spAutoFit/>
+          </a:bodyPr>
+          <a:lstStyle/>
+          <a:p>
+            <a:pPr algn="l">
+              <a:lnSpc>
+                <a:spcPct val="105000"/>
+              </a:lnSpc>
+              <a:spcBef>
+                <a:spcPts val="0"/>
+              </a:spcBef>
+              <a:spcAft>
+                <a:spcPts val="0"/>
+              </a:spcAft>
+            </a:pPr>
+            <a:r>
+              <a:rPr sz="750" b="0">
+                <a:solidFill>
+                  <a:srgbClr val="1A1A1A"/>
+                </a:solidFill>
+                <a:latin typeface="Meiryo"/>
+                <a:ea typeface="Meiryo"/>
+                <a:cs typeface="Meiryo"/>
+              </a:rPr>
+              <a:t>The effects of isometric hand grip force on wrist kinematics and forearm muscle activity during radial and ulnar wrist joint perturbations
+PeerJ</a:t>
+            </a:r>
+          </a:p>
+        </p:txBody>
+      </p:sp>
+      <p:cxnSp>
+        <p:nvCxnSpPr>
+          <p:cNvPr id="27" name="Connector 26"/>
+          <p:cNvCxnSpPr/>
+          <p:nvPr/>
+        </p:nvCxnSpPr>
+        <p:spPr>
+          <a:xfrm>
+            <a:off x="552450" y="3524250"/>
+            <a:ext cx="7981950" cy="0"/>
+          </a:xfrm>
+          <a:prstGeom prst="line">
+            <a:avLst/>
+          </a:prstGeom>
+          <a:ln w="7143">
+            <a:solidFill>
+              <a:srgbClr val="DDDDDD"/>
+            </a:solidFill>
+          </a:ln>
+        </p:spPr>
+      </p:cxnSp>
     </p:spTree>
   </p:cSld>
   <p:clrMapOvr>

</xml_diff>

<commit_message>
Set next week to MVC checks, reproducibility, other sites, and the API
Simplify the next recording to check -> B -> flexion, and add the
three things to start alongside it now that the API key has arrived.

Co-Authored-By: Claude Opus 5.5 <noreply@anthropic.com>
</commit_message>
<xml_diff>
--- a/docs/progress/slides/2026-10-08.pptx
+++ b/docs/progress/slides/2026-10-08.pptx
@@ -708,12 +708,18 @@
           <a:p/>
           <a:p>
             <a:r>
-              <a:t>屈曲の新しいやり方はまだ試していないので、次回の記録で確かめます。順番は、確認動作を最初に取り、B と一人用（H）を 2 回ずつ、屈曲、最後に確認動作と B をもう 1 回です。最後の B が最初より小さければ疲れていたとわかります。課題のあいだは十分休みます。</a:t>
+              <a:t>次回は、この決めたやり方で MVC を取ります。順番は、確認動作（反らしきる・曲げきる）を疲れる前の最初に取り、そのあと伸展（B）、屈曲です。課題のあいだは十分休みます。</a:t>
             </a:r>
           </a:p>
           <a:p/>
           <a:p>
             <a:r>
+              <a:t>確認動作を残すのは、屈曲の新しいやり方をまだ試していないからです。足りているかは、確認動作がその MVC の 100% 以下に収まるかでしか確かめられません。</a:t>
+            </a:r>
+          </a:p>
+          <a:p/>
+          <a:p>
+            <a:r>
               <a:t>伸展・屈曲とも、確認動作が 100 %MVC 以下に収まれば決定として、calibration.py の DEFAULT_TASKS に入れます。</a:t>
             </a:r>
           </a:p>
@@ -721,6 +727,30 @@
           <a:p>
             <a:r>
               <a:t>記録の前に、センサ番号と貼った位置を sensors.json に書き、反らしてどちらが伸筋側か確かめます。今回センサの上下がわからなくなったのを防ぐためです。</a:t>
+            </a:r>
+          </a:p>
+          <a:p/>
+          <a:p>
+            <a:r>
+              <a:t>あわせて 3 つ始めます。</a:t>
+            </a:r>
+          </a:p>
+          <a:p/>
+          <a:p>
+            <a:r>
+              <a:t>1 つ目、再現性を高めるためにすることを考えます。同じやり方（A）でも、09-29 は約 350%、10-06 は 96% と、日によって大きく違いました。日をまたいで比べる研究なので、ここは詰めておく必要があります。</a:t>
+            </a:r>
+          </a:p>
+          <a:p/>
+          <a:p>
+            <a:r>
+              <a:t>2 つ目、ほかの箇所（肩・上腕・僧帽筋）の MVC を早めに始めます。課題が多く、決めるのに時間がかかりそうなので、前腕と並行して進めます。</a:t>
+            </a:r>
+          </a:p>
+          <a:p/>
+          <a:p>
+            <a:r>
+              <a:t>3 つ目、Delsys API のキーが届いたので、Trigno Discover で CSV を取るやり方から API へ移行します。まず実機につながるか、Discover と同じ設定（Avanti、2148.1 Hz）で取れるかを確かめます。</a:t>
             </a:r>
           </a:p>
         </p:txBody>
@@ -796,7 +826,7 @@
           <a:p/>
           <a:p>
             <a:r>
-              <a:t>大きな目標は、前腕 2 か所で新しいデータを取りました。6 か所の本番データは、MVC の取り方を確かめてから取ります。</a:t>
+              <a:t>大きな目標は、前腕 2 か所で新しいデータを取りました。6 か所の本番データは、MVC の取り方を確かめてから取ります。API のキーが届いたので、取り方を API に移せるようになりました。</a:t>
             </a:r>
           </a:p>
           <a:p/>
@@ -808,7 +838,7 @@
           <a:p/>
           <a:p>
             <a:r>
-              <a:t>来週は、伸展・屈曲の MVC を確かめて、6 か所で本番データを取ります。</a:t>
+              <a:t>来週は、前腕の MVC を確かめ、ほかの箇所の MVC と API への移行を始めます。</a:t>
             </a:r>
           </a:p>
         </p:txBody>
@@ -5675,8 +5705,8 @@
         </p:nvSpPr>
         <p:spPr>
           <a:xfrm>
-            <a:off x="571500" y="1190625"/>
-            <a:ext cx="7962900" cy="381000"/>
+            <a:off x="552450" y="1071562"/>
+            <a:ext cx="7981950" cy="190500"/>
           </a:xfrm>
           <a:prstGeom prst="rect">
             <a:avLst/>
@@ -5691,17 +5721,17 @@
           <a:p>
             <a:pPr algn="l">
               <a:lnSpc>
-                <a:spcPct val="130000"/>
-              </a:lnSpc>
-              <a:spcBef>
-                <a:spcPts val="0"/>
-              </a:spcBef>
-              <a:spcAft>
-                <a:spcPts val="750"/>
-              </a:spcAft>
-            </a:pPr>
-            <a:r>
-              <a:rPr sz="1725" b="1">
+                <a:spcPct val="120000"/>
+              </a:lnSpc>
+              <a:spcBef>
+                <a:spcPts val="0"/>
+              </a:spcBef>
+              <a:spcAft>
+                <a:spcPts val="0"/>
+              </a:spcAft>
+            </a:pPr>
+            <a:r>
+              <a:rPr sz="1125" b="1">
                 <a:solidFill>
                   <a:srgbClr val="1A1A1A"/>
                 </a:solidFill>
@@ -5709,7 +5739,7 @@
                 <a:ea typeface="Meiryo"/>
                 <a:cs typeface="Meiryo"/>
               </a:rPr>
-              <a:t>・腕は机に乗せる。疲れる前と後に確認動作を取る</a:t>
+              <a:t>前腕の MVC を、決めたやり方で取る（腕は机に乗せる）</a:t>
             </a:r>
           </a:p>
         </p:txBody>
@@ -5722,245 +5752,12 @@
         </p:nvSpPr>
         <p:spPr>
           <a:xfrm>
-            <a:off x="552450" y="1762125"/>
-            <a:ext cx="3905250" cy="809625"/>
+            <a:off x="552450" y="1357312"/>
+            <a:ext cx="2381250" cy="714375"/>
           </a:xfrm>
           <a:prstGeom prst="roundRect">
             <a:avLst>
-              <a:gd name="adj" fmla="val 7058"/>
-            </a:avLst>
-          </a:prstGeom>
-          <a:solidFill>
-            <a:srgbClr val="E8F0F8"/>
-          </a:solidFill>
-          <a:ln w="14287">
-            <a:solidFill>
-              <a:srgbClr val="1F6FB4"/>
-            </a:solidFill>
-          </a:ln>
-          <a:effectLst/>
-        </p:spPr>
-        <p:style>
-          <a:lnRef idx="1">
-            <a:schemeClr val="accent1"/>
-          </a:lnRef>
-          <a:fillRef idx="3">
-            <a:schemeClr val="accent1"/>
-          </a:fillRef>
-          <a:effectRef idx="2">
-            <a:schemeClr val="accent1"/>
-          </a:effectRef>
-          <a:fontRef idx="minor">
-            <a:schemeClr val="lt1"/>
-          </a:fontRef>
-        </p:style>
-        <p:txBody>
-          <a:bodyPr rtlCol="0" anchor="ctr" wrap="square" tIns="114300" rIns="152400" bIns="114300" lIns="152400"/>
-          <a:lstStyle/>
-          <a:p>
-            <a:pPr algn="l">
-              <a:lnSpc>
-                <a:spcPct val="120000"/>
-              </a:lnSpc>
-              <a:spcBef>
-                <a:spcPts val="0"/>
-              </a:spcBef>
-              <a:spcAft>
-                <a:spcPts val="300"/>
-              </a:spcAft>
-            </a:pPr>
-            <a:r>
-              <a:rPr sz="1050" b="1">
-                <a:solidFill>
-                  <a:srgbClr val="1F6FB4"/>
-                </a:solidFill>
-                <a:latin typeface="Meiryo"/>
-                <a:ea typeface="Meiryo"/>
-                <a:cs typeface="Meiryo"/>
-              </a:rPr>
-              <a:t>伸展（決定）</a:t>
-            </a:r>
-          </a:p>
-          <a:p>
-            <a:pPr algn="l">
-              <a:lnSpc>
-                <a:spcPct val="120000"/>
-              </a:lnSpc>
-              <a:spcBef>
-                <a:spcPts val="0"/>
-              </a:spcBef>
-              <a:spcAft>
-                <a:spcPts val="0"/>
-              </a:spcAft>
-            </a:pPr>
-            <a:r>
-              <a:rPr sz="1200" b="1">
-                <a:solidFill>
-                  <a:srgbClr val="1A1A1A"/>
-                </a:solidFill>
-                <a:latin typeface="Meiryo"/>
-                <a:ea typeface="Meiryo"/>
-                <a:cs typeface="Meiryo"/>
-              </a:rPr>
-              <a:t>手のひら下・握って、上から押さえてもらう</a:t>
-            </a:r>
-          </a:p>
-        </p:txBody>
-      </p:sp>
-      <p:sp>
-        <p:nvSpPr>
-          <p:cNvPr id="6" name="Rounded Rectangle 5"/>
-          <p:cNvSpPr/>
-          <p:nvPr/>
-        </p:nvSpPr>
-        <p:spPr>
-          <a:xfrm>
-            <a:off x="4629150" y="1762125"/>
-            <a:ext cx="3905250" cy="809625"/>
-          </a:xfrm>
-          <a:prstGeom prst="roundRect">
-            <a:avLst>
-              <a:gd name="adj" fmla="val 7058"/>
-            </a:avLst>
-          </a:prstGeom>
-          <a:solidFill>
-            <a:srgbClr val="FBEBDD"/>
-          </a:solidFill>
-          <a:ln w="14287">
-            <a:solidFill>
-              <a:srgbClr val="E07B1A"/>
-            </a:solidFill>
-          </a:ln>
-          <a:effectLst/>
-        </p:spPr>
-        <p:style>
-          <a:lnRef idx="1">
-            <a:schemeClr val="accent1"/>
-          </a:lnRef>
-          <a:fillRef idx="3">
-            <a:schemeClr val="accent1"/>
-          </a:fillRef>
-          <a:effectRef idx="2">
-            <a:schemeClr val="accent1"/>
-          </a:effectRef>
-          <a:fontRef idx="minor">
-            <a:schemeClr val="lt1"/>
-          </a:fontRef>
-        </p:style>
-        <p:txBody>
-          <a:bodyPr rtlCol="0" anchor="ctr" wrap="square" tIns="114300" rIns="152400" bIns="114300" lIns="152400"/>
-          <a:lstStyle/>
-          <a:p>
-            <a:pPr algn="l">
-              <a:lnSpc>
-                <a:spcPct val="120000"/>
-              </a:lnSpc>
-              <a:spcBef>
-                <a:spcPts val="0"/>
-              </a:spcBef>
-              <a:spcAft>
-                <a:spcPts val="300"/>
-              </a:spcAft>
-            </a:pPr>
-            <a:r>
-              <a:rPr sz="1050" b="1">
-                <a:solidFill>
-                  <a:srgbClr val="B0560C"/>
-                </a:solidFill>
-                <a:latin typeface="Meiryo"/>
-                <a:ea typeface="Meiryo"/>
-                <a:cs typeface="Meiryo"/>
-              </a:rPr>
-              <a:t>屈曲（次回確かめる）</a:t>
-            </a:r>
-          </a:p>
-          <a:p>
-            <a:pPr algn="l">
-              <a:lnSpc>
-                <a:spcPct val="120000"/>
-              </a:lnSpc>
-              <a:spcBef>
-                <a:spcPts val="0"/>
-              </a:spcBef>
-              <a:spcAft>
-                <a:spcPts val="0"/>
-              </a:spcAft>
-            </a:pPr>
-            <a:r>
-              <a:rPr sz="1200" b="1">
-                <a:solidFill>
-                  <a:srgbClr val="1A1A1A"/>
-                </a:solidFill>
-                <a:latin typeface="Meiryo"/>
-                <a:ea typeface="Meiryo"/>
-                <a:cs typeface="Meiryo"/>
-              </a:rPr>
-              <a:t>机に向かって押し下げる</a:t>
-            </a:r>
-          </a:p>
-        </p:txBody>
-      </p:sp>
-      <p:sp>
-        <p:nvSpPr>
-          <p:cNvPr id="7" name="TextBox 6"/>
-          <p:cNvSpPr txBox="1"/>
-          <p:nvPr/>
-        </p:nvSpPr>
-        <p:spPr>
-          <a:xfrm>
-            <a:off x="552450" y="2809875"/>
-            <a:ext cx="7981950" cy="190500"/>
-          </a:xfrm>
-          <a:prstGeom prst="rect">
-            <a:avLst/>
-          </a:prstGeom>
-          <a:noFill/>
-        </p:spPr>
-        <p:txBody>
-          <a:bodyPr wrap="square" tIns="0" rIns="0" bIns="0" lIns="0">
-            <a:spAutoFit/>
-          </a:bodyPr>
-          <a:lstStyle/>
-          <a:p>
-            <a:pPr algn="l">
-              <a:lnSpc>
-                <a:spcPct val="120000"/>
-              </a:lnSpc>
-              <a:spcBef>
-                <a:spcPts val="0"/>
-              </a:spcBef>
-              <a:spcAft>
-                <a:spcPts val="0"/>
-              </a:spcAft>
-            </a:pPr>
-            <a:r>
-              <a:rPr sz="1050" b="1">
-                <a:solidFill>
-                  <a:srgbClr val="6B6B6B"/>
-                </a:solidFill>
-                <a:latin typeface="Meiryo"/>
-                <a:ea typeface="Meiryo"/>
-                <a:cs typeface="Meiryo"/>
-              </a:rPr>
-              <a:t>次回の記録の順番</a:t>
-            </a:r>
-          </a:p>
-        </p:txBody>
-      </p:sp>
-      <p:sp>
-        <p:nvSpPr>
-          <p:cNvPr id="8" name="Rounded Rectangle 7"/>
-          <p:cNvSpPr/>
-          <p:nvPr/>
-        </p:nvSpPr>
-        <p:spPr>
-          <a:xfrm>
-            <a:off x="552450" y="3095625"/>
-            <a:ext cx="1762125" cy="762000"/>
-          </a:xfrm>
-          <a:prstGeom prst="roundRect">
-            <a:avLst>
-              <a:gd name="adj" fmla="val 7500"/>
+              <a:gd name="adj" fmla="val 8000"/>
             </a:avLst>
           </a:prstGeom>
           <a:solidFill>
@@ -6011,7 +5808,7 @@
                 <a:ea typeface="Meiryo"/>
                 <a:cs typeface="Meiryo"/>
               </a:rPr>
-              <a:t>1 最初</a:t>
+              <a:t>1 最初（疲れる前）</a:t>
             </a:r>
           </a:p>
           <a:p>
@@ -6042,14 +5839,14 @@
       </p:sp>
       <p:cxnSp>
         <p:nvCxnSpPr>
-          <p:cNvPr id="9" name="Connector 8"/>
+          <p:cNvPr id="6" name="Connector 5"/>
           <p:cNvCxnSpPr/>
           <p:nvPr/>
         </p:nvCxnSpPr>
         <p:spPr>
           <a:xfrm>
-            <a:off x="2333625" y="3476625"/>
-            <a:ext cx="271463" cy="0"/>
+            <a:off x="2952750" y="1714500"/>
+            <a:ext cx="381000" cy="0"/>
           </a:xfrm>
           <a:prstGeom prst="line">
             <a:avLst/>
@@ -6064,18 +5861,18 @@
       </p:cxnSp>
       <p:sp>
         <p:nvSpPr>
-          <p:cNvPr id="10" name="Rounded Rectangle 9"/>
+          <p:cNvPr id="7" name="Rounded Rectangle 6"/>
           <p:cNvSpPr/>
           <p:nvPr/>
         </p:nvSpPr>
         <p:spPr>
           <a:xfrm>
-            <a:off x="2624138" y="3095625"/>
-            <a:ext cx="1762125" cy="762000"/>
+            <a:off x="3352800" y="1357312"/>
+            <a:ext cx="2381250" cy="714375"/>
           </a:xfrm>
           <a:prstGeom prst="roundRect">
             <a:avLst>
-              <a:gd name="adj" fmla="val 7500"/>
+              <a:gd name="adj" fmla="val 8000"/>
             </a:avLst>
           </a:prstGeom>
           <a:solidFill>
@@ -6126,7 +5923,7 @@
                 <a:ea typeface="Meiryo"/>
                 <a:cs typeface="Meiryo"/>
               </a:rPr>
-              <a:t>2</a:t>
+              <a:t>2 伸展（決定）</a:t>
             </a:r>
           </a:p>
           <a:p>
@@ -6150,22 +5947,21 @@
                 <a:ea typeface="Meiryo"/>
                 <a:cs typeface="Meiryo"/>
               </a:rPr>
-              <a:t>B・H
-2 回ずつ</a:t>
+              <a:t>上から押さえてもらう</a:t>
             </a:r>
           </a:p>
         </p:txBody>
       </p:sp>
       <p:cxnSp>
         <p:nvCxnSpPr>
-          <p:cNvPr id="11" name="Connector 10"/>
+          <p:cNvPr id="8" name="Connector 7"/>
           <p:cNvCxnSpPr/>
           <p:nvPr/>
         </p:nvCxnSpPr>
         <p:spPr>
           <a:xfrm>
-            <a:off x="4405312" y="3476625"/>
-            <a:ext cx="271463" cy="0"/>
+            <a:off x="5753100" y="1714500"/>
+            <a:ext cx="381000" cy="0"/>
           </a:xfrm>
           <a:prstGeom prst="line">
             <a:avLst/>
@@ -6180,18 +5976,18 @@
       </p:cxnSp>
       <p:sp>
         <p:nvSpPr>
-          <p:cNvPr id="12" name="Rounded Rectangle 11"/>
+          <p:cNvPr id="9" name="Rounded Rectangle 8"/>
           <p:cNvSpPr/>
           <p:nvPr/>
         </p:nvSpPr>
         <p:spPr>
           <a:xfrm>
-            <a:off x="4695825" y="3095625"/>
-            <a:ext cx="1762125" cy="762000"/>
+            <a:off x="6153150" y="1357312"/>
+            <a:ext cx="2381250" cy="714375"/>
           </a:xfrm>
           <a:prstGeom prst="roundRect">
             <a:avLst>
-              <a:gd name="adj" fmla="val 7500"/>
+              <a:gd name="adj" fmla="val 8000"/>
             </a:avLst>
           </a:prstGeom>
           <a:solidFill>
@@ -6242,7 +6038,7 @@
                 <a:ea typeface="Meiryo"/>
                 <a:cs typeface="Meiryo"/>
               </a:rPr>
-              <a:t>3</a:t>
+              <a:t>3 屈曲（次回確かめる）</a:t>
             </a:r>
           </a:p>
           <a:p>
@@ -6266,47 +6062,72 @@
                 <a:ea typeface="Meiryo"/>
                 <a:cs typeface="Meiryo"/>
               </a:rPr>
-              <a:t>屈曲</a:t>
-            </a:r>
-          </a:p>
-        </p:txBody>
-      </p:sp>
-      <p:cxnSp>
-        <p:nvCxnSpPr>
-          <p:cNvPr id="13" name="Connector 12"/>
-          <p:cNvCxnSpPr/>
-          <p:nvPr/>
-        </p:nvCxnSpPr>
-        <p:spPr>
-          <a:xfrm>
-            <a:off x="6477000" y="3476625"/>
-            <a:ext cx="271462" cy="0"/>
-          </a:xfrm>
-          <a:prstGeom prst="line">
-            <a:avLst/>
-          </a:prstGeom>
-          <a:ln w="19050">
-            <a:solidFill>
-              <a:srgbClr val="6B6B6B"/>
-            </a:solidFill>
-            <a:tailEnd type="triangle" w="med" len="med"/>
-          </a:ln>
-        </p:spPr>
-      </p:cxnSp>
-      <p:sp>
-        <p:nvSpPr>
-          <p:cNvPr id="14" name="Rounded Rectangle 13"/>
+              <a:t>机に向かって押し下げる</a:t>
+            </a:r>
+          </a:p>
+        </p:txBody>
+      </p:sp>
+      <p:sp>
+        <p:nvSpPr>
+          <p:cNvPr id="10" name="TextBox 9"/>
+          <p:cNvSpPr txBox="1"/>
+          <p:nvPr/>
+        </p:nvSpPr>
+        <p:spPr>
+          <a:xfrm>
+            <a:off x="552450" y="2238375"/>
+            <a:ext cx="7981950" cy="190500"/>
+          </a:xfrm>
+          <a:prstGeom prst="rect">
+            <a:avLst/>
+          </a:prstGeom>
+          <a:noFill/>
+        </p:spPr>
+        <p:txBody>
+          <a:bodyPr wrap="square" tIns="0" rIns="0" bIns="0" lIns="0">
+            <a:spAutoFit/>
+          </a:bodyPr>
+          <a:lstStyle/>
+          <a:p>
+            <a:pPr algn="l">
+              <a:lnSpc>
+                <a:spcPct val="120000"/>
+              </a:lnSpc>
+              <a:spcBef>
+                <a:spcPts val="0"/>
+              </a:spcBef>
+              <a:spcAft>
+                <a:spcPts val="0"/>
+              </a:spcAft>
+            </a:pPr>
+            <a:r>
+              <a:rPr sz="1125" b="1">
+                <a:solidFill>
+                  <a:srgbClr val="1A1A1A"/>
+                </a:solidFill>
+                <a:latin typeface="Meiryo"/>
+                <a:ea typeface="Meiryo"/>
+                <a:cs typeface="Meiryo"/>
+              </a:rPr>
+              <a:t>あわせて始めること</a:t>
+            </a:r>
+          </a:p>
+        </p:txBody>
+      </p:sp>
+      <p:sp>
+        <p:nvSpPr>
+          <p:cNvPr id="11" name="Rounded Rectangle 10"/>
           <p:cNvSpPr/>
           <p:nvPr/>
         </p:nvSpPr>
         <p:spPr>
           <a:xfrm>
-            <a:off x="6767512" y="3095625"/>
-            <a:ext cx="1762125" cy="762000"/>
+            <a:off x="552450" y="2524125"/>
+            <a:ext cx="2381250" cy="1190625"/>
           </a:xfrm>
           <a:prstGeom prst="roundRect">
             <a:avLst>
-              <a:gd name="adj" fmla="val 7500"/>
+              <a:gd name="adj" fmla="val 4800"/>
             </a:avLst>
           </a:prstGeom>
           <a:solidFill>
@@ -6334,7 +6155,269 @@
           </a:fontRef>
         </p:style>
         <p:txBody>
-          <a:bodyPr rtlCol="0" anchor="ctr" wrap="square" tIns="114300" rIns="114300" bIns="114300" lIns="114300"/>
+          <a:bodyPr rtlCol="0" anchor="t" wrap="square" tIns="133350" rIns="133350" bIns="133350" lIns="133350"/>
+          <a:lstStyle/>
+          <a:p>
+            <a:pPr algn="l">
+              <a:lnSpc>
+                <a:spcPct val="130000"/>
+              </a:lnSpc>
+              <a:spcBef>
+                <a:spcPts val="0"/>
+              </a:spcBef>
+              <a:spcAft>
+                <a:spcPts val="525"/>
+              </a:spcAft>
+            </a:pPr>
+            <a:r>
+              <a:rPr sz="1275" b="1">
+                <a:solidFill>
+                  <a:srgbClr val="1A1A1A"/>
+                </a:solidFill>
+                <a:latin typeface="Meiryo"/>
+                <a:ea typeface="Meiryo"/>
+                <a:cs typeface="Meiryo"/>
+              </a:rPr>
+              <a:t>再現性を高める
+方法を考える</a:t>
+            </a:r>
+          </a:p>
+          <a:p>
+            <a:pPr algn="l">
+              <a:lnSpc>
+                <a:spcPct val="130000"/>
+              </a:lnSpc>
+              <a:spcBef>
+                <a:spcPts val="0"/>
+              </a:spcBef>
+              <a:spcAft>
+                <a:spcPts val="0"/>
+              </a:spcAft>
+            </a:pPr>
+            <a:r>
+              <a:rPr sz="900" b="0">
+                <a:solidFill>
+                  <a:srgbClr val="4A4A4A"/>
+                </a:solidFill>
+                <a:latin typeface="Meiryo"/>
+                <a:ea typeface="Meiryo"/>
+                <a:cs typeface="Meiryo"/>
+              </a:rPr>
+              <a:t>同じやり方でも
+日によって 350% と 96%</a:t>
+            </a:r>
+          </a:p>
+        </p:txBody>
+      </p:sp>
+      <p:sp>
+        <p:nvSpPr>
+          <p:cNvPr id="12" name="Rounded Rectangle 11"/>
+          <p:cNvSpPr/>
+          <p:nvPr/>
+        </p:nvSpPr>
+        <p:spPr>
+          <a:xfrm>
+            <a:off x="3352800" y="2524125"/>
+            <a:ext cx="2381250" cy="1190625"/>
+          </a:xfrm>
+          <a:prstGeom prst="roundRect">
+            <a:avLst>
+              <a:gd name="adj" fmla="val 4800"/>
+            </a:avLst>
+          </a:prstGeom>
+          <a:solidFill>
+            <a:srgbClr val="F4F4F4"/>
+          </a:solidFill>
+          <a:ln w="9525">
+            <a:solidFill>
+              <a:srgbClr val="C8C8C8"/>
+            </a:solidFill>
+          </a:ln>
+          <a:effectLst/>
+        </p:spPr>
+        <p:style>
+          <a:lnRef idx="1">
+            <a:schemeClr val="accent1"/>
+          </a:lnRef>
+          <a:fillRef idx="3">
+            <a:schemeClr val="accent1"/>
+          </a:fillRef>
+          <a:effectRef idx="2">
+            <a:schemeClr val="accent1"/>
+          </a:effectRef>
+          <a:fontRef idx="minor">
+            <a:schemeClr val="lt1"/>
+          </a:fontRef>
+        </p:style>
+        <p:txBody>
+          <a:bodyPr rtlCol="0" anchor="t" wrap="square" tIns="133350" rIns="133350" bIns="133350" lIns="133350"/>
+          <a:lstStyle/>
+          <a:p>
+            <a:pPr algn="l">
+              <a:lnSpc>
+                <a:spcPct val="130000"/>
+              </a:lnSpc>
+              <a:spcBef>
+                <a:spcPts val="0"/>
+              </a:spcBef>
+              <a:spcAft>
+                <a:spcPts val="525"/>
+              </a:spcAft>
+            </a:pPr>
+            <a:r>
+              <a:rPr sz="1275" b="1">
+                <a:solidFill>
+                  <a:srgbClr val="1A1A1A"/>
+                </a:solidFill>
+                <a:latin typeface="Meiryo"/>
+                <a:ea typeface="Meiryo"/>
+                <a:cs typeface="Meiryo"/>
+              </a:rPr>
+              <a:t>ほかの箇所の
+MVC を始める</a:t>
+            </a:r>
+          </a:p>
+          <a:p>
+            <a:pPr algn="l">
+              <a:lnSpc>
+                <a:spcPct val="130000"/>
+              </a:lnSpc>
+              <a:spcBef>
+                <a:spcPts val="0"/>
+              </a:spcBef>
+              <a:spcAft>
+                <a:spcPts val="0"/>
+              </a:spcAft>
+            </a:pPr>
+            <a:r>
+              <a:rPr sz="900" b="0">
+                <a:solidFill>
+                  <a:srgbClr val="4A4A4A"/>
+                </a:solidFill>
+                <a:latin typeface="Meiryo"/>
+                <a:ea typeface="Meiryo"/>
+                <a:cs typeface="Meiryo"/>
+              </a:rPr>
+              <a:t>肩・上腕・僧帽筋
+時間がかかりそう</a:t>
+            </a:r>
+          </a:p>
+        </p:txBody>
+      </p:sp>
+      <p:sp>
+        <p:nvSpPr>
+          <p:cNvPr id="13" name="Rounded Rectangle 12"/>
+          <p:cNvSpPr/>
+          <p:nvPr/>
+        </p:nvSpPr>
+        <p:spPr>
+          <a:xfrm>
+            <a:off x="6153150" y="2524125"/>
+            <a:ext cx="2381250" cy="1190625"/>
+          </a:xfrm>
+          <a:prstGeom prst="roundRect">
+            <a:avLst>
+              <a:gd name="adj" fmla="val 4800"/>
+            </a:avLst>
+          </a:prstGeom>
+          <a:solidFill>
+            <a:srgbClr val="F4F4F4"/>
+          </a:solidFill>
+          <a:ln w="9525">
+            <a:solidFill>
+              <a:srgbClr val="C8C8C8"/>
+            </a:solidFill>
+          </a:ln>
+          <a:effectLst/>
+        </p:spPr>
+        <p:style>
+          <a:lnRef idx="1">
+            <a:schemeClr val="accent1"/>
+          </a:lnRef>
+          <a:fillRef idx="3">
+            <a:schemeClr val="accent1"/>
+          </a:fillRef>
+          <a:effectRef idx="2">
+            <a:schemeClr val="accent1"/>
+          </a:effectRef>
+          <a:fontRef idx="minor">
+            <a:schemeClr val="lt1"/>
+          </a:fontRef>
+        </p:style>
+        <p:txBody>
+          <a:bodyPr rtlCol="0" anchor="t" wrap="square" tIns="133350" rIns="133350" bIns="133350" lIns="133350"/>
+          <a:lstStyle/>
+          <a:p>
+            <a:pPr algn="l">
+              <a:lnSpc>
+                <a:spcPct val="130000"/>
+              </a:lnSpc>
+              <a:spcBef>
+                <a:spcPts val="0"/>
+              </a:spcBef>
+              <a:spcAft>
+                <a:spcPts val="525"/>
+              </a:spcAft>
+            </a:pPr>
+            <a:r>
+              <a:rPr sz="1275" b="1">
+                <a:solidFill>
+                  <a:srgbClr val="1A1A1A"/>
+                </a:solidFill>
+                <a:latin typeface="Meiryo"/>
+                <a:ea typeface="Meiryo"/>
+                <a:cs typeface="Meiryo"/>
+              </a:rPr>
+              <a:t>API へ移行する</a:t>
+            </a:r>
+          </a:p>
+          <a:p>
+            <a:pPr algn="l">
+              <a:lnSpc>
+                <a:spcPct val="130000"/>
+              </a:lnSpc>
+              <a:spcBef>
+                <a:spcPts val="0"/>
+              </a:spcBef>
+              <a:spcAft>
+                <a:spcPts val="0"/>
+              </a:spcAft>
+            </a:pPr>
+            <a:r>
+              <a:rPr sz="900" b="0">
+                <a:solidFill>
+                  <a:srgbClr val="4A4A4A"/>
+                </a:solidFill>
+                <a:latin typeface="Meiryo"/>
+                <a:ea typeface="Meiryo"/>
+                <a:cs typeface="Meiryo"/>
+              </a:rPr>
+              <a:t>キーが届いた
+CSV で取るやり方から切り替え</a:t>
+            </a:r>
+          </a:p>
+        </p:txBody>
+      </p:sp>
+      <p:sp>
+        <p:nvSpPr>
+          <p:cNvPr id="14" name="TextBox 13"/>
+          <p:cNvSpPr txBox="1"/>
+          <p:nvPr/>
+        </p:nvSpPr>
+        <p:spPr>
+          <a:xfrm>
+            <a:off x="552450" y="3905250"/>
+            <a:ext cx="7981950" cy="238125"/>
+          </a:xfrm>
+          <a:prstGeom prst="rect">
+            <a:avLst/>
+          </a:prstGeom>
+          <a:noFill/>
+        </p:spPr>
+        <p:txBody>
+          <a:bodyPr wrap="square" tIns="0" rIns="0" bIns="0" lIns="0">
+            <a:spAutoFit/>
+          </a:bodyPr>
           <a:lstStyle/>
           <a:p>
             <a:pPr algn="l">
@@ -6345,83 +6428,11 @@
                 <a:spcPts val="0"/>
               </a:spcBef>
               <a:spcAft>
-                <a:spcPts val="300"/>
-              </a:spcAft>
-            </a:pPr>
-            <a:r>
-              <a:rPr sz="975" b="1">
-                <a:solidFill>
-                  <a:srgbClr val="6B6B6B"/>
-                </a:solidFill>
-                <a:latin typeface="Meiryo"/>
-                <a:ea typeface="Meiryo"/>
-                <a:cs typeface="Meiryo"/>
-              </a:rPr>
-              <a:t>4 最後</a:t>
-            </a:r>
-          </a:p>
-          <a:p>
-            <a:pPr algn="l">
-              <a:lnSpc>
-                <a:spcPct val="130000"/>
-              </a:lnSpc>
-              <a:spcBef>
-                <a:spcPts val="0"/>
-              </a:spcBef>
-              <a:spcAft>
-                <a:spcPts val="0"/>
-              </a:spcAft>
-            </a:pPr>
-            <a:r>
-              <a:rPr sz="1200" b="1">
-                <a:solidFill>
-                  <a:srgbClr val="1A1A1A"/>
-                </a:solidFill>
-                <a:latin typeface="Meiryo"/>
-                <a:ea typeface="Meiryo"/>
-                <a:cs typeface="Meiryo"/>
-              </a:rPr>
-              <a:t>確認動作
-＋ B</a:t>
-            </a:r>
-          </a:p>
-        </p:txBody>
-      </p:sp>
-      <p:sp>
-        <p:nvSpPr>
-          <p:cNvPr id="15" name="TextBox 14"/>
-          <p:cNvSpPr txBox="1"/>
-          <p:nvPr/>
-        </p:nvSpPr>
-        <p:spPr>
-          <a:xfrm>
-            <a:off x="552450" y="4048125"/>
-            <a:ext cx="7981950" cy="238125"/>
-          </a:xfrm>
-          <a:prstGeom prst="rect">
-            <a:avLst/>
-          </a:prstGeom>
-          <a:noFill/>
-        </p:spPr>
-        <p:txBody>
-          <a:bodyPr wrap="square" tIns="0" rIns="0" bIns="0" lIns="0">
-            <a:spAutoFit/>
-          </a:bodyPr>
-          <a:lstStyle/>
-          <a:p>
-            <a:pPr algn="l">
-              <a:lnSpc>
-                <a:spcPct val="120000"/>
-              </a:lnSpc>
-              <a:spcBef>
-                <a:spcPts val="0"/>
-              </a:spcBef>
-              <a:spcAft>
-                <a:spcPts val="0"/>
-              </a:spcAft>
-            </a:pPr>
-            <a:r>
-              <a:rPr sz="1125" b="0">
+                <a:spcPts val="0"/>
+              </a:spcAft>
+            </a:pPr>
+            <a:r>
+              <a:rPr sz="1050" b="0">
                 <a:solidFill>
                   <a:srgbClr val="6B6B6B"/>
                 </a:solidFill>
@@ -6866,6 +6877,30 @@
               <a:t>・6 か所は、MVC を確かめてから</a:t>
             </a:r>
           </a:p>
+          <a:p>
+            <a:pPr algn="l">
+              <a:lnSpc>
+                <a:spcPct val="130000"/>
+              </a:lnSpc>
+              <a:spcBef>
+                <a:spcPts val="0"/>
+              </a:spcBef>
+              <a:spcAft>
+                <a:spcPts val="375"/>
+              </a:spcAft>
+            </a:pPr>
+            <a:r>
+              <a:rPr sz="1350" b="1">
+                <a:solidFill>
+                  <a:srgbClr val="1A1A1A"/>
+                </a:solidFill>
+                <a:latin typeface="Meiryo"/>
+                <a:ea typeface="Meiryo"/>
+                <a:cs typeface="Meiryo"/>
+              </a:rPr>
+              <a:t>・API のキーが届いた</a:t>
+            </a:r>
+          </a:p>
         </p:txBody>
       </p:sp>
       <p:sp>
@@ -7069,7 +7104,7 @@
                 <a:ea typeface="Meiryo"/>
                 <a:cs typeface="Meiryo"/>
               </a:rPr>
-              <a:t>来週：MVC を確かめて、6 か所で本番データを取る</a:t>
+              <a:t>来週：前腕の MVC を確かめ、ほかの箇所と API への移行を始める</a:t>
             </a:r>
           </a:p>
         </p:txBody>

</xml_diff>